<commit_message>
feat(slides): add Codex entry and migrate to 81 slides
Explain the documented desktop entry path and human decision ownership.
Align slide numbering, notes and current planning references while
preserving the six-hour schedule and historical evidence.
</commit_message>
<xml_diff>
--- a/production/ACT_1.pptx
+++ b/production/ACT_1.pptx
@@ -2,24 +2,24 @@
 <file path=ppt/presentation.xml><?xml version="1.0" encoding="utf-8"?>
 <p:presentation xmlns:p="http://schemas.openxmlformats.org/presentationml/2006/main">
   <p:sldMasterIdLst>
-    <p:sldMasterId xmlns:r="http://schemas.openxmlformats.org/officeDocument/2006/relationships" id="2147483648" r:id="R7737013f695b4951"/>
+    <p:sldMasterId xmlns:r="http://schemas.openxmlformats.org/officeDocument/2006/relationships" id="2147483648" r:id="R662cf0d54cde4161"/>
   </p:sldMasterIdLst>
   <p:notesMasterIdLst>
-    <p:notesMasterId xmlns:r="http://schemas.openxmlformats.org/officeDocument/2006/relationships" r:id="R9aef974c2b354d1c"/>
+    <p:notesMasterId xmlns:r="http://schemas.openxmlformats.org/officeDocument/2006/relationships" r:id="R9efdb8e3a29242ea"/>
   </p:notesMasterIdLst>
   <p:sldIdLst>
-    <p:sldId xmlns:r="http://schemas.openxmlformats.org/officeDocument/2006/relationships" id="256" r:id="R0bf48aee52ae4021"/>
-    <p:sldId xmlns:r="http://schemas.openxmlformats.org/officeDocument/2006/relationships" id="257" r:id="R5609845514cb45ee"/>
-    <p:sldId xmlns:r="http://schemas.openxmlformats.org/officeDocument/2006/relationships" id="258" r:id="R63db848948104ff1"/>
-    <p:sldId xmlns:r="http://schemas.openxmlformats.org/officeDocument/2006/relationships" id="259" r:id="Rdb9b046f6df74fdf"/>
-    <p:sldId xmlns:r="http://schemas.openxmlformats.org/officeDocument/2006/relationships" id="260" r:id="R417c43f65c77490c"/>
-    <p:sldId xmlns:r="http://schemas.openxmlformats.org/officeDocument/2006/relationships" id="261" r:id="R5dade3af2dbf48af"/>
-    <p:sldId xmlns:r="http://schemas.openxmlformats.org/officeDocument/2006/relationships" id="262" r:id="Rc682847f0de24fee"/>
-    <p:sldId xmlns:r="http://schemas.openxmlformats.org/officeDocument/2006/relationships" id="263" r:id="R1e4deb35181646c9"/>
-    <p:sldId xmlns:r="http://schemas.openxmlformats.org/officeDocument/2006/relationships" id="264" r:id="R0fd410c58e8a4325"/>
-    <p:sldId xmlns:r="http://schemas.openxmlformats.org/officeDocument/2006/relationships" id="265" r:id="R090634e0b2ba4651"/>
-    <p:sldId xmlns:r="http://schemas.openxmlformats.org/officeDocument/2006/relationships" id="266" r:id="R9153f474e3c742f3"/>
-    <p:sldId xmlns:r="http://schemas.openxmlformats.org/officeDocument/2006/relationships" id="267" r:id="R0f7714e8b9d44c92"/>
+    <p:sldId xmlns:r="http://schemas.openxmlformats.org/officeDocument/2006/relationships" id="256" r:id="R8b71143fc8654c3c"/>
+    <p:sldId xmlns:r="http://schemas.openxmlformats.org/officeDocument/2006/relationships" id="257" r:id="R9f0a44909c2b4d19"/>
+    <p:sldId xmlns:r="http://schemas.openxmlformats.org/officeDocument/2006/relationships" id="258" r:id="R70836fc7df884978"/>
+    <p:sldId xmlns:r="http://schemas.openxmlformats.org/officeDocument/2006/relationships" id="259" r:id="R3072f5e26a41456b"/>
+    <p:sldId xmlns:r="http://schemas.openxmlformats.org/officeDocument/2006/relationships" id="260" r:id="R7c2400b163054078"/>
+    <p:sldId xmlns:r="http://schemas.openxmlformats.org/officeDocument/2006/relationships" id="261" r:id="Reaf549110e2b465f"/>
+    <p:sldId xmlns:r="http://schemas.openxmlformats.org/officeDocument/2006/relationships" id="262" r:id="R8ac01866e8234f52"/>
+    <p:sldId xmlns:r="http://schemas.openxmlformats.org/officeDocument/2006/relationships" id="263" r:id="R36fa30aaa83f42e5"/>
+    <p:sldId xmlns:r="http://schemas.openxmlformats.org/officeDocument/2006/relationships" id="264" r:id="R94455afe1b6a4c85"/>
+    <p:sldId xmlns:r="http://schemas.openxmlformats.org/officeDocument/2006/relationships" id="265" r:id="R6f8cf58b8a7d4b21"/>
+    <p:sldId xmlns:r="http://schemas.openxmlformats.org/officeDocument/2006/relationships" id="266" r:id="R024fd4c8a4414e14"/>
+    <p:sldId xmlns:r="http://schemas.openxmlformats.org/officeDocument/2006/relationships" id="267" r:id="R995e59ac6793467f"/>
   </p:sldIdLst>
   <p:sldSz cx="12192000" cy="6858000"/>
   <p:notesSz cx="6858000" cy="9144000"/>
@@ -453,7 +453,7 @@
           <a:lstStyle xmlns:a="http://schemas.openxmlformats.org/drawingml/2006/main"/>
           <a:p xmlns:a="http://schemas.openxmlformats.org/drawingml/2006/main">
             <a:r>
-              <a:t>## S10 — Task에는 무엇이 아직 정해지지 않았을까?</a:t>
+              <a:t>## S11 — Task에는 무엇이 아직 정해지지 않았을까?</a:t>
             </a:r>
           </a:p>
           <a:p xmlns:a="http://schemas.openxmlformats.org/drawingml/2006/main">
@@ -463,7 +463,7 @@
           </a:p>
           <a:p xmlns:a="http://schemas.openxmlformats.org/drawingml/2006/main">
             <a:r>
-              <a:t>Slide ID: S10</a:t>
+              <a:t>Slide ID: S11</a:t>
             </a:r>
           </a:p>
           <a:p xmlns:a="http://schemas.openxmlformats.org/drawingml/2006/main">
@@ -543,7 +543,7 @@
           </a:p>
           <a:p xmlns:a="http://schemas.openxmlformats.org/drawingml/2006/main">
             <a:r>
-              <a:t>1. (0:00–2:00) S09의 열린 질문을 회수하고 “같은 Repository를 보고 있다”는 조건을 고정한다.</a:t>
+              <a:t>1. (0:00–2:00) S10의 열린 질문을 회수하고 “같은 Repository를 보고 있다”는 조건을 고정한다.</a:t>
             </a:r>
           </a:p>
           <a:p xmlns:a="http://schemas.openxmlformats.org/drawingml/2006/main">
@@ -553,7 +553,7 @@
           </a:p>
           <a:p xmlns:a="http://schemas.openxmlformats.org/drawingml/2006/main">
             <a:r>
-              <a:t>3. (5:00–7:00) Repository 접근만으로 남은 결정을 정할 수 있는지 질문한다. 남은 결정을 더 구체적으로 보기 위해 앞서 조사한 crop 사례로 좁히겠다고 S11을 예고한다. 실제 제품 실패 사례나 관찰 결과로 말하지 않는다.</a:t>
+              <a:t>3. (5:00–7:00) Repository 접근만으로 남은 결정을 정할 수 있는지 질문한다. 남은 결정을 더 구체적으로 보기 위해 앞서 조사한 crop 사례로 좁히겠다고 S12을 예고한다. 실제 제품 실패 사례나 관찰 결과로 말하지 않는다.</a:t>
             </a:r>
           </a:p>
           <a:p xmlns:a="http://schemas.openxmlformats.org/drawingml/2006/main">
@@ -643,7 +643,7 @@
           </a:p>
           <a:p xmlns:a="http://schemas.openxmlformats.org/drawingml/2006/main">
             <a:r>
-              <a:t>Transition: “남은 결정을 더 분명히 보기 위해, 앞서 조사한 crop 사례로 좁혀 보겠습니다.”라고 S11의 교육용 요청 예시로 이동한다.</a:t>
+              <a:t>Transition: “남은 결정을 더 분명히 보기 위해, 앞서 조사한 crop 사례로 좁혀 보겠습니다.”라고 S12의 교육용 요청 예시로 이동한다.</a:t>
             </a:r>
           </a:p>
           <a:p xmlns:a="http://schemas.openxmlformats.org/drawingml/2006/main">
@@ -663,7 +663,7 @@
           </a:p>
           <a:p xmlns:a="http://schemas.openxmlformats.org/drawingml/2006/main">
             <a:r>
-              <a:t>Fallback: 정적 기본 경로 — 정적 슬라이드 `production/ACT_1.pptx` S10 또는 `production/preview/act1/S10.png` 사용. 응답이 없어도 7분 후 S11로 이동한다. 새 제작본의 렌더·경로 대조는 통합 단계에서 수행한다.</a:t>
+              <a:t>Fallback: 정적 기본 경로 — 정적 슬라이드 `production/ACT_1.pptx` S11 또는 `production/preview/act1/S11.png` 사용. 응답이 없어도 7분 후 S12로 이동한다. 새 제작본의 렌더·경로 대조는 통합 단계에서 수행한다.</a:t>
             </a:r>
           </a:p>
           <a:p xmlns:a="http://schemas.openxmlformats.org/drawingml/2006/main">
@@ -743,7 +743,7 @@
           <a:lstStyle xmlns:a="http://schemas.openxmlformats.org/drawingml/2006/main"/>
           <a:p xmlns:a="http://schemas.openxmlformats.org/drawingml/2006/main">
             <a:r>
-              <a:t>## S19 — Check마다 확인하는 범위</a:t>
+              <a:t>## S20 — Check마다 확인하는 범위</a:t>
             </a:r>
           </a:p>
           <a:p xmlns:a="http://schemas.openxmlformats.org/drawingml/2006/main">
@@ -753,7 +753,7 @@
           </a:p>
           <a:p xmlns:a="http://schemas.openxmlformats.org/drawingml/2006/main">
             <a:r>
-              <a:t>Slide ID: S19</a:t>
+              <a:t>Slide ID: S20</a:t>
             </a:r>
           </a:p>
           <a:p xmlns:a="http://schemas.openxmlformats.org/drawingml/2006/main">
@@ -898,7 +898,7 @@
           </a:p>
           <a:p xmlns:a="http://schemas.openxmlformats.org/drawingml/2006/main">
             <a:r>
-              <a:t>C++ Vision Bridge: NOTES-ONLY 선택적 참고: `build claim → Release build`; `compatibility claim → API / ABI review`; `performance claim → benchmark with named workload`. 화면의 C++ inset은 계약 비교 예시로 대체했으며 이 대응을 추가 강의하지 않는다. 주요 C++ 패턴 전이는 S53에 유지한다. No Windows, shell, IDE, or hardware setup is asserted.</a:t>
+              <a:t>C++ Vision Bridge: NOTES-ONLY 선택적 참고: `build claim → Release build`; `compatibility claim → API / ABI review`; `performance claim → benchmark with named workload`. 화면의 C++ inset은 계약 비교 예시로 대체했으며 이 대응을 추가 강의하지 않는다. 주요 C++ 패턴 전이는 S54에 유지한다. No Windows, shell, IDE, or hardware setup is asserted.</a:t>
             </a:r>
           </a:p>
           <a:p xmlns:a="http://schemas.openxmlformats.org/drawingml/2006/main">
@@ -928,7 +928,7 @@
           </a:p>
           <a:p xmlns:a="http://schemas.openxmlformats.org/drawingml/2006/main">
             <a:r>
-              <a:t>Transition: “방금 정한 테스트 명령과 보존 조건은 다음 작업에도 필요할 수 있습니다. 이 설명을 매번 다시 적어야 할까요?”라고 검증 지침의 재사용에서 S20의 정보 수명 질문으로 연결한다.</a:t>
+              <a:t>Transition: “방금 정한 테스트 명령과 보존 조건은 다음 작업에도 필요할 수 있습니다. 이 설명을 매번 다시 적어야 할까요?”라고 검증 지침의 재사용에서 S21의 정보 수명 질문으로 연결한다.</a:t>
             </a:r>
           </a:p>
           <a:p xmlns:a="http://schemas.openxmlformats.org/drawingml/2006/main">
@@ -948,7 +948,7 @@
           </a:p>
           <a:p xmlns:a="http://schemas.openxmlformats.org/drawingml/2006/main">
             <a:r>
-              <a:t>Fallback: 정적 PPTX S19 또는 `production/preview/act1/S19.png`를 사용한다. 표의 일반적인 범위와 하단 Trial 출처를 구분한다. 새 렌더 검토는 통합 단계에서 수행한다.</a:t>
+              <a:t>Fallback: 정적 PPTX S20 또는 `production/preview/act1/S20.png`를 사용한다. 표의 일반적인 범위와 하단 Trial 출처를 구분한다. 새 렌더 검토는 통합 단계에서 수행한다.</a:t>
             </a:r>
           </a:p>
           <a:p xmlns:a="http://schemas.openxmlformats.org/drawingml/2006/main">
@@ -1028,7 +1028,7 @@
           <a:lstStyle xmlns:a="http://schemas.openxmlformats.org/drawingml/2006/main"/>
           <a:p xmlns:a="http://schemas.openxmlformats.org/drawingml/2006/main">
             <a:r>
-              <a:t>## S20 — 이번 Task인가, 계속 유지할 Project 정보인가?</a:t>
+              <a:t>## S21 — 이번 Task인가, 계속 유지할 Project 정보인가?</a:t>
             </a:r>
           </a:p>
           <a:p xmlns:a="http://schemas.openxmlformats.org/drawingml/2006/main">
@@ -1038,7 +1038,7 @@
           </a:p>
           <a:p xmlns:a="http://schemas.openxmlformats.org/drawingml/2006/main">
             <a:r>
-              <a:t>Slide ID: S20</a:t>
+              <a:t>Slide ID: S21</a:t>
             </a:r>
           </a:p>
           <a:p xmlns:a="http://schemas.openxmlformats.org/drawingml/2006/main">
@@ -1118,7 +1118,7 @@
           </a:p>
           <a:p xmlns:a="http://schemas.openxmlformats.org/drawingml/2006/main">
             <a:r>
-              <a:t>1. (0:00–1:00) S19에서 검증 방법을 골랐다는 점을 회수하고, 테스트·보존 조건처럼 최근 요청에 반복해서 썼던 문장 하나를 떠올리게 한다. “이번 작업에만?”과 “다음 작업에도?” 중 어디에 해당할지 개인적으로 생각한다. 화면의 두 영역은 비워 두고 문장의 분류를 대신 정하지 않는다.</a:t>
+              <a:t>1. (0:00–1:00) S20에서 검증 방법을 골랐다는 점을 회수하고, 테스트·보존 조건처럼 최근 요청에 반복해서 썼던 문장 하나를 떠올리게 한다. “이번 작업에만?”과 “다음 작업에도?” 중 어디에 해당할지 개인적으로 생각한다. 화면의 두 영역은 비워 두고 문장의 분류를 대신 정하지 않는다.</a:t>
             </a:r>
           </a:p>
           <a:p xmlns:a="http://schemas.openxmlformats.org/drawingml/2006/main">
@@ -1128,7 +1128,7 @@
           </a:p>
           <a:p xmlns:a="http://schemas.openxmlformats.org/drawingml/2006/main">
             <a:r>
-              <a:t>3. (3:00) S21에서 후보 예시를 함께 확인하겠다고 전환한다.</a:t>
+              <a:t>3. (3:00) S22에서 후보 예시를 함께 확인하겠다고 전환한다.</a:t>
             </a:r>
           </a:p>
           <a:p xmlns:a="http://schemas.openxmlformats.org/drawingml/2006/main">
@@ -1208,7 +1208,7 @@
           </a:p>
           <a:p xmlns:a="http://schemas.openxmlformats.org/drawingml/2006/main">
             <a:r>
-              <a:t>Transition: Slide 21에서 Reflection/Discussion을 회수하고 “왜 Project 설명을 매번 다시 쓰는가?”라는 ACT 2 질문으로 넘긴다.</a:t>
+              <a:t>Transition: Slide 22에서 Reflection/Discussion을 회수하고 “왜 Project 설명을 매번 다시 쓰는가?”라는 ACT 2 질문으로 넘긴다.</a:t>
             </a:r>
           </a:p>
           <a:p xmlns:a="http://schemas.openxmlformats.org/drawingml/2006/main">
@@ -1228,7 +1228,7 @@
           </a:p>
           <a:p xmlns:a="http://schemas.openxmlformats.org/drawingml/2006/main">
             <a:r>
-              <a:t>Fallback: 정적 기본 경로 — 정적 질문 슬라이드 `production/ACT_1.pptx` S20 또는 `production/preview/act1/S20.png` 사용. 공유 응답이 없어도 다음으로 진행한다. 새 제작본의 렌더·경로 대조는 통합 단계에서 수행한다.</a:t>
+              <a:t>Fallback: 정적 기본 경로 — 정적 질문 슬라이드 `production/ACT_1.pptx` S21 또는 `production/preview/act1/S21.png` 사용. 공유 응답이 없어도 다음으로 진행한다. 새 제작본의 렌더·경로 대조는 통합 단계에서 수행한다.</a:t>
             </a:r>
           </a:p>
           <a:p xmlns:a="http://schemas.openxmlformats.org/drawingml/2006/main">
@@ -1308,7 +1308,7 @@
           <a:lstStyle xmlns:a="http://schemas.openxmlformats.org/drawingml/2006/main"/>
           <a:p xmlns:a="http://schemas.openxmlformats.org/drawingml/2006/main">
             <a:r>
-              <a:t>## S21 — 반복하는 설명을 두 범주로 나누기</a:t>
+              <a:t>## S22 — 반복하는 설명을 두 범주로 나누기</a:t>
             </a:r>
           </a:p>
           <a:p xmlns:a="http://schemas.openxmlformats.org/drawingml/2006/main">
@@ -1318,7 +1318,7 @@
           </a:p>
           <a:p xmlns:a="http://schemas.openxmlformats.org/drawingml/2006/main">
             <a:r>
-              <a:t>Slide ID: S21</a:t>
+              <a:t>Slide ID: S22</a:t>
             </a:r>
           </a:p>
           <a:p xmlns:a="http://schemas.openxmlformats.org/drawingml/2006/main">
@@ -1398,7 +1398,7 @@
           </a:p>
           <a:p xmlns:a="http://schemas.openxmlformats.org/drawingml/2006/main">
             <a:r>
-              <a:t>1. (0:00–1:00, Reflection) S20의 두 질문을 회수하고 화면의 후보가 자신의 작업에서도 같은 수명·범위인지 조용히 생각하게 한다.</a:t>
+              <a:t>1. (0:00–1:00, Reflection) S21의 두 질문을 회수하고 화면의 후보가 자신의 작업에서도 같은 수명·범위인지 조용히 생각하게 한다.</a:t>
             </a:r>
           </a:p>
           <a:p xmlns:a="http://schemas.openxmlformats.org/drawingml/2006/main">
@@ -1423,7 +1423,7 @@
           </a:p>
           <a:p xmlns:a="http://schemas.openxmlformats.org/drawingml/2006/main">
             <a:r>
-              <a:t>화면 진행: 이 장의 두 열은 다음 ACT로 넘길 분류 후보다. 이번 목표와 여러 작업에 남길 사실의 수명이 다르다는 질문만 남긴다. 아직 S24 관찰 결과를 근거처럼 회수하지 않는다.</a:t>
+              <a:t>화면 진행: 이 장의 두 열은 다음 ACT로 넘길 분류 후보다. 이번 목표와 여러 작업에 남길 사실의 수명이 다르다는 질문만 남긴다. 아직 S25 관찰 결과를 근거처럼 회수하지 않는다.</a:t>
             </a:r>
           </a:p>
           <a:p xmlns:a="http://schemas.openxmlformats.org/drawingml/2006/main">
@@ -1523,7 +1523,7 @@
           </a:p>
           <a:p xmlns:a="http://schemas.openxmlformats.org/drawingml/2006/main">
             <a:r>
-              <a:t>Fallback: 정적 기본 경로 — 정적 비교 슬라이드 `production/ACT_1.pptx` S21 또는 `production/preview/act1/S21.png` 사용. Q&amp;A가 없어도 마지막 Transition 질문 후 ACT 2로 간다. 새 제작본의 렌더·경로 대조는 통합 단계에서 수행한다.</a:t>
+              <a:t>Fallback: 정적 기본 경로 — 정적 비교 슬라이드 `production/ACT_1.pptx` S22 또는 `production/preview/act1/S22.png` 사용. Q&amp;A가 없어도 마지막 Transition 질문 후 ACT 2로 간다. 새 제작본의 렌더·경로 대조는 통합 단계에서 수행한다.</a:t>
             </a:r>
           </a:p>
           <a:p xmlns:a="http://schemas.openxmlformats.org/drawingml/2006/main">
@@ -1603,7 +1603,7 @@
           <a:lstStyle xmlns:a="http://schemas.openxmlformats.org/drawingml/2006/main"/>
           <a:p xmlns:a="http://schemas.openxmlformats.org/drawingml/2006/main">
             <a:r>
-              <a:t>## S11 — 요청만으로는 의도가 보이지 않는다</a:t>
+              <a:t>## S12 — 요청만으로는 의도가 보이지 않는다</a:t>
             </a:r>
           </a:p>
           <a:p xmlns:a="http://schemas.openxmlformats.org/drawingml/2006/main">
@@ -1613,7 +1613,7 @@
           </a:p>
           <a:p xmlns:a="http://schemas.openxmlformats.org/drawingml/2006/main">
             <a:r>
-              <a:t>Slide ID: S11</a:t>
+              <a:t>Slide ID: S12</a:t>
             </a:r>
           </a:p>
           <a:p xmlns:a="http://schemas.openxmlformats.org/drawingml/2006/main">
@@ -1703,7 +1703,7 @@
           </a:p>
           <a:p xmlns:a="http://schemas.openxmlformats.org/drawingml/2006/main">
             <a:r>
-              <a:t>3. (3:00–4:00) 남은 결정들을 짚고, 다음 장에서는 이를 개발자가 답할 질문으로 바꿔 보겠다고 S12로 넘긴다. 특정 답은 제시하지 않는다.</a:t>
+              <a:t>3. (3:00–4:00) 남은 결정들을 짚고, 다음 장에서는 이를 개발자가 답할 질문으로 바꿔 보겠다고 S13로 넘긴다. 특정 답은 제시하지 않는다.</a:t>
             </a:r>
           </a:p>
           <a:p xmlns:a="http://schemas.openxmlformats.org/drawingml/2006/main">
@@ -1713,7 +1713,7 @@
           </a:p>
           <a:p xmlns:a="http://schemas.openxmlformats.org/drawingml/2006/main">
             <a:r>
-              <a:t>화면 진행: 이 장은 같은 요청의 두 해석에 집중한다. 왼쪽 테스트 변경과 오른쪽 구현 변경을 비교한 뒤, 아래 미정 정보를 짚는다. S10의 세 질문을 다시 강의하지 않는다.</a:t>
+              <a:t>화면 진행: 이 장은 같은 요청의 두 해석에 집중한다. 왼쪽 테스트 변경과 오른쪽 구현 변경을 비교한 뒤, 아래 미정 정보를 짚는다. S11의 세 질문을 다시 강의하지 않는다.</a:t>
             </a:r>
           </a:p>
           <a:p xmlns:a="http://schemas.openxmlformats.org/drawingml/2006/main">
@@ -1793,7 +1793,7 @@
           </a:p>
           <a:p xmlns:a="http://schemas.openxmlformats.org/drawingml/2006/main">
             <a:r>
-              <a:t>Transition: “Agent에게 남아 있던 결정을 개발자가 답할 질문으로 바꿔 보겠습니다.”라고 S12로 간다.</a:t>
+              <a:t>Transition: “Agent에게 남아 있던 결정을 개발자가 답할 질문으로 바꿔 보겠습니다.”라고 S13로 간다.</a:t>
             </a:r>
           </a:p>
           <a:p xmlns:a="http://schemas.openxmlformats.org/drawingml/2006/main">
@@ -1813,7 +1813,7 @@
           </a:p>
           <a:p xmlns:a="http://schemas.openxmlformats.org/drawingml/2006/main">
             <a:r>
-              <a:t>Fallback: 정적 기본 경로 — 정적 슬라이드 `production/ACT_1.pptx` S11 또는 `production/preview/act1/S11.png` 사용. 청중 응답 없이 진행한다. 새 제작본의 렌더·경로 대조는 통합 단계에서 수행한다.</a:t>
+              <a:t>Fallback: 정적 기본 경로 — 정적 슬라이드 `production/ACT_1.pptx` S12 또는 `production/preview/act1/S12.png` 사용. 청중 응답 없이 진행한다. 새 제작본의 렌더·경로 대조는 통합 단계에서 수행한다.</a:t>
             </a:r>
           </a:p>
           <a:p xmlns:a="http://schemas.openxmlformats.org/drawingml/2006/main">
@@ -1893,7 +1893,7 @@
           <a:lstStyle xmlns:a="http://schemas.openxmlformats.org/drawingml/2006/main"/>
           <a:p xmlns:a="http://schemas.openxmlformats.org/drawingml/2006/main">
             <a:r>
-              <a:t>## S12 — 개발자가 정해야 하는 경계</a:t>
+              <a:t>## S13 — 개발자가 정해야 하는 경계</a:t>
             </a:r>
           </a:p>
           <a:p xmlns:a="http://schemas.openxmlformats.org/drawingml/2006/main">
@@ -1903,7 +1903,7 @@
           </a:p>
           <a:p xmlns:a="http://schemas.openxmlformats.org/drawingml/2006/main">
             <a:r>
-              <a:t>Slide ID: S12</a:t>
+              <a:t>Slide ID: S13</a:t>
             </a:r>
           </a:p>
           <a:p xmlns:a="http://schemas.openxmlformats.org/drawingml/2006/main">
@@ -1983,7 +1983,7 @@
           </a:p>
           <a:p xmlns:a="http://schemas.openxmlformats.org/drawingml/2006/main">
             <a:r>
-              <a:t>1. (0:00–1:00) S11에서 남은 결정을 개발자의 질문으로 읽는다. “무엇을 바꿀까?”와 “무엇을 유지할까?”를 짚는다.</a:t>
+              <a:t>1. (0:00–1:00) S12에서 남은 결정을 개발자의 질문으로 읽는다. “무엇을 바꿀까?”와 “무엇을 유지할까?”를 짚는다.</a:t>
             </a:r>
           </a:p>
           <a:p xmlns:a="http://schemas.openxmlformats.org/drawingml/2006/main">
@@ -2083,7 +2083,7 @@
           </a:p>
           <a:p xmlns:a="http://schemas.openxmlformats.org/drawingml/2006/main">
             <a:r>
-              <a:t>Transition: “앞의 질문을 묶고, 필요한 사실과 작업 순서를 함께 명시하는 틀로 정리해 보겠습니다.”라고 S13의 Task Specification으로 이동한다.</a:t>
+              <a:t>Transition: “앞의 질문을 묶고, 필요한 사실과 작업 순서를 함께 명시하는 틀로 정리해 보겠습니다.”라고 S14의 Task Specification으로 이동한다.</a:t>
             </a:r>
           </a:p>
           <a:p xmlns:a="http://schemas.openxmlformats.org/drawingml/2006/main">
@@ -2103,7 +2103,7 @@
           </a:p>
           <a:p xmlns:a="http://schemas.openxmlformats.org/drawingml/2006/main">
             <a:r>
-              <a:t>Fallback: 정적 기본 경로 — 정적 슬라이드 `production/ACT_1.pptx` S12 또는 `production/preview/act1/S12.png` 사용. 침묵은 정상 진행으로 본다. 새 제작본의 렌더·경로 대조는 통합 단계에서 수행한다.</a:t>
+              <a:t>Fallback: 정적 기본 경로 — 정적 슬라이드 `production/ACT_1.pptx` S13 또는 `production/preview/act1/S13.png` 사용. 침묵은 정상 진행으로 본다. 새 제작본의 렌더·경로 대조는 통합 단계에서 수행한다.</a:t>
             </a:r>
           </a:p>
           <a:p xmlns:a="http://schemas.openxmlformats.org/drawingml/2006/main">
@@ -2183,7 +2183,7 @@
           <a:lstStyle xmlns:a="http://schemas.openxmlformats.org/drawingml/2006/main"/>
           <a:p xmlns:a="http://schemas.openxmlformats.org/drawingml/2006/main">
             <a:r>
-              <a:t>## S13 — Task Specification의 다섯 책임</a:t>
+              <a:t>## S14 — Task Specification의 다섯 책임</a:t>
             </a:r>
           </a:p>
           <a:p xmlns:a="http://schemas.openxmlformats.org/drawingml/2006/main">
@@ -2193,7 +2193,7 @@
           </a:p>
           <a:p xmlns:a="http://schemas.openxmlformats.org/drawingml/2006/main">
             <a:r>
-              <a:t>Slide ID: S13</a:t>
+              <a:t>Slide ID: S14</a:t>
             </a:r>
           </a:p>
           <a:p xmlns:a="http://schemas.openxmlformats.org/drawingml/2006/main">
@@ -2283,7 +2283,7 @@
           </a:p>
           <a:p xmlns:a="http://schemas.openxmlformats.org/drawingml/2006/main">
             <a:r>
-              <a:t>3. (3:15–4:00) 다섯 책임을 모두 길게 적으라는 뜻이 아니라 작업에 필요한 경계를 검토할 틀이라고 정리하고 S14로 간다.</a:t>
+              <a:t>3. (3:15–4:00) 다섯 책임을 모두 길게 적으라는 뜻이 아니라 작업에 필요한 경계를 검토할 틀이라고 정리하고 S15로 간다.</a:t>
             </a:r>
           </a:p>
           <a:p xmlns:a="http://schemas.openxmlformats.org/drawingml/2006/main">
@@ -2293,7 +2293,7 @@
           </a:p>
           <a:p xmlns:a="http://schemas.openxmlformats.org/drawingml/2006/main">
             <a:r>
-              <a:t>화면 진행: 이 장은 한 작업 요청에 다섯 책임을 묶는 구조를 보여준다. S12의 다섯 질문과 일대일 대응하는 표가 아니라 질문을 재구성하고 맥락·과정을 명시한 틀이다. 상단 안내 → 왼쪽 Task Specification → 오른쪽 행 순서로 읽는다.</a:t>
+              <a:t>화면 진행: 이 장은 한 작업 요청에 다섯 책임을 묶는 구조를 보여준다. S13의 다섯 질문과 일대일 대응하는 표가 아니라 질문을 재구성하고 맥락·과정을 명시한 틀이다. 상단 안내 → 왼쪽 Task Specification → 오른쪽 행 순서로 읽는다.</a:t>
             </a:r>
           </a:p>
           <a:p xmlns:a="http://schemas.openxmlformats.org/drawingml/2006/main">
@@ -2373,7 +2373,7 @@
           </a:p>
           <a:p xmlns:a="http://schemas.openxmlformats.org/drawingml/2006/main">
             <a:r>
-              <a:t>Transition: Slide 14에서 다섯 책임을 짧은 Before / After에 적용한다.</a:t>
+              <a:t>Transition: Slide 15에서 다섯 책임을 짧은 Before / After에 적용한다.</a:t>
             </a:r>
           </a:p>
           <a:p xmlns:a="http://schemas.openxmlformats.org/drawingml/2006/main">
@@ -2393,7 +2393,7 @@
           </a:p>
           <a:p xmlns:a="http://schemas.openxmlformats.org/drawingml/2006/main">
             <a:r>
-              <a:t>Fallback: 정적 기본 경로 — 정적 슬라이드 `production/ACT_1.pptx` S13 또는 `production/preview/act1/S13.png` 사용. 새 제작본의 렌더·경로 대조는 통합 단계에서 수행한다.</a:t>
+              <a:t>Fallback: 정적 기본 경로 — 정적 슬라이드 `production/ACT_1.pptx` S14 또는 `production/preview/act1/S14.png` 사용. 새 제작본의 렌더·경로 대조는 통합 단계에서 수행한다.</a:t>
             </a:r>
           </a:p>
           <a:p xmlns:a="http://schemas.openxmlformats.org/drawingml/2006/main">
@@ -2473,7 +2473,7 @@
           <a:lstStyle xmlns:a="http://schemas.openxmlformats.org/drawingml/2006/main"/>
           <a:p xmlns:a="http://schemas.openxmlformats.org/drawingml/2006/main">
             <a:r>
-              <a:t>## S14 — 더 긴 Prompt보다 분명한 경계</a:t>
+              <a:t>## S15 — 더 긴 Prompt보다 분명한 경계</a:t>
             </a:r>
           </a:p>
           <a:p xmlns:a="http://schemas.openxmlformats.org/drawingml/2006/main">
@@ -2483,7 +2483,7 @@
           </a:p>
           <a:p xmlns:a="http://schemas.openxmlformats.org/drawingml/2006/main">
             <a:r>
-              <a:t>Slide ID: S14</a:t>
+              <a:t>Slide ID: S15</a:t>
             </a:r>
           </a:p>
           <a:p xmlns:a="http://schemas.openxmlformats.org/drawingml/2006/main">
@@ -2693,7 +2693,7 @@
           </a:p>
           <a:p xmlns:a="http://schemas.openxmlformats.org/drawingml/2006/main">
             <a:r>
-              <a:t>Fallback: 정적 기본 경로 — 정적 비교 슬라이드 `production/ACT_1.pptx` S14 또는 `production/preview/act1/S14.png` 사용. Trial 결과로 대체하지 않는다. 새 제작본의 렌더·경로 대조는 통합 단계에서 수행한다.</a:t>
+              <a:t>Fallback: 정적 기본 경로 — 정적 비교 슬라이드 `production/ACT_1.pptx` S15 또는 `production/preview/act1/S15.png` 사용. Trial 결과로 대체하지 않는다. 새 제작본의 렌더·경로 대조는 통합 단계에서 수행한다.</a:t>
             </a:r>
           </a:p>
           <a:p xmlns:a="http://schemas.openxmlformats.org/drawingml/2006/main">
@@ -2773,7 +2773,7 @@
           <a:lstStyle xmlns:a="http://schemas.openxmlformats.org/drawingml/2006/main"/>
           <a:p xmlns:a="http://schemas.openxmlformats.org/drawingml/2006/main">
             <a:r>
-              <a:t>## S15 — 먼저 무엇을 하는지 보자</a:t>
+              <a:t>## S16 — 먼저 무엇을 하는지 보자</a:t>
             </a:r>
           </a:p>
           <a:p xmlns:a="http://schemas.openxmlformats.org/drawingml/2006/main">
@@ -2783,7 +2783,7 @@
           </a:p>
           <a:p xmlns:a="http://schemas.openxmlformats.org/drawingml/2006/main">
             <a:r>
-              <a:t>Slide ID: S15</a:t>
+              <a:t>Slide ID: S16</a:t>
             </a:r>
           </a:p>
           <a:p xmlns:a="http://schemas.openxmlformats.org/drawingml/2006/main">
@@ -2863,7 +2863,7 @@
           </a:p>
           <a:p xmlns:a="http://schemas.openxmlformats.org/drawingml/2006/main">
             <a:r>
-              <a:t>1. (0:00–0:35) S14의 교육용 구성 예시에서 과거 TRIAL-002 기록으로 전환했음을 밝힌다. “실제 기록에서는 수정 전에 무엇을 했을까?”를 제시한다. S14 화면의 요청을 그대로 실행한 것으로 설명하지 않는다.</a:t>
+              <a:t>1. (0:00–0:35) S15의 교육용 구성 예시에서 과거 TRIAL-002 기록으로 전환했음을 밝힌다. “실제 기록에서는 수정 전에 무엇을 했을까?”를 제시한다. S15 화면의 요청을 그대로 실행한 것으로 설명하지 않는다.</a:t>
             </a:r>
           </a:p>
           <a:p xmlns:a="http://schemas.openxmlformats.org/drawingml/2006/main">
@@ -2873,7 +2873,7 @@
           </a:p>
           <a:p xmlns:a="http://schemas.openxmlformats.org/drawingml/2006/main">
             <a:r>
-              <a:t>3. (1:35–2:00) 다음 두 장에서 이 단일 과거 CLI 기록의 요청 흐름과 행동을 대조한다고 알리고 S16으로 이동한다.</a:t>
+              <a:t>3. (1:35–2:00) 다음 두 장에서 이 단일 과거 CLI 기록의 요청 흐름과 행동을 대조한다고 알리고 S17으로 이동한다.</a:t>
             </a:r>
           </a:p>
           <a:p xmlns:a="http://schemas.openxmlformats.org/drawingml/2006/main">
@@ -2953,7 +2953,7 @@
           </a:p>
           <a:p xmlns:a="http://schemas.openxmlformats.org/drawingml/2006/main">
             <a:r>
-              <a:t>Transition: Slide 16에서 조사와 변경의 핵심 장면을 보여준다.</a:t>
+              <a:t>Transition: Slide 17에서 조사와 변경의 핵심 장면을 보여준다.</a:t>
             </a:r>
           </a:p>
           <a:p xmlns:a="http://schemas.openxmlformats.org/drawingml/2006/main">
@@ -2973,7 +2973,7 @@
           </a:p>
           <a:p xmlns:a="http://schemas.openxmlformats.org/drawingml/2006/main">
             <a:r>
-              <a:t>Fallback: 정적 기본 경로 — 정적 WATCH 슬라이드 `production/ACT_1.pptx` S15 또는 `production/preview/act1/S15.png` 사용. 라이브 실행은 이 단계에서 하지 않는다. 새 제작본의 렌더·경로 대조는 통합 단계에서 수행한다.</a:t>
+              <a:t>Fallback: 정적 기본 경로 — 정적 WATCH 슬라이드 `production/ACT_1.pptx` S16 또는 `production/preview/act1/S16.png` 사용. 라이브 실행은 이 단계에서 하지 않는다. 새 제작본의 렌더·경로 대조는 통합 단계에서 수행한다.</a:t>
             </a:r>
           </a:p>
           <a:p xmlns:a="http://schemas.openxmlformats.org/drawingml/2006/main">
@@ -3053,7 +3053,7 @@
           <a:lstStyle xmlns:a="http://schemas.openxmlformats.org/drawingml/2006/main"/>
           <a:p xmlns:a="http://schemas.openxmlformats.org/drawingml/2006/main">
             <a:r>
-              <a:t>## S16 — 조사에서 한 줄 변경까지</a:t>
+              <a:t>## S17 — 조사에서 한 줄 변경까지</a:t>
             </a:r>
           </a:p>
           <a:p xmlns:a="http://schemas.openxmlformats.org/drawingml/2006/main">
@@ -3063,7 +3063,7 @@
           </a:p>
           <a:p xmlns:a="http://schemas.openxmlformats.org/drawingml/2006/main">
             <a:r>
-              <a:t>Slide ID: S16</a:t>
+              <a:t>Slide ID: S17</a:t>
             </a:r>
           </a:p>
           <a:p xmlns:a="http://schemas.openxmlformats.org/drawingml/2006/main">
@@ -3158,7 +3158,7 @@
           </a:p>
           <a:p xmlns:a="http://schemas.openxmlformats.org/drawingml/2006/main">
             <a:r>
-              <a:t>4. (3:15–4:00) 이 입력의 너비 3이 계약대로 2가 되는 변화로 정리한다. 정적 소스·diff 재구성이며 새 실행이나 screenshot이 아님을 유지하고 S17로 넘긴다.</a:t>
+              <a:t>4. (3:15–4:00) 이 입력의 너비 3이 계약대로 2가 되는 변화로 정리한다. 정적 소스·diff 재구성이며 새 실행이나 screenshot이 아님을 유지하고 S18로 넘긴다.</a:t>
             </a:r>
           </a:p>
           <a:p xmlns:a="http://schemas.openxmlformats.org/drawingml/2006/main">
@@ -3218,7 +3218,7 @@
           </a:p>
           <a:p xmlns:a="http://schemas.openxmlformats.org/drawingml/2006/main">
             <a:r>
-              <a:t>Demo Operation: DEMO-05 / CAPTURED historical evidence. `production/ACT_1.pptx` S16의 실제 diff 재구성 도식을 사용한다. 실패 테스트·호출 경로·계약·수정 전 계획 → Before/After slice → 너비 변화를 순서대로 가리킨다. source test ID: `test_crop_excludes_end_coordinate`. Source: TRIAL-002 record, STATE-00 및 STATE-00-FIXED의 `src/graypipe/transform.py`. 전체 파일이나 새 실행을 보여 주지 않는다.</a:t>
+              <a:t>Demo Operation: DEMO-05 / CAPTURED historical evidence. `production/ACT_1.pptx` S17의 실제 diff 재구성 도식을 사용한다. 실패 테스트·호출 경로·계약·수정 전 계획 → Before/After slice → 너비 변화를 순서대로 가리킨다. source test ID: `test_crop_excludes_end_coordinate`. Source: TRIAL-002 record, STATE-00 및 STATE-00-FIXED의 `src/graypipe/transform.py`. 전체 파일이나 새 실행을 보여 주지 않는다.</a:t>
             </a:r>
           </a:p>
           <a:p xmlns:a="http://schemas.openxmlformats.org/drawingml/2006/main">
@@ -3238,7 +3238,7 @@
           </a:p>
           <a:p xmlns:a="http://schemas.openxmlformats.org/drawingml/2006/main">
             <a:r>
-              <a:t>Transition: Slide 17에서 변경 결과를 어떤 확인으로 뒷받침했는지 본다.</a:t>
+              <a:t>Transition: Slide 18에서 변경 결과를 어떤 확인으로 뒷받침했는지 본다.</a:t>
             </a:r>
           </a:p>
           <a:p xmlns:a="http://schemas.openxmlformats.org/drawingml/2006/main">
@@ -3258,7 +3258,7 @@
           </a:p>
           <a:p xmlns:a="http://schemas.openxmlformats.org/drawingml/2006/main">
             <a:r>
-              <a:t>Fallback: 정적 기본 경로 — 정적 PPTX S16 또는 `production/preview/act1/S16.png` 사용. 시각 도식은 기록에서 재구성한 자료이며 원본 화면 캡처가 아니다. 실행 실패 상황은 없다: Live를 하지 않는다. 새 제작본의 렌더·경로 대조는 통합 단계에서 수행한다.</a:t>
+              <a:t>Fallback: 정적 기본 경로 — 정적 PPTX S17 또는 `production/preview/act1/S17.png` 사용. 시각 도식은 기록에서 재구성한 자료이며 원본 화면 캡처가 아니다. 실행 실패 상황은 없다: Live를 하지 않는다. 새 제작본의 렌더·경로 대조는 통합 단계에서 수행한다.</a:t>
             </a:r>
           </a:p>
           <a:p xmlns:a="http://schemas.openxmlformats.org/drawingml/2006/main">
@@ -3338,7 +3338,7 @@
           <a:lstStyle xmlns:a="http://schemas.openxmlformats.org/drawingml/2006/main"/>
           <a:p xmlns:a="http://schemas.openxmlformats.org/drawingml/2006/main">
             <a:r>
-              <a:t>## S17 — 변경 결과와 확인 증거</a:t>
+              <a:t>## S18 — 변경 결과와 확인 증거</a:t>
             </a:r>
           </a:p>
           <a:p xmlns:a="http://schemas.openxmlformats.org/drawingml/2006/main">
@@ -3348,7 +3348,7 @@
           </a:p>
           <a:p xmlns:a="http://schemas.openxmlformats.org/drawingml/2006/main">
             <a:r>
-              <a:t>Slide ID: S17</a:t>
+              <a:t>Slide ID: S18</a:t>
             </a:r>
           </a:p>
           <a:p xmlns:a="http://schemas.openxmlformats.org/drawingml/2006/main">
@@ -3443,7 +3443,7 @@
           </a:p>
           <a:p xmlns:a="http://schemas.openxmlformats.org/drawingml/2006/main">
             <a:r>
-              <a:t>4. (3:30–4:00) 생성된 코드와 완료 판단의 차이로 S18에 넘긴다.</a:t>
+              <a:t>4. (3:30–4:00) 생성된 코드와 완료 판단의 차이로 S19에 넘긴다.</a:t>
             </a:r>
           </a:p>
           <a:p xmlns:a="http://schemas.openxmlformats.org/drawingml/2006/main">
@@ -3523,7 +3523,7 @@
           </a:p>
           <a:p xmlns:a="http://schemas.openxmlformats.org/drawingml/2006/main">
             <a:r>
-              <a:t>Transition: 생성 자체와 완료 판단을 구분하는 Slide 18로 간다.</a:t>
+              <a:t>Transition: 생성 자체와 완료 판단을 구분하는 Slide 19로 간다.</a:t>
             </a:r>
           </a:p>
           <a:p xmlns:a="http://schemas.openxmlformats.org/drawingml/2006/main">
@@ -3543,7 +3543,7 @@
           </a:p>
           <a:p xmlns:a="http://schemas.openxmlformats.org/drawingml/2006/main">
             <a:r>
-              <a:t>Fallback: 정적 기본 경로 — 정적 PPTX S17 또는 `production/preview/act1/S17.png` 사용. 수치는 TRIAL-002 기록에 한정한다; 새로운 pass 수치를 추가하지 않는다. 새 제작본의 렌더·경로 대조는 통합 단계에서 수행한다.</a:t>
+              <a:t>Fallback: 정적 기본 경로 — 정적 PPTX S18 또는 `production/preview/act1/S18.png` 사용. 수치는 TRIAL-002 기록에 한정한다; 새로운 pass 수치를 추가하지 않는다. 새 제작본의 렌더·경로 대조는 통합 단계에서 수행한다.</a:t>
             </a:r>
           </a:p>
           <a:p xmlns:a="http://schemas.openxmlformats.org/drawingml/2006/main">
@@ -3623,7 +3623,7 @@
           <a:lstStyle xmlns:a="http://schemas.openxmlformats.org/drawingml/2006/main"/>
           <a:p xmlns:a="http://schemas.openxmlformats.org/drawingml/2006/main">
             <a:r>
-              <a:t>## S18 — Generated ≠ Done</a:t>
+              <a:t>## S19 — Generated ≠ Done</a:t>
             </a:r>
           </a:p>
           <a:p xmlns:a="http://schemas.openxmlformats.org/drawingml/2006/main">
@@ -3633,7 +3633,7 @@
           </a:p>
           <a:p xmlns:a="http://schemas.openxmlformats.org/drawingml/2006/main">
             <a:r>
-              <a:t>Slide ID: S18</a:t>
+              <a:t>Slide ID: S19</a:t>
             </a:r>
           </a:p>
           <a:p xmlns:a="http://schemas.openxmlformats.org/drawingml/2006/main">
@@ -3718,7 +3718,7 @@
           </a:p>
           <a:p xmlns:a="http://schemas.openxmlformats.org/drawingml/2006/main">
             <a:r>
-              <a:t>2. (0:45–2:15) 검토용 결과 인계의 네 항목을 crop 사례로 설명한다. 변경 이유·범위는 끝 좌표 제외 계약에 맞춘 crop 한 줄 수정, 검증 근거·결과는 S17의 집중·전체 테스트와 CLI·diff 기록 참조, 미확인은 이 수정의 성능을 측정하지 않았다는 점, 사람의 수용 판단은 이 범위와 근거로 변경을 받아들일지 개발자가 결정한다는 점이다. 동작 테스트·샘플 실행·변경 검토는 검증 근거 항목에 묶고 수치를 다시 나열하지 않는다. 이 네 항목은 기존 기록의 강의용 정리이며 실제 PR이나 당시 Agent 답변 원문이 아니다.</a:t>
+              <a:t>2. (0:45–2:15) 검토용 결과 인계의 네 항목을 crop 사례로 설명한다. 변경 이유·범위는 끝 좌표 제외 계약에 맞춘 crop 한 줄 수정, 검증 근거·결과는 S18의 집중·전체 테스트와 CLI·diff 기록 참조, 미확인은 이 수정의 성능을 측정하지 않았다는 점, 사람의 수용 판단은 이 범위와 근거로 변경을 받아들일지 개발자가 결정한다는 점이다. 동작 테스트·샘플 실행·변경 검토는 검증 근거 항목에 묶고 수치를 다시 나열하지 않는다. 이 네 항목은 기존 기록의 강의용 정리이며 실제 PR이나 당시 Agent 답변 원문이 아니다.</a:t>
             </a:r>
           </a:p>
           <a:p xmlns:a="http://schemas.openxmlformats.org/drawingml/2006/main">
@@ -3728,7 +3728,7 @@
           </a:p>
           <a:p xmlns:a="http://schemas.openxmlformats.org/drawingml/2006/main">
             <a:r>
-              <a:t>4. (2:45–3:00) 주장마다 필요한 근거가 다르다는 S19로 넘긴다.</a:t>
+              <a:t>4. (2:45–3:00) 주장마다 필요한 근거가 다르다는 S20로 넘긴다.</a:t>
             </a:r>
           </a:p>
           <a:p xmlns:a="http://schemas.openxmlformats.org/drawingml/2006/main">
@@ -3778,7 +3778,7 @@
           </a:p>
           <a:p xmlns:a="http://schemas.openxmlformats.org/drawingml/2006/main">
             <a:r>
-              <a:t>C++ Vision Bridge: C++ 대응은 S19 Notes의 선택적 참고로 남기며 S19 화면에는 C++ inset이 없다. 주요 C++ 패턴 전이는 S53에서 이어 간다. 이 장에서 중복 설명하지 않는다.</a:t>
+              <a:t>C++ Vision Bridge: C++ 대응은 S20 Notes의 선택적 참고로 남기며 S20 화면에는 C++ inset이 없다. 주요 C++ 패턴 전이는 S54에서 이어 간다. 이 장에서 중복 설명하지 않는다.</a:t>
             </a:r>
           </a:p>
           <a:p xmlns:a="http://schemas.openxmlformats.org/drawingml/2006/main">
@@ -3808,7 +3808,7 @@
           </a:p>
           <a:p xmlns:a="http://schemas.openxmlformats.org/drawingml/2006/main">
             <a:r>
-              <a:t>Transition: Slide 19에서 각 Check가 뒷받침하는 범위를 비교한다.</a:t>
+              <a:t>Transition: Slide 20에서 각 Check가 뒷받침하는 범위를 비교한다.</a:t>
             </a:r>
           </a:p>
           <a:p xmlns:a="http://schemas.openxmlformats.org/drawingml/2006/main">
@@ -3818,7 +3818,7 @@
           </a:p>
           <a:p xmlns:a="http://schemas.openxmlformats.org/drawingml/2006/main">
             <a:r>
-              <a:t>Time Management: Lecture 3분을 유지한다. 생성·완료 질문 45초, 결과 인계 예시 90초, 조건부 성능 측정 30초, S19 연결 15초로 배분한다. 기존 검증 근거의 재나열과 반복 설명을 이 예시로 교체한다. 기록 사실과 Teaching Model을 분리하고 S17의 다섯 수치를 다시 읽지 않는다. 실제 시간 적합성은 리허설 전까지 UNVERIFIED다.</a:t>
+              <a:t>Time Management: Lecture 3분을 유지한다. 생성·완료 질문 45초, 결과 인계 예시 90초, 조건부 성능 측정 30초, S20 연결 15초로 배분한다. 기존 검증 근거의 재나열과 반복 설명을 이 예시로 교체한다. 기록 사실과 Teaching Model을 분리하고 S18의 다섯 수치를 다시 읽지 않는다. 실제 시간 적합성은 리허설 전까지 UNVERIFIED다.</a:t>
             </a:r>
           </a:p>
           <a:p xmlns:a="http://schemas.openxmlformats.org/drawingml/2006/main">
@@ -3828,7 +3828,7 @@
           </a:p>
           <a:p xmlns:a="http://schemas.openxmlformats.org/drawingml/2006/main">
             <a:r>
-              <a:t>Fallback: 정적 PPTX S18 또는 `production/preview/act1/S18.png`를 사용한다. 생성·완료의 관계는 교육 모델, TRIAL-002는 하단에 표시된 과거 관찰로 구분한다. 새 렌더 검토는 통합 단계에서 수행한다.</a:t>
+              <a:t>Fallback: 정적 PPTX S19 또는 `production/preview/act1/S19.png`를 사용한다. 생성·완료의 관계는 교육 모델, TRIAL-002는 하단에 표시된 과거 관찰로 구분한다. 새 렌더 검토는 통합 단계에서 수행한다.</a:t>
             </a:r>
           </a:p>
           <a:p xmlns:a="http://schemas.openxmlformats.org/drawingml/2006/main">
@@ -3885,7 +3885,7 @@
           <p:cNvPr id="3" name="Title">
             <a:extLst xmlns:a="http://schemas.openxmlformats.org/drawingml/2006/main">
               <a:ext uri="{FF2B5EF4-FFF2-40B4-BE49-F238E27FC236}">
-                <a16:creationId xmlns:a16="http://schemas.microsoft.com/office/drawing/2014/main" id="{BF05E2ED-386F-44A2-BD09-6FE03AE2FFAB}"/>
+                <a16:creationId xmlns:a16="http://schemas.microsoft.com/office/drawing/2014/main" id="{B4895B26-014A-40CE-B565-089FA1CEFC9A}"/>
               </a:ext>
             </a:extLst>
           </p:cNvPr>
@@ -4114,7 +4114,7 @@
           <p:cNvPr id="2" name="Subtitle">
             <a:extLst xmlns:a="http://schemas.openxmlformats.org/drawingml/2006/main">
               <a:ext uri="{FF2B5EF4-FFF2-40B4-BE49-F238E27FC236}">
-                <a16:creationId xmlns:a16="http://schemas.microsoft.com/office/drawing/2014/main" id="{234A13AF-B62F-491E-A366-E2EDE55F82C8}"/>
+                <a16:creationId xmlns:a16="http://schemas.microsoft.com/office/drawing/2014/main" id="{E267AEA2-FBA7-4985-9A66-DDABA9105032}"/>
               </a:ext>
             </a:extLst>
           </p:cNvPr>
@@ -4360,7 +4360,7 @@
           <p:cNvPr id="2" name="Section title">
             <a:extLst xmlns:a="http://schemas.openxmlformats.org/drawingml/2006/main">
               <a:ext uri="{FF2B5EF4-FFF2-40B4-BE49-F238E27FC236}">
-                <a16:creationId xmlns:a16="http://schemas.microsoft.com/office/drawing/2014/main" id="{595EF860-08AD-45C6-A3A7-22291E62F46F}"/>
+                <a16:creationId xmlns:a16="http://schemas.microsoft.com/office/drawing/2014/main" id="{81C58DA9-D917-4F50-846B-139D40FE96CC}"/>
               </a:ext>
             </a:extLst>
           </p:cNvPr>
@@ -4606,7 +4606,7 @@
           <p:cNvPr id="3" name="Title">
             <a:extLst xmlns:a="http://schemas.openxmlformats.org/drawingml/2006/main">
               <a:ext uri="{FF2B5EF4-FFF2-40B4-BE49-F238E27FC236}">
-                <a16:creationId xmlns:a16="http://schemas.microsoft.com/office/drawing/2014/main" id="{804EEBCB-4C90-4B03-A7E5-CC923CF22ADD}"/>
+                <a16:creationId xmlns:a16="http://schemas.microsoft.com/office/drawing/2014/main" id="{7D2670E6-1D9B-45E8-BA5F-17EECBCF44B3}"/>
               </a:ext>
             </a:extLst>
           </p:cNvPr>
@@ -4835,7 +4835,7 @@
           <p:cNvPr id="2" name="Body">
             <a:extLst xmlns:a="http://schemas.openxmlformats.org/drawingml/2006/main">
               <a:ext uri="{FF2B5EF4-FFF2-40B4-BE49-F238E27FC236}">
-                <a16:creationId xmlns:a16="http://schemas.microsoft.com/office/drawing/2014/main" id="{74FABCCD-9282-441E-AB2D-B001A93994EC}"/>
+                <a16:creationId xmlns:a16="http://schemas.microsoft.com/office/drawing/2014/main" id="{123A3B53-9BAC-4779-953D-97E4ADCEA5D9}"/>
               </a:ext>
             </a:extLst>
           </p:cNvPr>
@@ -5081,7 +5081,7 @@
           <p:cNvPr id="4" name="Title">
             <a:extLst xmlns:a="http://schemas.openxmlformats.org/drawingml/2006/main">
               <a:ext uri="{FF2B5EF4-FFF2-40B4-BE49-F238E27FC236}">
-                <a16:creationId xmlns:a16="http://schemas.microsoft.com/office/drawing/2014/main" id="{D9DA7CA1-7BF6-48F8-ADCB-6E05B0EC61A7}"/>
+                <a16:creationId xmlns:a16="http://schemas.microsoft.com/office/drawing/2014/main" id="{0D4EC5BC-7BF7-479A-87BB-F4513117264C}"/>
               </a:ext>
             </a:extLst>
           </p:cNvPr>
@@ -5310,7 +5310,7 @@
           <p:cNvPr id="2" name="Left column">
             <a:extLst xmlns:a="http://schemas.openxmlformats.org/drawingml/2006/main">
               <a:ext uri="{FF2B5EF4-FFF2-40B4-BE49-F238E27FC236}">
-                <a16:creationId xmlns:a16="http://schemas.microsoft.com/office/drawing/2014/main" id="{46961BD3-795D-44F8-9EA7-FF84D2325FC1}"/>
+                <a16:creationId xmlns:a16="http://schemas.microsoft.com/office/drawing/2014/main" id="{0E10C938-E509-4C41-8C10-FA8B51ABC183}"/>
               </a:ext>
             </a:extLst>
           </p:cNvPr>
@@ -5539,7 +5539,7 @@
           <p:cNvPr id="3" name="Right column">
             <a:extLst xmlns:a="http://schemas.openxmlformats.org/drawingml/2006/main">
               <a:ext uri="{FF2B5EF4-FFF2-40B4-BE49-F238E27FC236}">
-                <a16:creationId xmlns:a16="http://schemas.microsoft.com/office/drawing/2014/main" id="{B296F7E1-6383-41F9-BC8E-DDF024593097}"/>
+                <a16:creationId xmlns:a16="http://schemas.microsoft.com/office/drawing/2014/main" id="{80868CDE-5F3C-4791-AA79-F0DF5F5F5F2B}"/>
               </a:ext>
             </a:extLst>
           </p:cNvPr>
@@ -5785,7 +5785,7 @@
           <p:cNvPr id="3" name="Title">
             <a:extLst xmlns:a="http://schemas.openxmlformats.org/drawingml/2006/main">
               <a:ext uri="{FF2B5EF4-FFF2-40B4-BE49-F238E27FC236}">
-                <a16:creationId xmlns:a16="http://schemas.microsoft.com/office/drawing/2014/main" id="{6FB72378-15A3-42D5-8090-AE8F164434C3}"/>
+                <a16:creationId xmlns:a16="http://schemas.microsoft.com/office/drawing/2014/main" id="{9EEA3A84-5053-4BED-B139-D7FFEA664E3E}"/>
               </a:ext>
             </a:extLst>
           </p:cNvPr>
@@ -6014,7 +6014,7 @@
           <p:cNvPr id="2" name="Left column">
             <a:extLst xmlns:a="http://schemas.openxmlformats.org/drawingml/2006/main">
               <a:ext uri="{FF2B5EF4-FFF2-40B4-BE49-F238E27FC236}">
-                <a16:creationId xmlns:a16="http://schemas.microsoft.com/office/drawing/2014/main" id="{48301239-472E-47B1-BA88-6047DD0F64D6}"/>
+                <a16:creationId xmlns:a16="http://schemas.microsoft.com/office/drawing/2014/main" id="{2FF9EDC6-48E4-4A51-80C2-210EC2575D79}"/>
               </a:ext>
             </a:extLst>
           </p:cNvPr>
@@ -6281,12 +6281,12 @@
   </p:cSld>
   <p:clrMap bg1="lt1" tx1="dk1" bg2="lt2" tx2="dk2" accent1="accent1" accent2="accent2" accent3="accent3" accent4="accent4" accent5="accent5" accent6="accent6" hlink="hlink" folHlink="folHlink"/>
   <p:sldLayoutIdLst>
-    <p:sldLayoutId xmlns:r="http://schemas.openxmlformats.org/officeDocument/2006/relationships" id="2147483649" r:id="R45a074409c1a4bb6"/>
-    <p:sldLayoutId xmlns:r="http://schemas.openxmlformats.org/officeDocument/2006/relationships" id="2147483650" r:id="Rbf16747a310042dd"/>
-    <p:sldLayoutId xmlns:r="http://schemas.openxmlformats.org/officeDocument/2006/relationships" id="2147483651" r:id="R57beb660c49249cb"/>
-    <p:sldLayoutId xmlns:r="http://schemas.openxmlformats.org/officeDocument/2006/relationships" id="2147483652" r:id="R21943564f04c40d5"/>
-    <p:sldLayoutId xmlns:r="http://schemas.openxmlformats.org/officeDocument/2006/relationships" id="2147483653" r:id="R584589a7d76246f5"/>
-    <p:sldLayoutId xmlns:r="http://schemas.openxmlformats.org/officeDocument/2006/relationships" id="2147483654" r:id="R8b3ed2088cb046ed"/>
+    <p:sldLayoutId xmlns:r="http://schemas.openxmlformats.org/officeDocument/2006/relationships" id="2147483649" r:id="R65e3bbb70b7b4ac1"/>
+    <p:sldLayoutId xmlns:r="http://schemas.openxmlformats.org/officeDocument/2006/relationships" id="2147483650" r:id="Rf9d8aefaa550429c"/>
+    <p:sldLayoutId xmlns:r="http://schemas.openxmlformats.org/officeDocument/2006/relationships" id="2147483651" r:id="R6573f847b8f94dbf"/>
+    <p:sldLayoutId xmlns:r="http://schemas.openxmlformats.org/officeDocument/2006/relationships" id="2147483652" r:id="Rce5d8491882448f6"/>
+    <p:sldLayoutId xmlns:r="http://schemas.openxmlformats.org/officeDocument/2006/relationships" id="2147483653" r:id="R9ea5414858604128"/>
+    <p:sldLayoutId xmlns:r="http://schemas.openxmlformats.org/officeDocument/2006/relationships" id="2147483654" r:id="Rde4177654812497b"/>
   </p:sldLayoutIdLst>
   <p:txStyles>
     <p:titleStyle>
@@ -6837,7 +6837,7 @@
           <p:cNvPr id="25" name="ACT 1 · 모호한 작업 요청">
             <a:extLst xmlns:a="http://schemas.openxmlformats.org/drawingml/2006/main">
               <a:ext uri="{FF2B5EF4-FFF2-40B4-BE49-F238E27FC236}">
-                <a16:creationId xmlns:a16="http://schemas.microsoft.com/office/drawing/2014/main" id="{27C648DA-749E-42C5-9023-3ED398A9E640}"/>
+                <a16:creationId xmlns:a16="http://schemas.microsoft.com/office/drawing/2014/main" id="{CAB268C0-0085-493E-9BAB-A83A3E62B48F}"/>
               </a:ext>
             </a:extLst>
           </p:cNvPr>
@@ -6992,10 +6992,10 @@
       </p:sp>
       <p:sp>
         <p:nvSpPr>
-          <p:cNvPr id="2" name="S10">
+          <p:cNvPr id="2" name="S11">
             <a:extLst xmlns:a="http://schemas.openxmlformats.org/drawingml/2006/main">
               <a:ext uri="{FF2B5EF4-FFF2-40B4-BE49-F238E27FC236}">
-                <a16:creationId xmlns:a16="http://schemas.microsoft.com/office/drawing/2014/main" id="{92B15319-D3C1-41BE-A87F-0D91697A0179}"/>
+                <a16:creationId xmlns:a16="http://schemas.microsoft.com/office/drawing/2014/main" id="{635E7E12-B3EC-4A68-B75B-36ADD8F325C8}"/>
               </a:ext>
             </a:extLst>
           </p:cNvPr>
@@ -7143,7 +7143,7 @@
                 <a:ea typeface="Malgun Gothic"/>
                 <a:cs typeface="Malgun Gothic"/>
               </a:rPr>
-              <a:t>S10</a:t>
+              <a:t>S11</a:t>
             </a:r>
           </a:p>
         </p:txBody>
@@ -7153,7 +7153,7 @@
           <p:cNvPr id="3" name="Task에는 무엇이 아직 정해지지 않았을까?">
             <a:extLst xmlns:a="http://schemas.openxmlformats.org/drawingml/2006/main">
               <a:ext uri="{FF2B5EF4-FFF2-40B4-BE49-F238E27FC236}">
-                <a16:creationId xmlns:a16="http://schemas.microsoft.com/office/drawing/2014/main" id="{FA2E5D51-EFE3-4ABB-9349-64C307D2FDA8}"/>
+                <a16:creationId xmlns:a16="http://schemas.microsoft.com/office/drawing/2014/main" id="{2DDF78E5-5121-4CFA-A91A-7C19892728C6}"/>
               </a:ext>
             </a:extLst>
           </p:cNvPr>
@@ -7311,7 +7311,7 @@
           <p:cNvPr id="4" name="">
             <a:extLst xmlns:a="http://schemas.openxmlformats.org/drawingml/2006/main">
               <a:ext uri="{FF2B5EF4-FFF2-40B4-BE49-F238E27FC236}">
-                <a16:creationId xmlns:a16="http://schemas.microsoft.com/office/drawing/2014/main" id="{1675A8C4-33D5-427D-87C2-F14972FBFBA3}"/>
+                <a16:creationId xmlns:a16="http://schemas.microsoft.com/office/drawing/2014/main" id="{B3930B36-901E-43CE-9F1B-5CF2143C2B99}"/>
               </a:ext>
             </a:extLst>
           </p:cNvPr>
@@ -7342,7 +7342,7 @@
           <p:cNvPr id="5" name="교육용 구성 사례 · 실제 Agent 실패나 Trial 결과가 아님">
             <a:extLst xmlns:a="http://schemas.openxmlformats.org/drawingml/2006/main">
               <a:ext uri="{FF2B5EF4-FFF2-40B4-BE49-F238E27FC236}">
-                <a16:creationId xmlns:a16="http://schemas.microsoft.com/office/drawing/2014/main" id="{B88F1E6B-3F9F-42FA-9278-E6B67E36B09A}"/>
+                <a16:creationId xmlns:a16="http://schemas.microsoft.com/office/drawing/2014/main" id="{414F4B62-AE9A-49CB-A658-B0CF2AFCCD02}"/>
               </a:ext>
             </a:extLst>
           </p:cNvPr>
@@ -7500,7 +7500,7 @@
           <p:cNvPr id="6" name="Repository는 열려 있어도 작업의 목표·보존 조건·완료 기준이 자동으로 정해지지는 않습니다.">
             <a:extLst xmlns:a="http://schemas.openxmlformats.org/drawingml/2006/main">
               <a:ext uri="{FF2B5EF4-FFF2-40B4-BE49-F238E27FC236}">
-                <a16:creationId xmlns:a16="http://schemas.microsoft.com/office/drawing/2014/main" id="{7DE11FEF-45F8-421D-B770-F07BA2838FE1}"/>
+                <a16:creationId xmlns:a16="http://schemas.microsoft.com/office/drawing/2014/main" id="{98C9D78C-BFA3-4960-8230-C3C9721441D6}"/>
               </a:ext>
             </a:extLst>
           </p:cNvPr>
@@ -7658,7 +7658,7 @@
           <p:cNvPr id="7" name="같은 Repository를 보고 있습니다.">
             <a:extLst xmlns:a="http://schemas.openxmlformats.org/drawingml/2006/main">
               <a:ext uri="{FF2B5EF4-FFF2-40B4-BE49-F238E27FC236}">
-                <a16:creationId xmlns:a16="http://schemas.microsoft.com/office/drawing/2014/main" id="{DA41074A-5CD0-4426-BC49-B1F433B4611B}"/>
+                <a16:creationId xmlns:a16="http://schemas.microsoft.com/office/drawing/2014/main" id="{FDE07CBF-A529-4219-BFE8-988B3975C518}"/>
               </a:ext>
             </a:extLst>
           </p:cNvPr>
@@ -7816,7 +7816,7 @@
           <p:cNvPr id="8" name="">
             <a:extLst xmlns:a="http://schemas.openxmlformats.org/drawingml/2006/main">
               <a:ext uri="{FF2B5EF4-FFF2-40B4-BE49-F238E27FC236}">
-                <a16:creationId xmlns:a16="http://schemas.microsoft.com/office/drawing/2014/main" id="{1D4B4446-7A2E-4C1B-B701-CDF5793AA934}"/>
+                <a16:creationId xmlns:a16="http://schemas.microsoft.com/office/drawing/2014/main" id="{415A6562-52A0-4D1D-A317-5C73707A4009}"/>
               </a:ext>
             </a:extLst>
           </p:cNvPr>
@@ -7849,7 +7849,7 @@
           <p:cNvPr id="9" name="요청">
             <a:extLst xmlns:a="http://schemas.openxmlformats.org/drawingml/2006/main">
               <a:ext uri="{FF2B5EF4-FFF2-40B4-BE49-F238E27FC236}">
-                <a16:creationId xmlns:a16="http://schemas.microsoft.com/office/drawing/2014/main" id="{831E3F75-38A5-46DF-B174-985BC9B8FB71}"/>
+                <a16:creationId xmlns:a16="http://schemas.microsoft.com/office/drawing/2014/main" id="{93D394D8-6293-4EE4-8604-C57C17D8FAB9}"/>
               </a:ext>
             </a:extLst>
           </p:cNvPr>
@@ -8007,7 +8007,7 @@
           <p:cNvPr id="10" name="“filter 성능&#10;개선해줘.”">
             <a:extLst xmlns:a="http://schemas.openxmlformats.org/drawingml/2006/main">
               <a:ext uri="{FF2B5EF4-FFF2-40B4-BE49-F238E27FC236}">
-                <a16:creationId xmlns:a16="http://schemas.microsoft.com/office/drawing/2014/main" id="{0D077853-A04B-4AC0-BAB3-BB4897FD008B}"/>
+                <a16:creationId xmlns:a16="http://schemas.microsoft.com/office/drawing/2014/main" id="{8848B29A-3A39-49FA-9C2A-03E4DA9A1E4D}"/>
               </a:ext>
             </a:extLst>
           </p:cNvPr>
@@ -8188,7 +8188,7 @@
           <p:cNvPr id="11" name="">
             <a:extLst xmlns:a="http://schemas.openxmlformats.org/drawingml/2006/main">
               <a:ext uri="{FF2B5EF4-FFF2-40B4-BE49-F238E27FC236}">
-                <a16:creationId xmlns:a16="http://schemas.microsoft.com/office/drawing/2014/main" id="{60A61832-B68C-4DCB-B7D2-066805AD68CA}"/>
+                <a16:creationId xmlns:a16="http://schemas.microsoft.com/office/drawing/2014/main" id="{774E81F7-382A-4C1A-84B0-6F0BC1D88C67}"/>
               </a:ext>
             </a:extLst>
           </p:cNvPr>
@@ -8218,7 +8218,7 @@
           <p:cNvPr id="12" name="바꿀 것">
             <a:extLst xmlns:a="http://schemas.openxmlformats.org/drawingml/2006/main">
               <a:ext uri="{FF2B5EF4-FFF2-40B4-BE49-F238E27FC236}">
-                <a16:creationId xmlns:a16="http://schemas.microsoft.com/office/drawing/2014/main" id="{F9682806-6F84-4B09-A16D-4AFFEF63AAAD}"/>
+                <a16:creationId xmlns:a16="http://schemas.microsoft.com/office/drawing/2014/main" id="{899458E5-2585-4FD5-B7B2-0140FED82A9A}"/>
               </a:ext>
             </a:extLst>
           </p:cNvPr>
@@ -8376,7 +8376,7 @@
           <p:cNvPr id="13" name="">
             <a:extLst xmlns:a="http://schemas.openxmlformats.org/drawingml/2006/main">
               <a:ext uri="{FF2B5EF4-FFF2-40B4-BE49-F238E27FC236}">
-                <a16:creationId xmlns:a16="http://schemas.microsoft.com/office/drawing/2014/main" id="{0ED7936E-A900-4207-A18F-93F66057980D}"/>
+                <a16:creationId xmlns:a16="http://schemas.microsoft.com/office/drawing/2014/main" id="{E13232AE-DEE8-48F5-A19D-17905B4C96C8}"/>
               </a:ext>
             </a:extLst>
           </p:cNvPr>
@@ -8407,7 +8407,7 @@
           <p:cNvPr id="14" name="무엇을 바꿀까?">
             <a:extLst xmlns:a="http://schemas.openxmlformats.org/drawingml/2006/main">
               <a:ext uri="{FF2B5EF4-FFF2-40B4-BE49-F238E27FC236}">
-                <a16:creationId xmlns:a16="http://schemas.microsoft.com/office/drawing/2014/main" id="{4C3C5D8B-D3DC-4FB7-828D-E4B6C1EAF03F}"/>
+                <a16:creationId xmlns:a16="http://schemas.microsoft.com/office/drawing/2014/main" id="{D095CFC3-3C0A-4706-B622-5DBB59ADA2CF}"/>
               </a:ext>
             </a:extLst>
           </p:cNvPr>
@@ -8565,7 +8565,7 @@
           <p:cNvPr id="15" name="?">
             <a:extLst xmlns:a="http://schemas.openxmlformats.org/drawingml/2006/main">
               <a:ext uri="{FF2B5EF4-FFF2-40B4-BE49-F238E27FC236}">
-                <a16:creationId xmlns:a16="http://schemas.microsoft.com/office/drawing/2014/main" id="{F9109B9C-AA6E-4AB9-B56C-EE3F3E6D8BDA}"/>
+                <a16:creationId xmlns:a16="http://schemas.microsoft.com/office/drawing/2014/main" id="{A4F90B96-5644-477A-9205-3EC9B0FEB10E}"/>
               </a:ext>
             </a:extLst>
           </p:cNvPr>
@@ -8723,7 +8723,7 @@
           <p:cNvPr id="16" name="보존할 것">
             <a:extLst xmlns:a="http://schemas.openxmlformats.org/drawingml/2006/main">
               <a:ext uri="{FF2B5EF4-FFF2-40B4-BE49-F238E27FC236}">
-                <a16:creationId xmlns:a16="http://schemas.microsoft.com/office/drawing/2014/main" id="{9CD8DA13-A441-4358-9130-DCB3A675A236}"/>
+                <a16:creationId xmlns:a16="http://schemas.microsoft.com/office/drawing/2014/main" id="{447FDEBD-B2C5-4AD8-8565-FF102CC6AC60}"/>
               </a:ext>
             </a:extLst>
           </p:cNvPr>
@@ -8881,7 +8881,7 @@
           <p:cNvPr id="17" name="">
             <a:extLst xmlns:a="http://schemas.openxmlformats.org/drawingml/2006/main">
               <a:ext uri="{FF2B5EF4-FFF2-40B4-BE49-F238E27FC236}">
-                <a16:creationId xmlns:a16="http://schemas.microsoft.com/office/drawing/2014/main" id="{B19516B2-CCB9-48BB-9188-603975EEBE9F}"/>
+                <a16:creationId xmlns:a16="http://schemas.microsoft.com/office/drawing/2014/main" id="{01CED3AC-0A87-4B94-8703-9FD8F25A3510}"/>
               </a:ext>
             </a:extLst>
           </p:cNvPr>
@@ -8912,7 +8912,7 @@
           <p:cNvPr id="18" name="무엇을 그대로 지킬까?">
             <a:extLst xmlns:a="http://schemas.openxmlformats.org/drawingml/2006/main">
               <a:ext uri="{FF2B5EF4-FFF2-40B4-BE49-F238E27FC236}">
-                <a16:creationId xmlns:a16="http://schemas.microsoft.com/office/drawing/2014/main" id="{98603425-3969-41BD-9254-D28D63C45224}"/>
+                <a16:creationId xmlns:a16="http://schemas.microsoft.com/office/drawing/2014/main" id="{B2C85058-1318-4145-A7EC-CFD1A9B79CDE}"/>
               </a:ext>
             </a:extLst>
           </p:cNvPr>
@@ -9070,7 +9070,7 @@
           <p:cNvPr id="19" name="?">
             <a:extLst xmlns:a="http://schemas.openxmlformats.org/drawingml/2006/main">
               <a:ext uri="{FF2B5EF4-FFF2-40B4-BE49-F238E27FC236}">
-                <a16:creationId xmlns:a16="http://schemas.microsoft.com/office/drawing/2014/main" id="{C1701E3D-80F3-42A7-9FF0-B042C6CA7823}"/>
+                <a16:creationId xmlns:a16="http://schemas.microsoft.com/office/drawing/2014/main" id="{DA987B66-469F-4826-AFDD-09E07100F9ED}"/>
               </a:ext>
             </a:extLst>
           </p:cNvPr>
@@ -9228,7 +9228,7 @@
           <p:cNvPr id="20" name="완료 근거">
             <a:extLst xmlns:a="http://schemas.openxmlformats.org/drawingml/2006/main">
               <a:ext uri="{FF2B5EF4-FFF2-40B4-BE49-F238E27FC236}">
-                <a16:creationId xmlns:a16="http://schemas.microsoft.com/office/drawing/2014/main" id="{7420593C-5007-47D2-9F44-AE99C71DD247}"/>
+                <a16:creationId xmlns:a16="http://schemas.microsoft.com/office/drawing/2014/main" id="{56581A56-CFE7-4ABB-9E8F-D78C2F26890C}"/>
               </a:ext>
             </a:extLst>
           </p:cNvPr>
@@ -9386,7 +9386,7 @@
           <p:cNvPr id="21" name="">
             <a:extLst xmlns:a="http://schemas.openxmlformats.org/drawingml/2006/main">
               <a:ext uri="{FF2B5EF4-FFF2-40B4-BE49-F238E27FC236}">
-                <a16:creationId xmlns:a16="http://schemas.microsoft.com/office/drawing/2014/main" id="{D25FC36A-0A6A-43CA-9869-7D38EB1C89DC}"/>
+                <a16:creationId xmlns:a16="http://schemas.microsoft.com/office/drawing/2014/main" id="{9206341A-3B6A-473E-81A2-DBB5A02C0A95}"/>
               </a:ext>
             </a:extLst>
           </p:cNvPr>
@@ -9417,7 +9417,7 @@
           <p:cNvPr id="22" name="무엇을 보면 끝났다고 할까?">
             <a:extLst xmlns:a="http://schemas.openxmlformats.org/drawingml/2006/main">
               <a:ext uri="{FF2B5EF4-FFF2-40B4-BE49-F238E27FC236}">
-                <a16:creationId xmlns:a16="http://schemas.microsoft.com/office/drawing/2014/main" id="{D2CECE9C-8E94-4C31-805F-095F90CCB78E}"/>
+                <a16:creationId xmlns:a16="http://schemas.microsoft.com/office/drawing/2014/main" id="{E0BE698D-ECB4-4C1D-9DDD-5A1713A28C96}"/>
               </a:ext>
             </a:extLst>
           </p:cNvPr>
@@ -9575,7 +9575,7 @@
           <p:cNvPr id="23" name="?">
             <a:extLst xmlns:a="http://schemas.openxmlformats.org/drawingml/2006/main">
               <a:ext uri="{FF2B5EF4-FFF2-40B4-BE49-F238E27FC236}">
-                <a16:creationId xmlns:a16="http://schemas.microsoft.com/office/drawing/2014/main" id="{A4AA632E-5581-4B13-97CF-4C30B94F1DD7}"/>
+                <a16:creationId xmlns:a16="http://schemas.microsoft.com/office/drawing/2014/main" id="{B47456E4-C161-4A79-9391-90355FBD76A8}"/>
               </a:ext>
             </a:extLst>
           </p:cNvPr>
@@ -9733,7 +9733,7 @@
           <p:cNvPr id="24" name="Legacy module connection">
             <a:extLst xmlns:a="http://schemas.openxmlformats.org/drawingml/2006/main">
               <a:ext uri="{FF2B5EF4-FFF2-40B4-BE49-F238E27FC236}">
-                <a16:creationId xmlns:a16="http://schemas.microsoft.com/office/drawing/2014/main" id="{E4A6841C-4CC1-4658-A186-1E635E5188AE}"/>
+                <a16:creationId xmlns:a16="http://schemas.microsoft.com/office/drawing/2014/main" id="{750E7412-76E5-4C95-B2BF-ECCD084CA199}"/>
               </a:ext>
             </a:extLst>
           </p:cNvPr>
@@ -9889,7 +9889,7 @@
     </p:spTree>
     <p:extLst>
       <p:ext uri="{BB962C8B-B14F-4D97-AF65-F5344CB8AC3E}">
-        <p14:creationId xmlns:p14="http://schemas.microsoft.com/office/powerpoint/2010/main" val="2037015405"/>
+        <p14:creationId xmlns:p14="http://schemas.microsoft.com/office/powerpoint/2010/main" val="1161578725"/>
       </p:ext>
     </p:extLst>
   </p:cSld>
@@ -9920,7 +9920,7 @@
           <p:cNvPr id="30" name="ACT 1 · 근거에 맞춰 말하기">
             <a:extLst xmlns:a="http://schemas.openxmlformats.org/drawingml/2006/main">
               <a:ext uri="{FF2B5EF4-FFF2-40B4-BE49-F238E27FC236}">
-                <a16:creationId xmlns:a16="http://schemas.microsoft.com/office/drawing/2014/main" id="{A685B8AA-71AB-4742-AE8A-F08F5087BC80}"/>
+                <a16:creationId xmlns:a16="http://schemas.microsoft.com/office/drawing/2014/main" id="{A4B10B2A-02E2-4212-BD44-55350E6B68AA}"/>
               </a:ext>
             </a:extLst>
           </p:cNvPr>
@@ -10075,10 +10075,10 @@
       </p:sp>
       <p:sp>
         <p:nvSpPr>
-          <p:cNvPr id="2" name="S19">
+          <p:cNvPr id="2" name="S20">
             <a:extLst xmlns:a="http://schemas.openxmlformats.org/drawingml/2006/main">
               <a:ext uri="{FF2B5EF4-FFF2-40B4-BE49-F238E27FC236}">
-                <a16:creationId xmlns:a16="http://schemas.microsoft.com/office/drawing/2014/main" id="{4CCB7FD2-3B4E-4F4E-AD5B-4B3004DCC3F3}"/>
+                <a16:creationId xmlns:a16="http://schemas.microsoft.com/office/drawing/2014/main" id="{CB5596EB-02C5-47FE-B72F-82E07515638B}"/>
               </a:ext>
             </a:extLst>
           </p:cNvPr>
@@ -10226,7 +10226,7 @@
                 <a:ea typeface="Malgun Gothic"/>
                 <a:cs typeface="Malgun Gothic"/>
               </a:rPr>
-              <a:t>S19</a:t>
+              <a:t>S20</a:t>
             </a:r>
           </a:p>
         </p:txBody>
@@ -10236,7 +10236,7 @@
           <p:cNvPr id="3" name="Check마다 확인하는 범위">
             <a:extLst xmlns:a="http://schemas.openxmlformats.org/drawingml/2006/main">
               <a:ext uri="{FF2B5EF4-FFF2-40B4-BE49-F238E27FC236}">
-                <a16:creationId xmlns:a16="http://schemas.microsoft.com/office/drawing/2014/main" id="{120776EA-D0DD-4137-8294-8A1C2C600AE5}"/>
+                <a16:creationId xmlns:a16="http://schemas.microsoft.com/office/drawing/2014/main" id="{5884E49C-1542-4894-BA1D-BADEC3C429D5}"/>
               </a:ext>
             </a:extLst>
           </p:cNvPr>
@@ -10394,7 +10394,7 @@
           <p:cNvPr id="4" name="">
             <a:extLst xmlns:a="http://schemas.openxmlformats.org/drawingml/2006/main">
               <a:ext uri="{FF2B5EF4-FFF2-40B4-BE49-F238E27FC236}">
-                <a16:creationId xmlns:a16="http://schemas.microsoft.com/office/drawing/2014/main" id="{7D1C9104-7065-47BA-B26C-B4D2DA8B15A0}"/>
+                <a16:creationId xmlns:a16="http://schemas.microsoft.com/office/drawing/2014/main" id="{8310CF5A-C69D-4249-9379-32A24D80204C}"/>
               </a:ext>
             </a:extLst>
           </p:cNvPr>
@@ -10425,7 +10425,7 @@
           <p:cNvPr id="5" name="TRIAL-002 실제 확인: 집중·전체 테스트 / CLI smoke / diff · 검사 비교는 교육용 재">
             <a:extLst xmlns:a="http://schemas.openxmlformats.org/drawingml/2006/main">
               <a:ext uri="{FF2B5EF4-FFF2-40B4-BE49-F238E27FC236}">
-                <a16:creationId xmlns:a16="http://schemas.microsoft.com/office/drawing/2014/main" id="{A789782F-8D0E-42EB-9905-750142904917}"/>
+                <a16:creationId xmlns:a16="http://schemas.microsoft.com/office/drawing/2014/main" id="{4B3ABF7C-867B-4F09-A001-E718AC9B6A5C}"/>
               </a:ext>
             </a:extLst>
           </p:cNvPr>
@@ -10583,7 +10583,7 @@
           <p:cNvPr id="6" name="Benchmark는 이 Trial에서 미실행. 검사 비교는 새 테스트 실행이나 PASS 결과가 아닙니다.">
             <a:extLst xmlns:a="http://schemas.openxmlformats.org/drawingml/2006/main">
               <a:ext uri="{FF2B5EF4-FFF2-40B4-BE49-F238E27FC236}">
-                <a16:creationId xmlns:a16="http://schemas.microsoft.com/office/drawing/2014/main" id="{0E7A6503-09AE-4C53-B7A8-D41E51D06E30}"/>
+                <a16:creationId xmlns:a16="http://schemas.microsoft.com/office/drawing/2014/main" id="{F41D3E31-C086-49B0-B41F-D40DE48EE6F3}"/>
               </a:ext>
             </a:extLst>
           </p:cNvPr>
@@ -10741,7 +10741,7 @@
           <p:cNvPr id="7" name="확인 방법">
             <a:extLst xmlns:a="http://schemas.openxmlformats.org/drawingml/2006/main">
               <a:ext uri="{FF2B5EF4-FFF2-40B4-BE49-F238E27FC236}">
-                <a16:creationId xmlns:a16="http://schemas.microsoft.com/office/drawing/2014/main" id="{2A2B88F9-10D8-4022-A8C7-23A812536A58}"/>
+                <a16:creationId xmlns:a16="http://schemas.microsoft.com/office/drawing/2014/main" id="{02D14D0C-93E3-44E4-9BC5-A08CFD90B318}"/>
               </a:ext>
             </a:extLst>
           </p:cNvPr>
@@ -10899,7 +10899,7 @@
           <p:cNvPr id="8" name="말할 수 있는 범위">
             <a:extLst xmlns:a="http://schemas.openxmlformats.org/drawingml/2006/main">
               <a:ext uri="{FF2B5EF4-FFF2-40B4-BE49-F238E27FC236}">
-                <a16:creationId xmlns:a16="http://schemas.microsoft.com/office/drawing/2014/main" id="{6BE54089-1EBF-4299-9483-71C0C3FF5241}"/>
+                <a16:creationId xmlns:a16="http://schemas.microsoft.com/office/drawing/2014/main" id="{D3E2C784-C1C8-4E0B-A2E9-F5B149F2EBEF}"/>
               </a:ext>
             </a:extLst>
           </p:cNvPr>
@@ -11057,7 +11057,7 @@
           <p:cNvPr id="9" name="">
             <a:extLst xmlns:a="http://schemas.openxmlformats.org/drawingml/2006/main">
               <a:ext uri="{FF2B5EF4-FFF2-40B4-BE49-F238E27FC236}">
-                <a16:creationId xmlns:a16="http://schemas.microsoft.com/office/drawing/2014/main" id="{9E149DE7-5318-40DD-863E-8652A7F23118}"/>
+                <a16:creationId xmlns:a16="http://schemas.microsoft.com/office/drawing/2014/main" id="{553244FD-772C-4F5E-941C-D9C1246FA67F}"/>
               </a:ext>
             </a:extLst>
           </p:cNvPr>
@@ -11088,7 +11088,7 @@
           <p:cNvPr id="10" name="집중 테스트">
             <a:extLst xmlns:a="http://schemas.openxmlformats.org/drawingml/2006/main">
               <a:ext uri="{FF2B5EF4-FFF2-40B4-BE49-F238E27FC236}">
-                <a16:creationId xmlns:a16="http://schemas.microsoft.com/office/drawing/2014/main" id="{37C6AC7B-14AC-4710-9A14-34DD8A59855F}"/>
+                <a16:creationId xmlns:a16="http://schemas.microsoft.com/office/drawing/2014/main" id="{93190D5D-AEB4-49E3-A9B8-A94ACD06A4B9}"/>
               </a:ext>
             </a:extLst>
           </p:cNvPr>
@@ -11246,7 +11246,7 @@
           <p:cNvPr id="11" name="바뀐 동작의 해당 테스트 조건">
             <a:extLst xmlns:a="http://schemas.openxmlformats.org/drawingml/2006/main">
               <a:ext uri="{FF2B5EF4-FFF2-40B4-BE49-F238E27FC236}">
-                <a16:creationId xmlns:a16="http://schemas.microsoft.com/office/drawing/2014/main" id="{FB7E9644-3614-48A7-9FCD-A60BA565D3AF}"/>
+                <a16:creationId xmlns:a16="http://schemas.microsoft.com/office/drawing/2014/main" id="{6BC186D4-6C2F-42C9-8BD7-B0DAF3563EB6}"/>
               </a:ext>
             </a:extLst>
           </p:cNvPr>
@@ -11404,7 +11404,7 @@
           <p:cNvPr id="12" name="">
             <a:extLst xmlns:a="http://schemas.openxmlformats.org/drawingml/2006/main">
               <a:ext uri="{FF2B5EF4-FFF2-40B4-BE49-F238E27FC236}">
-                <a16:creationId xmlns:a16="http://schemas.microsoft.com/office/drawing/2014/main" id="{C283C04A-C167-4902-80D2-BBAB56720C72}"/>
+                <a16:creationId xmlns:a16="http://schemas.microsoft.com/office/drawing/2014/main" id="{28133E29-0121-47B3-96B4-CB7DA1E76D88}"/>
               </a:ext>
             </a:extLst>
           </p:cNvPr>
@@ -11435,7 +11435,7 @@
           <p:cNvPr id="13" name="전체 테스트">
             <a:extLst xmlns:a="http://schemas.openxmlformats.org/drawingml/2006/main">
               <a:ext uri="{FF2B5EF4-FFF2-40B4-BE49-F238E27FC236}">
-                <a16:creationId xmlns:a16="http://schemas.microsoft.com/office/drawing/2014/main" id="{B729417F-5279-456A-85BE-574168EF48DA}"/>
+                <a16:creationId xmlns:a16="http://schemas.microsoft.com/office/drawing/2014/main" id="{3074007A-180D-473F-B41C-2D5FAE59E5A0}"/>
               </a:ext>
             </a:extLst>
           </p:cNvPr>
@@ -11593,7 +11593,7 @@
           <p:cNvPr id="14" name="현재 suite에 담긴 회귀 범위">
             <a:extLst xmlns:a="http://schemas.openxmlformats.org/drawingml/2006/main">
               <a:ext uri="{FF2B5EF4-FFF2-40B4-BE49-F238E27FC236}">
-                <a16:creationId xmlns:a16="http://schemas.microsoft.com/office/drawing/2014/main" id="{2BA25D6B-3E31-487B-84D3-98F1B39F912A}"/>
+                <a16:creationId xmlns:a16="http://schemas.microsoft.com/office/drawing/2014/main" id="{5F188631-91FF-4BE2-9077-E4D970E442A5}"/>
               </a:ext>
             </a:extLst>
           </p:cNvPr>
@@ -11751,7 +11751,7 @@
           <p:cNvPr id="15" name="">
             <a:extLst xmlns:a="http://schemas.openxmlformats.org/drawingml/2006/main">
               <a:ext uri="{FF2B5EF4-FFF2-40B4-BE49-F238E27FC236}">
-                <a16:creationId xmlns:a16="http://schemas.microsoft.com/office/drawing/2014/main" id="{4E184D3E-11F2-4541-9ACF-FAE0A29896D2}"/>
+                <a16:creationId xmlns:a16="http://schemas.microsoft.com/office/drawing/2014/main" id="{716D439A-60F1-4B1C-B73E-ED58AEBB5039}"/>
               </a:ext>
             </a:extLst>
           </p:cNvPr>
@@ -11782,7 +11782,7 @@
           <p:cNvPr id="16" name="CLI smoke">
             <a:extLst xmlns:a="http://schemas.openxmlformats.org/drawingml/2006/main">
               <a:ext uri="{FF2B5EF4-FFF2-40B4-BE49-F238E27FC236}">
-                <a16:creationId xmlns:a16="http://schemas.microsoft.com/office/drawing/2014/main" id="{4262FA4F-E290-4168-94F8-0DDED6B176DD}"/>
+                <a16:creationId xmlns:a16="http://schemas.microsoft.com/office/drawing/2014/main" id="{03D8D061-4D08-4A41-AAC2-502FCD5FB873}"/>
               </a:ext>
             </a:extLst>
           </p:cNvPr>
@@ -11940,7 +11940,7 @@
           <p:cNvPr id="17" name="샘플 입력의 통합 실행 경로">
             <a:extLst xmlns:a="http://schemas.openxmlformats.org/drawingml/2006/main">
               <a:ext uri="{FF2B5EF4-FFF2-40B4-BE49-F238E27FC236}">
-                <a16:creationId xmlns:a16="http://schemas.microsoft.com/office/drawing/2014/main" id="{B0C8C324-B63E-4D08-A90F-9256BE4AE573}"/>
+                <a16:creationId xmlns:a16="http://schemas.microsoft.com/office/drawing/2014/main" id="{CEF1FCE4-DAB0-4CCE-AB05-ACEA378D8D32}"/>
               </a:ext>
             </a:extLst>
           </p:cNvPr>
@@ -12098,7 +12098,7 @@
           <p:cNvPr id="18" name="">
             <a:extLst xmlns:a="http://schemas.openxmlformats.org/drawingml/2006/main">
               <a:ext uri="{FF2B5EF4-FFF2-40B4-BE49-F238E27FC236}">
-                <a16:creationId xmlns:a16="http://schemas.microsoft.com/office/drawing/2014/main" id="{68C6B0E8-0204-4A56-8423-7D2B6A91E90A}"/>
+                <a16:creationId xmlns:a16="http://schemas.microsoft.com/office/drawing/2014/main" id="{E0533FA1-7753-4AE2-A882-E1DD5060517E}"/>
               </a:ext>
             </a:extLst>
           </p:cNvPr>
@@ -12129,7 +12129,7 @@
           <p:cNvPr id="19" name="diff 검토">
             <a:extLst xmlns:a="http://schemas.openxmlformats.org/drawingml/2006/main">
               <a:ext uri="{FF2B5EF4-FFF2-40B4-BE49-F238E27FC236}">
-                <a16:creationId xmlns:a16="http://schemas.microsoft.com/office/drawing/2014/main" id="{F0C2FF39-1238-4649-88B0-62B3BE7C56DD}"/>
+                <a16:creationId xmlns:a16="http://schemas.microsoft.com/office/drawing/2014/main" id="{0A9D22A7-F0C5-4ECE-950F-6E12A26E3C0F}"/>
               </a:ext>
             </a:extLst>
           </p:cNvPr>
@@ -12287,7 +12287,7 @@
           <p:cNvPr id="20" name="변경 범위와 의도하지 않은 수정">
             <a:extLst xmlns:a="http://schemas.openxmlformats.org/drawingml/2006/main">
               <a:ext uri="{FF2B5EF4-FFF2-40B4-BE49-F238E27FC236}">
-                <a16:creationId xmlns:a16="http://schemas.microsoft.com/office/drawing/2014/main" id="{D0D9638B-448E-4820-BC4A-8B9CF56D8D37}"/>
+                <a16:creationId xmlns:a16="http://schemas.microsoft.com/office/drawing/2014/main" id="{CFEBD9D5-D73E-488E-AF0B-624B4FF669F7}"/>
               </a:ext>
             </a:extLst>
           </p:cNvPr>
@@ -12445,7 +12445,7 @@
           <p:cNvPr id="21" name="">
             <a:extLst xmlns:a="http://schemas.openxmlformats.org/drawingml/2006/main">
               <a:ext uri="{FF2B5EF4-FFF2-40B4-BE49-F238E27FC236}">
-                <a16:creationId xmlns:a16="http://schemas.microsoft.com/office/drawing/2014/main" id="{A02C5A21-17A2-4694-B0BA-12A89385B32C}"/>
+                <a16:creationId xmlns:a16="http://schemas.microsoft.com/office/drawing/2014/main" id="{970D50F5-5EBD-4EE1-A5AB-6702726C00E4}"/>
               </a:ext>
             </a:extLst>
           </p:cNvPr>
@@ -12476,7 +12476,7 @@
           <p:cNvPr id="22" name="성능 측정">
             <a:extLst xmlns:a="http://schemas.openxmlformats.org/drawingml/2006/main">
               <a:ext uri="{FF2B5EF4-FFF2-40B4-BE49-F238E27FC236}">
-                <a16:creationId xmlns:a16="http://schemas.microsoft.com/office/drawing/2014/main" id="{BF281158-6C5D-4C62-8D84-FE4B5AA733E9}"/>
+                <a16:creationId xmlns:a16="http://schemas.microsoft.com/office/drawing/2014/main" id="{3E16FC2E-1F1D-4E8A-ACA3-B15EA57F3ABF}"/>
               </a:ext>
             </a:extLst>
           </p:cNvPr>
@@ -12634,7 +12634,7 @@
           <p:cNvPr id="23" name="측정한 입력·환경에서의 성능">
             <a:extLst xmlns:a="http://schemas.openxmlformats.org/drawingml/2006/main">
               <a:ext uri="{FF2B5EF4-FFF2-40B4-BE49-F238E27FC236}">
-                <a16:creationId xmlns:a16="http://schemas.microsoft.com/office/drawing/2014/main" id="{E14C2E66-25F2-42FF-9499-5B79F0C6F0D1}"/>
+                <a16:creationId xmlns:a16="http://schemas.microsoft.com/office/drawing/2014/main" id="{F132DCCA-471A-4E51-9C05-9A66143AC1D1}"/>
               </a:ext>
             </a:extLst>
           </p:cNvPr>
@@ -12792,7 +12792,7 @@
           <p:cNvPr id="24" name="4열 입력 · crop 1 3의 끝 좌표 계약을 확인한다면">
             <a:extLst xmlns:a="http://schemas.openxmlformats.org/drawingml/2006/main">
               <a:ext uri="{FF2B5EF4-FFF2-40B4-BE49-F238E27FC236}">
-                <a16:creationId xmlns:a16="http://schemas.microsoft.com/office/drawing/2014/main" id="{E7D1F263-262B-47B8-A103-83091824390A}"/>
+                <a16:creationId xmlns:a16="http://schemas.microsoft.com/office/drawing/2014/main" id="{C5A93BD5-5D0E-4108-806E-5E0860BBF8DD}"/>
               </a:ext>
             </a:extLst>
           </p:cNvPr>
@@ -12950,7 +12950,7 @@
           <p:cNvPr id="25" name="비어 있지 않음">
             <a:extLst xmlns:a="http://schemas.openxmlformats.org/drawingml/2006/main">
               <a:ext uri="{FF2B5EF4-FFF2-40B4-BE49-F238E27FC236}">
-                <a16:creationId xmlns:a16="http://schemas.microsoft.com/office/drawing/2014/main" id="{7EC547BA-1EDF-49D9-AE0F-B733201050BF}"/>
+                <a16:creationId xmlns:a16="http://schemas.microsoft.com/office/drawing/2014/main" id="{4AAAA94B-1EC2-48E3-B0D1-3CE6A70794DE}"/>
               </a:ext>
             </a:extLst>
           </p:cNvPr>
@@ -13108,7 +13108,7 @@
           <p:cNvPr id="26" name="잘못된 3열 결과도 만족할 수 있음">
             <a:extLst xmlns:a="http://schemas.openxmlformats.org/drawingml/2006/main">
               <a:ext uri="{FF2B5EF4-FFF2-40B4-BE49-F238E27FC236}">
-                <a16:creationId xmlns:a16="http://schemas.microsoft.com/office/drawing/2014/main" id="{EB75D642-AAA3-409B-8DAD-8826CC9549F1}"/>
+                <a16:creationId xmlns:a16="http://schemas.microsoft.com/office/drawing/2014/main" id="{9E50D441-40CC-42CA-BEC5-B3EF8BB0E20B}"/>
               </a:ext>
             </a:extLst>
           </p:cNvPr>
@@ -13266,7 +13266,7 @@
           <p:cNvPr id="27" name="원본 열 1·2, 폭 2">
             <a:extLst xmlns:a="http://schemas.openxmlformats.org/drawingml/2006/main">
               <a:ext uri="{FF2B5EF4-FFF2-40B4-BE49-F238E27FC236}">
-                <a16:creationId xmlns:a16="http://schemas.microsoft.com/office/drawing/2014/main" id="{83F1F6CD-E316-4684-BE76-921FACE97B3E}"/>
+                <a16:creationId xmlns:a16="http://schemas.microsoft.com/office/drawing/2014/main" id="{027E7FA3-D7FE-4302-9DD6-CF21C14C7FBE}"/>
               </a:ext>
             </a:extLst>
           </p:cNvPr>
@@ -13424,7 +13424,7 @@
           <p:cNvPr id="28" name="끝 좌표 제외 계약을 직접 확인">
             <a:extLst xmlns:a="http://schemas.openxmlformats.org/drawingml/2006/main">
               <a:ext uri="{FF2B5EF4-FFF2-40B4-BE49-F238E27FC236}">
-                <a16:creationId xmlns:a16="http://schemas.microsoft.com/office/drawing/2014/main" id="{1D83D2E1-2E95-49DA-8349-EEB8A7B9B4C4}"/>
+                <a16:creationId xmlns:a16="http://schemas.microsoft.com/office/drawing/2014/main" id="{BF13FD10-E9C9-4895-AFC6-0FC71FDAD6AF}"/>
               </a:ext>
             </a:extLst>
           </p:cNvPr>
@@ -13582,7 +13582,7 @@
           <p:cNvPr id="29" name="Legacy module connection">
             <a:extLst xmlns:a="http://schemas.openxmlformats.org/drawingml/2006/main">
               <a:ext uri="{FF2B5EF4-FFF2-40B4-BE49-F238E27FC236}">
-                <a16:creationId xmlns:a16="http://schemas.microsoft.com/office/drawing/2014/main" id="{F2C2F5CA-5FE8-4C19-AEEE-F76A53F90E64}"/>
+                <a16:creationId xmlns:a16="http://schemas.microsoft.com/office/drawing/2014/main" id="{29214940-8499-46DC-B4C5-5C6132D0898B}"/>
               </a:ext>
             </a:extLst>
           </p:cNvPr>
@@ -13738,7 +13738,7 @@
     </p:spTree>
     <p:extLst>
       <p:ext uri="{BB962C8B-B14F-4D97-AF65-F5344CB8AC3E}">
-        <p14:creationId xmlns:p14="http://schemas.microsoft.com/office/powerpoint/2010/main" val="1484673958"/>
+        <p14:creationId xmlns:p14="http://schemas.microsoft.com/office/powerpoint/2010/main" val="2042461433"/>
       </p:ext>
     </p:extLst>
   </p:cSld>
@@ -13769,7 +13769,7 @@
           <p:cNvPr id="14" name="ACT 1 · 반복해서 쓰는 정보 돌아보기">
             <a:extLst xmlns:a="http://schemas.openxmlformats.org/drawingml/2006/main">
               <a:ext uri="{FF2B5EF4-FFF2-40B4-BE49-F238E27FC236}">
-                <a16:creationId xmlns:a16="http://schemas.microsoft.com/office/drawing/2014/main" id="{86754EA9-7EE2-4547-9B78-ACD80585A360}"/>
+                <a16:creationId xmlns:a16="http://schemas.microsoft.com/office/drawing/2014/main" id="{E40D9020-F65B-4A28-899F-AE3EB4D7D336}"/>
               </a:ext>
             </a:extLst>
           </p:cNvPr>
@@ -13924,10 +13924,10 @@
       </p:sp>
       <p:sp>
         <p:nvSpPr>
-          <p:cNvPr id="2" name="S20">
+          <p:cNvPr id="2" name="S21">
             <a:extLst xmlns:a="http://schemas.openxmlformats.org/drawingml/2006/main">
               <a:ext uri="{FF2B5EF4-FFF2-40B4-BE49-F238E27FC236}">
-                <a16:creationId xmlns:a16="http://schemas.microsoft.com/office/drawing/2014/main" id="{28AF44DF-D1A3-4FFD-AB8F-AB7A8FA1E4A0}"/>
+                <a16:creationId xmlns:a16="http://schemas.microsoft.com/office/drawing/2014/main" id="{012F9381-2D36-41A4-B20A-417D5122614A}"/>
               </a:ext>
             </a:extLst>
           </p:cNvPr>
@@ -14075,7 +14075,7 @@
                 <a:ea typeface="Malgun Gothic"/>
                 <a:cs typeface="Malgun Gothic"/>
               </a:rPr>
-              <a:t>S20</a:t>
+              <a:t>S21</a:t>
             </a:r>
           </a:p>
         </p:txBody>
@@ -14085,7 +14085,7 @@
           <p:cNvPr id="3" name="이번 Task인가,&#10;계속 유지할 Project 정보인가?">
             <a:extLst xmlns:a="http://schemas.openxmlformats.org/drawingml/2006/main">
               <a:ext uri="{FF2B5EF4-FFF2-40B4-BE49-F238E27FC236}">
-                <a16:creationId xmlns:a16="http://schemas.microsoft.com/office/drawing/2014/main" id="{F6DC7D97-4449-4C50-8D6F-919A9834D9C2}"/>
+                <a16:creationId xmlns:a16="http://schemas.microsoft.com/office/drawing/2014/main" id="{F76949F9-E6DE-4BE7-A309-79636A36BE91}"/>
               </a:ext>
             </a:extLst>
           </p:cNvPr>
@@ -14266,7 +14266,7 @@
           <p:cNvPr id="4" name="">
             <a:extLst xmlns:a="http://schemas.openxmlformats.org/drawingml/2006/main">
               <a:ext uri="{FF2B5EF4-FFF2-40B4-BE49-F238E27FC236}">
-                <a16:creationId xmlns:a16="http://schemas.microsoft.com/office/drawing/2014/main" id="{AABB82A9-4DA0-430E-86AC-76D10E33BBB5}"/>
+                <a16:creationId xmlns:a16="http://schemas.microsoft.com/office/drawing/2014/main" id="{1878DB88-90D0-4A68-8D45-4BB6B9BCEAA7}"/>
               </a:ext>
             </a:extLst>
           </p:cNvPr>
@@ -14297,7 +14297,7 @@
           <p:cNvPr id="5" name="생각해 보기 · 이 과정의 교육 모델">
             <a:extLst xmlns:a="http://schemas.openxmlformats.org/drawingml/2006/main">
               <a:ext uri="{FF2B5EF4-FFF2-40B4-BE49-F238E27FC236}">
-                <a16:creationId xmlns:a16="http://schemas.microsoft.com/office/drawing/2014/main" id="{BFF6D7F7-DC68-4371-ADFC-B1D11BDEDDAD}"/>
+                <a16:creationId xmlns:a16="http://schemas.microsoft.com/office/drawing/2014/main" id="{11C135C6-43AC-4BD1-8894-6FAC50C4D354}"/>
               </a:ext>
             </a:extLst>
           </p:cNvPr>
@@ -14455,7 +14455,7 @@
           <p:cNvPr id="6" name="1분 동안 개인적으로 생각한 뒤 2분간 자발적인 질문을 받습니다.">
             <a:extLst xmlns:a="http://schemas.openxmlformats.org/drawingml/2006/main">
               <a:ext uri="{FF2B5EF4-FFF2-40B4-BE49-F238E27FC236}">
-                <a16:creationId xmlns:a16="http://schemas.microsoft.com/office/drawing/2014/main" id="{43D88B81-69B0-4DA8-AA67-E5B0D2D244E5}"/>
+                <a16:creationId xmlns:a16="http://schemas.microsoft.com/office/drawing/2014/main" id="{7595591F-865D-4D25-ADD0-8D502F70395D}"/>
               </a:ext>
             </a:extLst>
           </p:cNvPr>
@@ -14613,7 +14613,7 @@
           <p:cNvPr id="7" name="테스트·보존 조건처럼, 반복해서 쓴 문장을 떠올려 보세요.">
             <a:extLst xmlns:a="http://schemas.openxmlformats.org/drawingml/2006/main">
               <a:ext uri="{FF2B5EF4-FFF2-40B4-BE49-F238E27FC236}">
-                <a16:creationId xmlns:a16="http://schemas.microsoft.com/office/drawing/2014/main" id="{4C189D8C-D475-451D-9185-7F5E31526D90}"/>
+                <a16:creationId xmlns:a16="http://schemas.microsoft.com/office/drawing/2014/main" id="{2173501F-1DA5-4FB0-831C-64E2647B3831}"/>
               </a:ext>
             </a:extLst>
           </p:cNvPr>
@@ -14771,7 +14771,7 @@
           <p:cNvPr id="8" name="이번 작업에만?">
             <a:extLst xmlns:a="http://schemas.openxmlformats.org/drawingml/2006/main">
               <a:ext uri="{FF2B5EF4-FFF2-40B4-BE49-F238E27FC236}">
-                <a16:creationId xmlns:a16="http://schemas.microsoft.com/office/drawing/2014/main" id="{9BA00267-4872-4992-8678-E5FE288B670E}"/>
+                <a16:creationId xmlns:a16="http://schemas.microsoft.com/office/drawing/2014/main" id="{9C45E225-0524-48A7-BCA7-6D7D8AA2BC6D}"/>
               </a:ext>
             </a:extLst>
           </p:cNvPr>
@@ -14929,7 +14929,7 @@
           <p:cNvPr id="9" name="다음 작업에도?">
             <a:extLst xmlns:a="http://schemas.openxmlformats.org/drawingml/2006/main">
               <a:ext uri="{FF2B5EF4-FFF2-40B4-BE49-F238E27FC236}">
-                <a16:creationId xmlns:a16="http://schemas.microsoft.com/office/drawing/2014/main" id="{65C355C8-820B-401B-A918-213CCD6608CB}"/>
+                <a16:creationId xmlns:a16="http://schemas.microsoft.com/office/drawing/2014/main" id="{BB501C8C-F1BD-4D22-8E97-F09E31B25733}"/>
               </a:ext>
             </a:extLst>
           </p:cNvPr>
@@ -15087,7 +15087,7 @@
           <p:cNvPr id="10" name="">
             <a:extLst xmlns:a="http://schemas.openxmlformats.org/drawingml/2006/main">
               <a:ext uri="{FF2B5EF4-FFF2-40B4-BE49-F238E27FC236}">
-                <a16:creationId xmlns:a16="http://schemas.microsoft.com/office/drawing/2014/main" id="{D22F5D9A-5DAA-4E10-84BE-DD8C9EC1DC0B}"/>
+                <a16:creationId xmlns:a16="http://schemas.microsoft.com/office/drawing/2014/main" id="{AD89280A-25F7-4775-8A32-A2A49192FE65}"/>
               </a:ext>
             </a:extLst>
           </p:cNvPr>
@@ -15118,7 +15118,7 @@
           <p:cNvPr id="11" name="">
             <a:extLst xmlns:a="http://schemas.openxmlformats.org/drawingml/2006/main">
               <a:ext uri="{FF2B5EF4-FFF2-40B4-BE49-F238E27FC236}">
-                <a16:creationId xmlns:a16="http://schemas.microsoft.com/office/drawing/2014/main" id="{2F04EF33-E70F-4195-936C-371FBFAAF809}"/>
+                <a16:creationId xmlns:a16="http://schemas.microsoft.com/office/drawing/2014/main" id="{B0AD5EFF-A9B3-4B05-AD3D-20B5B595B0FD}"/>
               </a:ext>
             </a:extLst>
           </p:cNvPr>
@@ -15149,7 +15149,7 @@
           <p:cNvPr id="12" name="어떤 정보가 계속 남아 있어야 할까요?">
             <a:extLst xmlns:a="http://schemas.openxmlformats.org/drawingml/2006/main">
               <a:ext uri="{FF2B5EF4-FFF2-40B4-BE49-F238E27FC236}">
-                <a16:creationId xmlns:a16="http://schemas.microsoft.com/office/drawing/2014/main" id="{21AC7123-86EA-4C07-8935-03F90DCFF8FB}"/>
+                <a16:creationId xmlns:a16="http://schemas.microsoft.com/office/drawing/2014/main" id="{13514232-A19F-41DF-A4EB-FA04BBE5BC95}"/>
               </a:ext>
             </a:extLst>
           </p:cNvPr>
@@ -15307,7 +15307,7 @@
           <p:cNvPr id="13" name="Legacy module connection">
             <a:extLst xmlns:a="http://schemas.openxmlformats.org/drawingml/2006/main">
               <a:ext uri="{FF2B5EF4-FFF2-40B4-BE49-F238E27FC236}">
-                <a16:creationId xmlns:a16="http://schemas.microsoft.com/office/drawing/2014/main" id="{913D78E0-B60D-4D0A-BB7F-88F5A9A9C61A}"/>
+                <a16:creationId xmlns:a16="http://schemas.microsoft.com/office/drawing/2014/main" id="{B8C15E56-B324-4936-833B-1716A8D3DAA0}"/>
               </a:ext>
             </a:extLst>
           </p:cNvPr>
@@ -15463,7 +15463,7 @@
     </p:spTree>
     <p:extLst>
       <p:ext uri="{BB962C8B-B14F-4D97-AF65-F5344CB8AC3E}">
-        <p14:creationId xmlns:p14="http://schemas.microsoft.com/office/powerpoint/2010/main" val="670699165"/>
+        <p14:creationId xmlns:p14="http://schemas.microsoft.com/office/powerpoint/2010/main" val="1802862958"/>
       </p:ext>
     </p:extLst>
   </p:cSld>
@@ -15494,7 +15494,7 @@
           <p:cNvPr id="17" name="ACT 1 · 정보의 수명과 범위">
             <a:extLst xmlns:a="http://schemas.openxmlformats.org/drawingml/2006/main">
               <a:ext uri="{FF2B5EF4-FFF2-40B4-BE49-F238E27FC236}">
-                <a16:creationId xmlns:a16="http://schemas.microsoft.com/office/drawing/2014/main" id="{94379F3C-ABE8-4073-9169-1AD44B10D050}"/>
+                <a16:creationId xmlns:a16="http://schemas.microsoft.com/office/drawing/2014/main" id="{FFC502E7-BC2E-408B-9750-F15286034EF2}"/>
               </a:ext>
             </a:extLst>
           </p:cNvPr>
@@ -15649,10 +15649,10 @@
       </p:sp>
       <p:sp>
         <p:nvSpPr>
-          <p:cNvPr id="2" name="S21">
+          <p:cNvPr id="2" name="S22">
             <a:extLst xmlns:a="http://schemas.openxmlformats.org/drawingml/2006/main">
               <a:ext uri="{FF2B5EF4-FFF2-40B4-BE49-F238E27FC236}">
-                <a16:creationId xmlns:a16="http://schemas.microsoft.com/office/drawing/2014/main" id="{861C4361-434F-42B1-A2D3-84DECCA4A783}"/>
+                <a16:creationId xmlns:a16="http://schemas.microsoft.com/office/drawing/2014/main" id="{64D23824-3648-48E1-9586-5840241C44E3}"/>
               </a:ext>
             </a:extLst>
           </p:cNvPr>
@@ -15800,7 +15800,7 @@
                 <a:ea typeface="Malgun Gothic"/>
                 <a:cs typeface="Malgun Gothic"/>
               </a:rPr>
-              <a:t>S21</a:t>
+              <a:t>S22</a:t>
             </a:r>
           </a:p>
         </p:txBody>
@@ -15810,7 +15810,7 @@
           <p:cNvPr id="3" name="반복하는 설명을 두 범주로 나누기">
             <a:extLst xmlns:a="http://schemas.openxmlformats.org/drawingml/2006/main">
               <a:ext uri="{FF2B5EF4-FFF2-40B4-BE49-F238E27FC236}">
-                <a16:creationId xmlns:a16="http://schemas.microsoft.com/office/drawing/2014/main" id="{98D1A684-2B97-44EB-AE36-EAF22C1B15C7}"/>
+                <a16:creationId xmlns:a16="http://schemas.microsoft.com/office/drawing/2014/main" id="{456E07F5-ADC0-4464-BC55-9C17999C1E94}"/>
               </a:ext>
             </a:extLst>
           </p:cNvPr>
@@ -15968,7 +15968,7 @@
           <p:cNvPr id="4" name="">
             <a:extLst xmlns:a="http://schemas.openxmlformats.org/drawingml/2006/main">
               <a:ext uri="{FF2B5EF4-FFF2-40B4-BE49-F238E27FC236}">
-                <a16:creationId xmlns:a16="http://schemas.microsoft.com/office/drawing/2014/main" id="{160FD8DD-F24C-4230-8291-E1D9A3BC3BDA}"/>
+                <a16:creationId xmlns:a16="http://schemas.microsoft.com/office/drawing/2014/main" id="{CFF5D136-64C5-4C43-96DC-69E21875BB0D}"/>
               </a:ext>
             </a:extLst>
           </p:cNvPr>
@@ -15999,7 +15999,7 @@
           <p:cNvPr id="5" name="교육용 후보 예시 · 모든 프로젝트에 적용되는 유일한 분류가 아님">
             <a:extLst xmlns:a="http://schemas.openxmlformats.org/drawingml/2006/main">
               <a:ext uri="{FF2B5EF4-FFF2-40B4-BE49-F238E27FC236}">
-                <a16:creationId xmlns:a16="http://schemas.microsoft.com/office/drawing/2014/main" id="{90790662-918D-49F4-90D3-9D7EE7C83D50}"/>
+                <a16:creationId xmlns:a16="http://schemas.microsoft.com/office/drawing/2014/main" id="{B0018884-D87B-4C35-B273-87C33D8D0466}"/>
               </a:ext>
             </a:extLst>
           </p:cNvPr>
@@ -16157,7 +16157,7 @@
           <p:cNvPr id="6" name="다음 질문: Project 정보를 왜 매번 Prompt에 다시 적고 있을까요?">
             <a:extLst xmlns:a="http://schemas.openxmlformats.org/drawingml/2006/main">
               <a:ext uri="{FF2B5EF4-FFF2-40B4-BE49-F238E27FC236}">
-                <a16:creationId xmlns:a16="http://schemas.microsoft.com/office/drawing/2014/main" id="{9C6509D8-83AA-4AC8-90EC-7D5B04E78DCB}"/>
+                <a16:creationId xmlns:a16="http://schemas.microsoft.com/office/drawing/2014/main" id="{B18468AD-1991-4981-9FCB-43328BA943C8}"/>
               </a:ext>
             </a:extLst>
           </p:cNvPr>
@@ -16315,7 +16315,7 @@
           <p:cNvPr id="7" name="이번 Task">
             <a:extLst xmlns:a="http://schemas.openxmlformats.org/drawingml/2006/main">
               <a:ext uri="{FF2B5EF4-FFF2-40B4-BE49-F238E27FC236}">
-                <a16:creationId xmlns:a16="http://schemas.microsoft.com/office/drawing/2014/main" id="{F5AB23EE-8E37-47B2-A7D9-19B3AB63E098}"/>
+                <a16:creationId xmlns:a16="http://schemas.microsoft.com/office/drawing/2014/main" id="{B2450AE2-2672-448D-903A-755E39036DBE}"/>
               </a:ext>
             </a:extLst>
           </p:cNvPr>
@@ -16473,7 +16473,7 @@
           <p:cNvPr id="8" name="계속 유지할 Project 정보">
             <a:extLst xmlns:a="http://schemas.openxmlformats.org/drawingml/2006/main">
               <a:ext uri="{FF2B5EF4-FFF2-40B4-BE49-F238E27FC236}">
-                <a16:creationId xmlns:a16="http://schemas.microsoft.com/office/drawing/2014/main" id="{C99BAB6B-0ADF-4051-A7B7-F1FE454C3DDE}"/>
+                <a16:creationId xmlns:a16="http://schemas.microsoft.com/office/drawing/2014/main" id="{1BAFE978-5A4B-46F0-B3A1-C9E4D49593F1}"/>
               </a:ext>
             </a:extLst>
           </p:cNvPr>
@@ -16631,7 +16631,7 @@
           <p:cNvPr id="9" name="">
             <a:extLst xmlns:a="http://schemas.openxmlformats.org/drawingml/2006/main">
               <a:ext uri="{FF2B5EF4-FFF2-40B4-BE49-F238E27FC236}">
-                <a16:creationId xmlns:a16="http://schemas.microsoft.com/office/drawing/2014/main" id="{7FACFCD5-1B15-4484-B4C2-BA4462516973}"/>
+                <a16:creationId xmlns:a16="http://schemas.microsoft.com/office/drawing/2014/main" id="{9E712A25-7F6E-49AE-8873-6FDB6DE22003}"/>
               </a:ext>
             </a:extLst>
           </p:cNvPr>
@@ -16664,7 +16664,7 @@
           <p:cNvPr id="10" name="crop 경계 수정&#10;이번에는 README만 수정">
             <a:extLst xmlns:a="http://schemas.openxmlformats.org/drawingml/2006/main">
               <a:ext uri="{FF2B5EF4-FFF2-40B4-BE49-F238E27FC236}">
-                <a16:creationId xmlns:a16="http://schemas.microsoft.com/office/drawing/2014/main" id="{96E0109F-903D-4EF1-B41C-395FFFB6F8C3}"/>
+                <a16:creationId xmlns:a16="http://schemas.microsoft.com/office/drawing/2014/main" id="{752FA118-437D-42D0-A819-1E761D9598CD}"/>
               </a:ext>
             </a:extLst>
           </p:cNvPr>
@@ -16845,7 +16845,7 @@
           <p:cNvPr id="11" name="이번 목표에 적용할 후보">
             <a:extLst xmlns:a="http://schemas.openxmlformats.org/drawingml/2006/main">
               <a:ext uri="{FF2B5EF4-FFF2-40B4-BE49-F238E27FC236}">
-                <a16:creationId xmlns:a16="http://schemas.microsoft.com/office/drawing/2014/main" id="{DD7BD2EF-12AC-4BA7-81CB-DB6C29640EF1}"/>
+                <a16:creationId xmlns:a16="http://schemas.microsoft.com/office/drawing/2014/main" id="{98690F35-AFF6-423F-A84D-32BF847A0E82}"/>
               </a:ext>
             </a:extLst>
           </p:cNvPr>
@@ -17003,7 +17003,7 @@
           <p:cNvPr id="12" name="">
             <a:extLst xmlns:a="http://schemas.openxmlformats.org/drawingml/2006/main">
               <a:ext uri="{FF2B5EF4-FFF2-40B4-BE49-F238E27FC236}">
-                <a16:creationId xmlns:a16="http://schemas.microsoft.com/office/drawing/2014/main" id="{A0CF13CF-9DBF-49D1-BC2E-CD0724FF7883}"/>
+                <a16:creationId xmlns:a16="http://schemas.microsoft.com/office/drawing/2014/main" id="{FBF60FD6-15A1-49CB-8DC7-372EB58A35D4}"/>
               </a:ext>
             </a:extLst>
           </p:cNvPr>
@@ -17036,7 +17036,7 @@
           <p:cNvPr id="13" name="의존성 추가에는 작업상 근거 필요&#10;프로젝트 테스트 명령">
             <a:extLst xmlns:a="http://schemas.openxmlformats.org/drawingml/2006/main">
               <a:ext uri="{FF2B5EF4-FFF2-40B4-BE49-F238E27FC236}">
-                <a16:creationId xmlns:a16="http://schemas.microsoft.com/office/drawing/2014/main" id="{DCED291C-A0E1-48D5-ADFB-1A6D2DBCDD7E}"/>
+                <a16:creationId xmlns:a16="http://schemas.microsoft.com/office/drawing/2014/main" id="{00D54274-8F05-4534-A8FC-E2E6CF2C4697}"/>
               </a:ext>
             </a:extLst>
           </p:cNvPr>
@@ -17217,7 +17217,7 @@
           <p:cNvPr id="14" name="여러 작업에서 참고할 후보">
             <a:extLst xmlns:a="http://schemas.openxmlformats.org/drawingml/2006/main">
               <a:ext uri="{FF2B5EF4-FFF2-40B4-BE49-F238E27FC236}">
-                <a16:creationId xmlns:a16="http://schemas.microsoft.com/office/drawing/2014/main" id="{A58E0729-BC8F-4ED0-A33E-8433D60422CB}"/>
+                <a16:creationId xmlns:a16="http://schemas.microsoft.com/office/drawing/2014/main" id="{247C745F-A1DE-4C20-9B87-E7DA3B124F12}"/>
               </a:ext>
             </a:extLst>
           </p:cNvPr>
@@ -17375,7 +17375,7 @@
           <p:cNvPr id="15" name="정보마다 필요한 기간과 적용 범위가 다르다.">
             <a:extLst xmlns:a="http://schemas.openxmlformats.org/drawingml/2006/main">
               <a:ext uri="{FF2B5EF4-FFF2-40B4-BE49-F238E27FC236}">
-                <a16:creationId xmlns:a16="http://schemas.microsoft.com/office/drawing/2014/main" id="{641D7665-65F7-4971-BB59-6709E6B77FE9}"/>
+                <a16:creationId xmlns:a16="http://schemas.microsoft.com/office/drawing/2014/main" id="{7D48394A-A20E-403B-A5C3-26D312EE8B1D}"/>
               </a:ext>
             </a:extLst>
           </p:cNvPr>
@@ -17533,7 +17533,7 @@
           <p:cNvPr id="16" name="Legacy module connection">
             <a:extLst xmlns:a="http://schemas.openxmlformats.org/drawingml/2006/main">
               <a:ext uri="{FF2B5EF4-FFF2-40B4-BE49-F238E27FC236}">
-                <a16:creationId xmlns:a16="http://schemas.microsoft.com/office/drawing/2014/main" id="{9C9F7DCD-553F-4CE9-944B-F7117E272CA1}"/>
+                <a16:creationId xmlns:a16="http://schemas.microsoft.com/office/drawing/2014/main" id="{56701317-C2EE-46E3-A83E-817737240289}"/>
               </a:ext>
             </a:extLst>
           </p:cNvPr>
@@ -17689,7 +17689,7 @@
     </p:spTree>
     <p:extLst>
       <p:ext uri="{BB962C8B-B14F-4D97-AF65-F5344CB8AC3E}">
-        <p14:creationId xmlns:p14="http://schemas.microsoft.com/office/powerpoint/2010/main" val="636010164"/>
+        <p14:creationId xmlns:p14="http://schemas.microsoft.com/office/powerpoint/2010/main" val="398690569"/>
       </p:ext>
     </p:extLst>
   </p:cSld>
@@ -17720,7 +17720,7 @@
           <p:cNvPr id="21" name="ACT 1 · 앞서 본 crop 사례로 좁히기">
             <a:extLst xmlns:a="http://schemas.openxmlformats.org/drawingml/2006/main">
               <a:ext uri="{FF2B5EF4-FFF2-40B4-BE49-F238E27FC236}">
-                <a16:creationId xmlns:a16="http://schemas.microsoft.com/office/drawing/2014/main" id="{F9C5927A-E009-4FA3-8A87-2C83DF22BA5E}"/>
+                <a16:creationId xmlns:a16="http://schemas.microsoft.com/office/drawing/2014/main" id="{FFCC4BF7-B0C5-4FAB-9D6C-80C4053BE375}"/>
               </a:ext>
             </a:extLst>
           </p:cNvPr>
@@ -17875,10 +17875,10 @@
       </p:sp>
       <p:sp>
         <p:nvSpPr>
-          <p:cNvPr id="2" name="S11">
+          <p:cNvPr id="2" name="S12">
             <a:extLst xmlns:a="http://schemas.openxmlformats.org/drawingml/2006/main">
               <a:ext uri="{FF2B5EF4-FFF2-40B4-BE49-F238E27FC236}">
-                <a16:creationId xmlns:a16="http://schemas.microsoft.com/office/drawing/2014/main" id="{52E450F0-CD59-46E7-B924-388F23FAFEE1}"/>
+                <a16:creationId xmlns:a16="http://schemas.microsoft.com/office/drawing/2014/main" id="{5CAF01EE-4950-4290-949E-C1242E3A6003}"/>
               </a:ext>
             </a:extLst>
           </p:cNvPr>
@@ -18026,7 +18026,7 @@
                 <a:ea typeface="Malgun Gothic"/>
                 <a:cs typeface="Malgun Gothic"/>
               </a:rPr>
-              <a:t>S11</a:t>
+              <a:t>S12</a:t>
             </a:r>
           </a:p>
         </p:txBody>
@@ -18036,7 +18036,7 @@
           <p:cNvPr id="3" name="요청만으로는 의도가 보이지 않는다">
             <a:extLst xmlns:a="http://schemas.openxmlformats.org/drawingml/2006/main">
               <a:ext uri="{FF2B5EF4-FFF2-40B4-BE49-F238E27FC236}">
-                <a16:creationId xmlns:a16="http://schemas.microsoft.com/office/drawing/2014/main" id="{EEB79E8B-A4E2-4935-AC4B-183828885747}"/>
+                <a16:creationId xmlns:a16="http://schemas.microsoft.com/office/drawing/2014/main" id="{A799D3DC-693E-4B6A-B461-9F0945002F79}"/>
               </a:ext>
             </a:extLst>
           </p:cNvPr>
@@ -18194,7 +18194,7 @@
           <p:cNvPr id="4" name="">
             <a:extLst xmlns:a="http://schemas.openxmlformats.org/drawingml/2006/main">
               <a:ext uri="{FF2B5EF4-FFF2-40B4-BE49-F238E27FC236}">
-                <a16:creationId xmlns:a16="http://schemas.microsoft.com/office/drawing/2014/main" id="{0242137F-3B1B-44B3-8E88-274E54EC0167}"/>
+                <a16:creationId xmlns:a16="http://schemas.microsoft.com/office/drawing/2014/main" id="{D39DD85D-89F8-419F-9107-B15E654C56ED}"/>
               </a:ext>
             </a:extLst>
           </p:cNvPr>
@@ -18225,7 +18225,7 @@
           <p:cNvPr id="5" name="교육용 구성 사례 · TRIAL-002의 실제 Prompt가 아님">
             <a:extLst xmlns:a="http://schemas.openxmlformats.org/drawingml/2006/main">
               <a:ext uri="{FF2B5EF4-FFF2-40B4-BE49-F238E27FC236}">
-                <a16:creationId xmlns:a16="http://schemas.microsoft.com/office/drawing/2014/main" id="{44C87303-9ED2-426E-A462-8951EB2F8ED2}"/>
+                <a16:creationId xmlns:a16="http://schemas.microsoft.com/office/drawing/2014/main" id="{8E0167CE-B790-4810-B52B-A88FEF0F132C}"/>
               </a:ext>
             </a:extLst>
           </p:cNvPr>
@@ -18383,7 +18383,7 @@
           <p:cNvPr id="6" name="짧은 요청을 비난하거나 이 요청이 특정 실패를 만들었다고 주장하지 않습니다.">
             <a:extLst xmlns:a="http://schemas.openxmlformats.org/drawingml/2006/main">
               <a:ext uri="{FF2B5EF4-FFF2-40B4-BE49-F238E27FC236}">
-                <a16:creationId xmlns:a16="http://schemas.microsoft.com/office/drawing/2014/main" id="{D40C568B-9E4E-43E2-9F0D-C27B9CC6C519}"/>
+                <a16:creationId xmlns:a16="http://schemas.microsoft.com/office/drawing/2014/main" id="{F5208817-EAB9-4AC2-B33F-249CC9771B3A}"/>
               </a:ext>
             </a:extLst>
           </p:cNvPr>
@@ -18541,7 +18541,7 @@
           <p:cNvPr id="7" name="“crop test 고쳐줘”">
             <a:extLst xmlns:a="http://schemas.openxmlformats.org/drawingml/2006/main">
               <a:ext uri="{FF2B5EF4-FFF2-40B4-BE49-F238E27FC236}">
-                <a16:creationId xmlns:a16="http://schemas.microsoft.com/office/drawing/2014/main" id="{82579125-07F3-4164-AF40-2EB2E83331F7}"/>
+                <a16:creationId xmlns:a16="http://schemas.microsoft.com/office/drawing/2014/main" id="{F9698E69-1A7E-4C19-B9F7-BB4D8DE20462}"/>
               </a:ext>
             </a:extLst>
           </p:cNvPr>
@@ -18699,7 +18699,7 @@
           <p:cNvPr id="8" name="">
             <a:extLst xmlns:a="http://schemas.openxmlformats.org/drawingml/2006/main">
               <a:ext uri="{FF2B5EF4-FFF2-40B4-BE49-F238E27FC236}">
-                <a16:creationId xmlns:a16="http://schemas.microsoft.com/office/drawing/2014/main" id="{160286D3-D5B0-4AF5-A323-638244D1529F}"/>
+                <a16:creationId xmlns:a16="http://schemas.microsoft.com/office/drawing/2014/main" id="{47563496-B730-4DD1-9E44-12DE16166A3C}"/>
               </a:ext>
             </a:extLst>
           </p:cNvPr>
@@ -18729,7 +18729,7 @@
           <p:cNvPr id="9" name="">
             <a:extLst xmlns:a="http://schemas.openxmlformats.org/drawingml/2006/main">
               <a:ext uri="{FF2B5EF4-FFF2-40B4-BE49-F238E27FC236}">
-                <a16:creationId xmlns:a16="http://schemas.microsoft.com/office/drawing/2014/main" id="{E151DA75-A208-4BA7-83A6-BAF95F6CD039}"/>
+                <a16:creationId xmlns:a16="http://schemas.microsoft.com/office/drawing/2014/main" id="{985F8BA4-2267-4E93-A2A7-DED514407CF5}"/>
               </a:ext>
             </a:extLst>
           </p:cNvPr>
@@ -18760,7 +18760,7 @@
           <p:cNvPr id="10" name="">
             <a:extLst xmlns:a="http://schemas.openxmlformats.org/drawingml/2006/main">
               <a:ext uri="{FF2B5EF4-FFF2-40B4-BE49-F238E27FC236}">
-                <a16:creationId xmlns:a16="http://schemas.microsoft.com/office/drawing/2014/main" id="{BCE4F8CF-7970-40DC-AD94-B2D035685AB6}"/>
+                <a16:creationId xmlns:a16="http://schemas.microsoft.com/office/drawing/2014/main" id="{89438752-C70E-4D72-825B-93AF1AB185EA}"/>
               </a:ext>
             </a:extLst>
           </p:cNvPr>
@@ -18793,7 +18793,7 @@
           <p:cNvPr id="11" name="">
             <a:extLst xmlns:a="http://schemas.openxmlformats.org/drawingml/2006/main">
               <a:ext uri="{FF2B5EF4-FFF2-40B4-BE49-F238E27FC236}">
-                <a16:creationId xmlns:a16="http://schemas.microsoft.com/office/drawing/2014/main" id="{EFAC0998-1A60-4821-A44F-A22C4DBB20BB}"/>
+                <a16:creationId xmlns:a16="http://schemas.microsoft.com/office/drawing/2014/main" id="{04FCB78A-231B-400F-83BA-636C46B15C4F}"/>
               </a:ext>
             </a:extLst>
           </p:cNvPr>
@@ -18826,7 +18826,7 @@
           <p:cNvPr id="12" name="테스트를 바꿀까?">
             <a:extLst xmlns:a="http://schemas.openxmlformats.org/drawingml/2006/main">
               <a:ext uri="{FF2B5EF4-FFF2-40B4-BE49-F238E27FC236}">
-                <a16:creationId xmlns:a16="http://schemas.microsoft.com/office/drawing/2014/main" id="{2B466F59-E88C-4A8C-AB47-84ABFB70F15D}"/>
+                <a16:creationId xmlns:a16="http://schemas.microsoft.com/office/drawing/2014/main" id="{42600A2A-5019-4158-86B1-64DDDC280144}"/>
               </a:ext>
             </a:extLst>
           </p:cNvPr>
@@ -18984,7 +18984,7 @@
           <p:cNvPr id="13" name="구현을 바꿀까?">
             <a:extLst xmlns:a="http://schemas.openxmlformats.org/drawingml/2006/main">
               <a:ext uri="{FF2B5EF4-FFF2-40B4-BE49-F238E27FC236}">
-                <a16:creationId xmlns:a16="http://schemas.microsoft.com/office/drawing/2014/main" id="{1A4F1BA9-5DEA-47DB-9202-BDBC19BF8146}"/>
+                <a16:creationId xmlns:a16="http://schemas.microsoft.com/office/drawing/2014/main" id="{1D3C9F82-D428-4280-A672-24A6B27558FA}"/>
               </a:ext>
             </a:extLst>
           </p:cNvPr>
@@ -19142,7 +19142,7 @@
           <p:cNvPr id="14" name="아직 정해지지 않은 정보">
             <a:extLst xmlns:a="http://schemas.openxmlformats.org/drawingml/2006/main">
               <a:ext uri="{FF2B5EF4-FFF2-40B4-BE49-F238E27FC236}">
-                <a16:creationId xmlns:a16="http://schemas.microsoft.com/office/drawing/2014/main" id="{00DFD4D9-AC99-4282-B84C-3CD12686C6DB}"/>
+                <a16:creationId xmlns:a16="http://schemas.microsoft.com/office/drawing/2014/main" id="{CBA80DFE-F537-40AE-9834-973B727C7D94}"/>
               </a:ext>
             </a:extLst>
           </p:cNvPr>
@@ -19300,7 +19300,7 @@
           <p:cNvPr id="15" name="목표의 세부 ?">
             <a:extLst xmlns:a="http://schemas.openxmlformats.org/drawingml/2006/main">
               <a:ext uri="{FF2B5EF4-FFF2-40B4-BE49-F238E27FC236}">
-                <a16:creationId xmlns:a16="http://schemas.microsoft.com/office/drawing/2014/main" id="{DD19D90A-C4B3-4162-95C2-72A4DA790F37}"/>
+                <a16:creationId xmlns:a16="http://schemas.microsoft.com/office/drawing/2014/main" id="{53DB2EF0-CE2B-4195-8E98-E9657617DC47}"/>
               </a:ext>
             </a:extLst>
           </p:cNvPr>
@@ -19458,7 +19458,7 @@
           <p:cNvPr id="16" name="보존 조건 ?">
             <a:extLst xmlns:a="http://schemas.openxmlformats.org/drawingml/2006/main">
               <a:ext uri="{FF2B5EF4-FFF2-40B4-BE49-F238E27FC236}">
-                <a16:creationId xmlns:a16="http://schemas.microsoft.com/office/drawing/2014/main" id="{D051A610-4AE3-4116-9EC1-EEF8A8CB5F1F}"/>
+                <a16:creationId xmlns:a16="http://schemas.microsoft.com/office/drawing/2014/main" id="{B9327D9F-1B9E-43EC-8BA7-4A76934D30F5}"/>
               </a:ext>
             </a:extLst>
           </p:cNvPr>
@@ -19616,7 +19616,7 @@
           <p:cNvPr id="17" name="수정 범위 ?">
             <a:extLst xmlns:a="http://schemas.openxmlformats.org/drawingml/2006/main">
               <a:ext uri="{FF2B5EF4-FFF2-40B4-BE49-F238E27FC236}">
-                <a16:creationId xmlns:a16="http://schemas.microsoft.com/office/drawing/2014/main" id="{1A7AA017-2AD3-4BA2-A776-5F25064AC41B}"/>
+                <a16:creationId xmlns:a16="http://schemas.microsoft.com/office/drawing/2014/main" id="{EF9C35E0-F485-4FF2-8C63-6868226F3F2C}"/>
               </a:ext>
             </a:extLst>
           </p:cNvPr>
@@ -19774,7 +19774,7 @@
           <p:cNvPr id="18" name="확인 근거 ?">
             <a:extLst xmlns:a="http://schemas.openxmlformats.org/drawingml/2006/main">
               <a:ext uri="{FF2B5EF4-FFF2-40B4-BE49-F238E27FC236}">
-                <a16:creationId xmlns:a16="http://schemas.microsoft.com/office/drawing/2014/main" id="{C6DB80CD-9907-4291-88A0-9F2BBA4523DC}"/>
+                <a16:creationId xmlns:a16="http://schemas.microsoft.com/office/drawing/2014/main" id="{C56B7355-3F6E-4446-AA84-38C41BEBBA88}"/>
               </a:ext>
             </a:extLst>
           </p:cNvPr>
@@ -19932,7 +19932,7 @@
           <p:cNvPr id="19" name="완료 조건 ?">
             <a:extLst xmlns:a="http://schemas.openxmlformats.org/drawingml/2006/main">
               <a:ext uri="{FF2B5EF4-FFF2-40B4-BE49-F238E27FC236}">
-                <a16:creationId xmlns:a16="http://schemas.microsoft.com/office/drawing/2014/main" id="{4C351617-B03D-46DF-A6B5-69C0B30FB2E1}"/>
+                <a16:creationId xmlns:a16="http://schemas.microsoft.com/office/drawing/2014/main" id="{B01F09EF-041A-462C-9CDA-DC7869A1525B}"/>
               </a:ext>
             </a:extLst>
           </p:cNvPr>
@@ -20090,7 +20090,7 @@
           <p:cNvPr id="20" name="Legacy module connection">
             <a:extLst xmlns:a="http://schemas.openxmlformats.org/drawingml/2006/main">
               <a:ext uri="{FF2B5EF4-FFF2-40B4-BE49-F238E27FC236}">
-                <a16:creationId xmlns:a16="http://schemas.microsoft.com/office/drawing/2014/main" id="{4FA9935A-6C10-4690-BB3A-2FA1695520EB}"/>
+                <a16:creationId xmlns:a16="http://schemas.microsoft.com/office/drawing/2014/main" id="{814100DA-2334-44F0-A347-0A8057A048D2}"/>
               </a:ext>
             </a:extLst>
           </p:cNvPr>
@@ -20246,7 +20246,7 @@
     </p:spTree>
     <p:extLst>
       <p:ext uri="{BB962C8B-B14F-4D97-AF65-F5344CB8AC3E}">
-        <p14:creationId xmlns:p14="http://schemas.microsoft.com/office/powerpoint/2010/main" val="1843776427"/>
+        <p14:creationId xmlns:p14="http://schemas.microsoft.com/office/powerpoint/2010/main" val="362024861"/>
       </p:ext>
     </p:extLst>
   </p:cSld>
@@ -20277,7 +20277,7 @@
           <p:cNvPr id="24" name="ACT 1 · 요청을 보내기 전의 질문">
             <a:extLst xmlns:a="http://schemas.openxmlformats.org/drawingml/2006/main">
               <a:ext uri="{FF2B5EF4-FFF2-40B4-BE49-F238E27FC236}">
-                <a16:creationId xmlns:a16="http://schemas.microsoft.com/office/drawing/2014/main" id="{5C22EE35-9DD7-424C-945E-4CFACF638E1B}"/>
+                <a16:creationId xmlns:a16="http://schemas.microsoft.com/office/drawing/2014/main" id="{6EB3CC72-F4D0-458A-A936-2C31AF5C60BF}"/>
               </a:ext>
             </a:extLst>
           </p:cNvPr>
@@ -20432,10 +20432,10 @@
       </p:sp>
       <p:sp>
         <p:nvSpPr>
-          <p:cNvPr id="2" name="S12">
+          <p:cNvPr id="2" name="S13">
             <a:extLst xmlns:a="http://schemas.openxmlformats.org/drawingml/2006/main">
               <a:ext uri="{FF2B5EF4-FFF2-40B4-BE49-F238E27FC236}">
-                <a16:creationId xmlns:a16="http://schemas.microsoft.com/office/drawing/2014/main" id="{7A20419B-9B03-43C0-98D8-9AB7804E3254}"/>
+                <a16:creationId xmlns:a16="http://schemas.microsoft.com/office/drawing/2014/main" id="{4C7830F0-5615-4D64-9E79-0D57C4BAF857}"/>
               </a:ext>
             </a:extLst>
           </p:cNvPr>
@@ -20583,7 +20583,7 @@
                 <a:ea typeface="Malgun Gothic"/>
                 <a:cs typeface="Malgun Gothic"/>
               </a:rPr>
-              <a:t>S12</a:t>
+              <a:t>S13</a:t>
             </a:r>
           </a:p>
         </p:txBody>
@@ -20593,7 +20593,7 @@
           <p:cNvPr id="3" name="개발자가 정해야 하는 경계">
             <a:extLst xmlns:a="http://schemas.openxmlformats.org/drawingml/2006/main">
               <a:ext uri="{FF2B5EF4-FFF2-40B4-BE49-F238E27FC236}">
-                <a16:creationId xmlns:a16="http://schemas.microsoft.com/office/drawing/2014/main" id="{D7533042-017D-4677-BE08-BCE98924CF5E}"/>
+                <a16:creationId xmlns:a16="http://schemas.microsoft.com/office/drawing/2014/main" id="{B13A78FD-EE43-48E8-9127-247C44AF8C64}"/>
               </a:ext>
             </a:extLst>
           </p:cNvPr>
@@ -20751,7 +20751,7 @@
           <p:cNvPr id="4" name="">
             <a:extLst xmlns:a="http://schemas.openxmlformats.org/drawingml/2006/main">
               <a:ext uri="{FF2B5EF4-FFF2-40B4-BE49-F238E27FC236}">
-                <a16:creationId xmlns:a16="http://schemas.microsoft.com/office/drawing/2014/main" id="{5E5EC735-C9AF-4F73-8360-FB6A4BE35CD4}"/>
+                <a16:creationId xmlns:a16="http://schemas.microsoft.com/office/drawing/2014/main" id="{3F0DCEC0-1618-4CBB-A053-4903BCC3E92C}"/>
               </a:ext>
             </a:extLst>
           </p:cNvPr>
@@ -20782,7 +20782,7 @@
           <p:cNvPr id="5" name="이 과정의 질문 틀 · 정답을 제시하는 분류 시험이 아님">
             <a:extLst xmlns:a="http://schemas.openxmlformats.org/drawingml/2006/main">
               <a:ext uri="{FF2B5EF4-FFF2-40B4-BE49-F238E27FC236}">
-                <a16:creationId xmlns:a16="http://schemas.microsoft.com/office/drawing/2014/main" id="{B8AC8953-9435-4627-93E0-C4E64AA84530}"/>
+                <a16:creationId xmlns:a16="http://schemas.microsoft.com/office/drawing/2014/main" id="{DF362094-1B17-481D-8852-FAB146E35694}"/>
               </a:ext>
             </a:extLst>
           </p:cNvPr>
@@ -20940,7 +20940,7 @@
           <p:cNvPr id="6" name="마지막 1분은 익숙한 작업 하나를 조용히 떠올려 보세요.">
             <a:extLst xmlns:a="http://schemas.openxmlformats.org/drawingml/2006/main">
               <a:ext uri="{FF2B5EF4-FFF2-40B4-BE49-F238E27FC236}">
-                <a16:creationId xmlns:a16="http://schemas.microsoft.com/office/drawing/2014/main" id="{5C02389C-6238-419D-B0B0-5EBD455E44D5}"/>
+                <a16:creationId xmlns:a16="http://schemas.microsoft.com/office/drawing/2014/main" id="{D0D60EF7-F585-4818-8A11-E52769FD81F2}"/>
               </a:ext>
             </a:extLst>
           </p:cNvPr>
@@ -21098,7 +21098,7 @@
           <p:cNvPr id="7" name="“crop test 고쳐줘”에 답하기 전에">
             <a:extLst xmlns:a="http://schemas.openxmlformats.org/drawingml/2006/main">
               <a:ext uri="{FF2B5EF4-FFF2-40B4-BE49-F238E27FC236}">
-                <a16:creationId xmlns:a16="http://schemas.microsoft.com/office/drawing/2014/main" id="{9B2C2695-D760-4091-9EA9-80FE39AFDE3B}"/>
+                <a16:creationId xmlns:a16="http://schemas.microsoft.com/office/drawing/2014/main" id="{CFE20B2C-90CE-47F5-8CA2-2D776BA4114E}"/>
               </a:ext>
             </a:extLst>
           </p:cNvPr>
@@ -21256,7 +21256,7 @@
           <p:cNvPr id="8" name="01">
             <a:extLst xmlns:a="http://schemas.openxmlformats.org/drawingml/2006/main">
               <a:ext uri="{FF2B5EF4-FFF2-40B4-BE49-F238E27FC236}">
-                <a16:creationId xmlns:a16="http://schemas.microsoft.com/office/drawing/2014/main" id="{C5FFD6D3-1305-4AB8-B258-26B414C07F3F}"/>
+                <a16:creationId xmlns:a16="http://schemas.microsoft.com/office/drawing/2014/main" id="{7B32884B-15DC-4D46-BCA5-6D8CCC6D9354}"/>
               </a:ext>
             </a:extLst>
           </p:cNvPr>
@@ -21414,7 +21414,7 @@
           <p:cNvPr id="9" name="무엇을 바꿀까?">
             <a:extLst xmlns:a="http://schemas.openxmlformats.org/drawingml/2006/main">
               <a:ext uri="{FF2B5EF4-FFF2-40B4-BE49-F238E27FC236}">
-                <a16:creationId xmlns:a16="http://schemas.microsoft.com/office/drawing/2014/main" id="{73DF9674-8303-4063-B533-BC21015DA2D3}"/>
+                <a16:creationId xmlns:a16="http://schemas.microsoft.com/office/drawing/2014/main" id="{86632CF8-D08B-4ADD-9D32-019EEEAD46EB}"/>
               </a:ext>
             </a:extLst>
           </p:cNvPr>
@@ -21572,7 +21572,7 @@
           <p:cNvPr id="10" name="">
             <a:extLst xmlns:a="http://schemas.openxmlformats.org/drawingml/2006/main">
               <a:ext uri="{FF2B5EF4-FFF2-40B4-BE49-F238E27FC236}">
-                <a16:creationId xmlns:a16="http://schemas.microsoft.com/office/drawing/2014/main" id="{CA79E8BE-54D6-4BF2-B3F2-5832451EDE35}"/>
+                <a16:creationId xmlns:a16="http://schemas.microsoft.com/office/drawing/2014/main" id="{2E4B0103-DDD7-4298-B23E-6815CEE22A3B}"/>
               </a:ext>
             </a:extLst>
           </p:cNvPr>
@@ -21603,7 +21603,7 @@
           <p:cNvPr id="11" name="02">
             <a:extLst xmlns:a="http://schemas.openxmlformats.org/drawingml/2006/main">
               <a:ext uri="{FF2B5EF4-FFF2-40B4-BE49-F238E27FC236}">
-                <a16:creationId xmlns:a16="http://schemas.microsoft.com/office/drawing/2014/main" id="{8197EE47-A0A8-4A3E-AEF6-AB0B9E4B51CB}"/>
+                <a16:creationId xmlns:a16="http://schemas.microsoft.com/office/drawing/2014/main" id="{E77AE1C3-5E21-4309-AE52-56BA1FDB4299}"/>
               </a:ext>
             </a:extLst>
           </p:cNvPr>
@@ -21761,7 +21761,7 @@
           <p:cNvPr id="12" name="무엇을 유지할까?">
             <a:extLst xmlns:a="http://schemas.openxmlformats.org/drawingml/2006/main">
               <a:ext uri="{FF2B5EF4-FFF2-40B4-BE49-F238E27FC236}">
-                <a16:creationId xmlns:a16="http://schemas.microsoft.com/office/drawing/2014/main" id="{B5EDF060-0722-4682-8604-B3265A39F575}"/>
+                <a16:creationId xmlns:a16="http://schemas.microsoft.com/office/drawing/2014/main" id="{8A9EBA9A-2AA8-4DF5-AC5B-BF8C6E4CFBD3}"/>
               </a:ext>
             </a:extLst>
           </p:cNvPr>
@@ -21919,7 +21919,7 @@
           <p:cNvPr id="13" name="">
             <a:extLst xmlns:a="http://schemas.openxmlformats.org/drawingml/2006/main">
               <a:ext uri="{FF2B5EF4-FFF2-40B4-BE49-F238E27FC236}">
-                <a16:creationId xmlns:a16="http://schemas.microsoft.com/office/drawing/2014/main" id="{977B29F6-1799-47B0-8D78-F612309D4F65}"/>
+                <a16:creationId xmlns:a16="http://schemas.microsoft.com/office/drawing/2014/main" id="{6617DB9F-5538-4DCC-B4B9-1C8011E573FB}"/>
               </a:ext>
             </a:extLst>
           </p:cNvPr>
@@ -21950,7 +21950,7 @@
           <p:cNvPr id="14" name="03">
             <a:extLst xmlns:a="http://schemas.openxmlformats.org/drawingml/2006/main">
               <a:ext uri="{FF2B5EF4-FFF2-40B4-BE49-F238E27FC236}">
-                <a16:creationId xmlns:a16="http://schemas.microsoft.com/office/drawing/2014/main" id="{6113D920-8D4D-4B20-A802-196B4384359A}"/>
+                <a16:creationId xmlns:a16="http://schemas.microsoft.com/office/drawing/2014/main" id="{D766B404-39D3-40B2-9405-D2F8A1DB9CEF}"/>
               </a:ext>
             </a:extLst>
           </p:cNvPr>
@@ -22108,7 +22108,7 @@
           <p:cNvPr id="15" name="어디까지 바꿔도 될까?">
             <a:extLst xmlns:a="http://schemas.openxmlformats.org/drawingml/2006/main">
               <a:ext uri="{FF2B5EF4-FFF2-40B4-BE49-F238E27FC236}">
-                <a16:creationId xmlns:a16="http://schemas.microsoft.com/office/drawing/2014/main" id="{B3F409A5-AD18-4726-8ADA-4CC4C98AE204}"/>
+                <a16:creationId xmlns:a16="http://schemas.microsoft.com/office/drawing/2014/main" id="{F9072055-1A9C-42F1-A2EE-8EF6FA2F4755}"/>
               </a:ext>
             </a:extLst>
           </p:cNvPr>
@@ -22266,7 +22266,7 @@
           <p:cNvPr id="16" name="">
             <a:extLst xmlns:a="http://schemas.openxmlformats.org/drawingml/2006/main">
               <a:ext uri="{FF2B5EF4-FFF2-40B4-BE49-F238E27FC236}">
-                <a16:creationId xmlns:a16="http://schemas.microsoft.com/office/drawing/2014/main" id="{DAA8FC6A-46FC-499F-906E-18BB8A2D8640}"/>
+                <a16:creationId xmlns:a16="http://schemas.microsoft.com/office/drawing/2014/main" id="{7E265DEE-03A7-4F7A-94B5-065DC51AA2F7}"/>
               </a:ext>
             </a:extLst>
           </p:cNvPr>
@@ -22297,7 +22297,7 @@
           <p:cNvPr id="17" name="04">
             <a:extLst xmlns:a="http://schemas.openxmlformats.org/drawingml/2006/main">
               <a:ext uri="{FF2B5EF4-FFF2-40B4-BE49-F238E27FC236}">
-                <a16:creationId xmlns:a16="http://schemas.microsoft.com/office/drawing/2014/main" id="{36BB13B9-8961-4993-B42D-06E9BDED9EB0}"/>
+                <a16:creationId xmlns:a16="http://schemas.microsoft.com/office/drawing/2014/main" id="{EDCDEC90-7E3A-42F3-A2BE-8A6E3F79D05B}"/>
               </a:ext>
             </a:extLst>
           </p:cNvPr>
@@ -22455,7 +22455,7 @@
           <p:cNvPr id="18" name="무슨 근거로 확인할까?">
             <a:extLst xmlns:a="http://schemas.openxmlformats.org/drawingml/2006/main">
               <a:ext uri="{FF2B5EF4-FFF2-40B4-BE49-F238E27FC236}">
-                <a16:creationId xmlns:a16="http://schemas.microsoft.com/office/drawing/2014/main" id="{1D007340-178B-46C4-8585-B73AE3D34BC0}"/>
+                <a16:creationId xmlns:a16="http://schemas.microsoft.com/office/drawing/2014/main" id="{6251085C-7760-4317-AC81-063660E15D2F}"/>
               </a:ext>
             </a:extLst>
           </p:cNvPr>
@@ -22613,7 +22613,7 @@
           <p:cNvPr id="19" name="">
             <a:extLst xmlns:a="http://schemas.openxmlformats.org/drawingml/2006/main">
               <a:ext uri="{FF2B5EF4-FFF2-40B4-BE49-F238E27FC236}">
-                <a16:creationId xmlns:a16="http://schemas.microsoft.com/office/drawing/2014/main" id="{FBD56964-999A-4E7B-978F-77D1A6168BF3}"/>
+                <a16:creationId xmlns:a16="http://schemas.microsoft.com/office/drawing/2014/main" id="{278AECD4-6DB0-4F5F-9CC2-32C8C8C7A37B}"/>
               </a:ext>
             </a:extLst>
           </p:cNvPr>
@@ -22644,7 +22644,7 @@
           <p:cNvPr id="20" name="">
             <a:extLst xmlns:a="http://schemas.openxmlformats.org/drawingml/2006/main">
               <a:ext uri="{FF2B5EF4-FFF2-40B4-BE49-F238E27FC236}">
-                <a16:creationId xmlns:a16="http://schemas.microsoft.com/office/drawing/2014/main" id="{ABEA75CC-F25E-4A83-B73F-C1AF13BC72A8}"/>
+                <a16:creationId xmlns:a16="http://schemas.microsoft.com/office/drawing/2014/main" id="{8BA7D5B9-21B5-4C9E-98D3-528B9900B046}"/>
               </a:ext>
             </a:extLst>
           </p:cNvPr>
@@ -22675,7 +22675,7 @@
           <p:cNvPr id="21" name="05">
             <a:extLst xmlns:a="http://schemas.openxmlformats.org/drawingml/2006/main">
               <a:ext uri="{FF2B5EF4-FFF2-40B4-BE49-F238E27FC236}">
-                <a16:creationId xmlns:a16="http://schemas.microsoft.com/office/drawing/2014/main" id="{FC994B85-16A6-4AD3-B2C9-36E93F562473}"/>
+                <a16:creationId xmlns:a16="http://schemas.microsoft.com/office/drawing/2014/main" id="{84B2DC39-31BF-4347-9021-2E178E3B7C92}"/>
               </a:ext>
             </a:extLst>
           </p:cNvPr>
@@ -22833,7 +22833,7 @@
           <p:cNvPr id="22" name="언제 완료라고 할까?">
             <a:extLst xmlns:a="http://schemas.openxmlformats.org/drawingml/2006/main">
               <a:ext uri="{FF2B5EF4-FFF2-40B4-BE49-F238E27FC236}">
-                <a16:creationId xmlns:a16="http://schemas.microsoft.com/office/drawing/2014/main" id="{17FAD68A-9C9A-4BBD-A795-BCBF1CDD2A19}"/>
+                <a16:creationId xmlns:a16="http://schemas.microsoft.com/office/drawing/2014/main" id="{321DA336-2B0D-4083-8226-CC10B200BB93}"/>
               </a:ext>
             </a:extLst>
           </p:cNvPr>
@@ -22991,7 +22991,7 @@
           <p:cNvPr id="23" name="Legacy module connection">
             <a:extLst xmlns:a="http://schemas.openxmlformats.org/drawingml/2006/main">
               <a:ext uri="{FF2B5EF4-FFF2-40B4-BE49-F238E27FC236}">
-                <a16:creationId xmlns:a16="http://schemas.microsoft.com/office/drawing/2014/main" id="{4F4DB847-4C8E-4224-A87C-8CC6CDB0C597}"/>
+                <a16:creationId xmlns:a16="http://schemas.microsoft.com/office/drawing/2014/main" id="{92616C52-EB99-4255-8BEF-C4A8A689D233}"/>
               </a:ext>
             </a:extLst>
           </p:cNvPr>
@@ -23147,7 +23147,7 @@
     </p:spTree>
     <p:extLst>
       <p:ext uri="{BB962C8B-B14F-4D97-AF65-F5344CB8AC3E}">
-        <p14:creationId xmlns:p14="http://schemas.microsoft.com/office/powerpoint/2010/main" val="638768996"/>
+        <p14:creationId xmlns:p14="http://schemas.microsoft.com/office/powerpoint/2010/main" val="176593076"/>
       </p:ext>
     </p:extLst>
   </p:cSld>
@@ -23178,7 +23178,7 @@
           <p:cNvPr id="26" name="ACT 1 · 작업을 구체화하는 틀">
             <a:extLst xmlns:a="http://schemas.openxmlformats.org/drawingml/2006/main">
               <a:ext uri="{FF2B5EF4-FFF2-40B4-BE49-F238E27FC236}">
-                <a16:creationId xmlns:a16="http://schemas.microsoft.com/office/drawing/2014/main" id="{FF70D5C3-2CE2-4ACA-B39B-774EFDD55104}"/>
+                <a16:creationId xmlns:a16="http://schemas.microsoft.com/office/drawing/2014/main" id="{0177FE57-5962-43FC-81D9-B40A34F768CE}"/>
               </a:ext>
             </a:extLst>
           </p:cNvPr>
@@ -23333,10 +23333,10 @@
       </p:sp>
       <p:sp>
         <p:nvSpPr>
-          <p:cNvPr id="2" name="S13">
+          <p:cNvPr id="2" name="S14">
             <a:extLst xmlns:a="http://schemas.openxmlformats.org/drawingml/2006/main">
               <a:ext uri="{FF2B5EF4-FFF2-40B4-BE49-F238E27FC236}">
-                <a16:creationId xmlns:a16="http://schemas.microsoft.com/office/drawing/2014/main" id="{4C3A5D85-6902-475E-BE0A-3A998854CB84}"/>
+                <a16:creationId xmlns:a16="http://schemas.microsoft.com/office/drawing/2014/main" id="{8466E845-6437-41D9-BCDB-73CADA5F9B90}"/>
               </a:ext>
             </a:extLst>
           </p:cNvPr>
@@ -23484,7 +23484,7 @@
                 <a:ea typeface="Malgun Gothic"/>
                 <a:cs typeface="Malgun Gothic"/>
               </a:rPr>
-              <a:t>S13</a:t>
+              <a:t>S14</a:t>
             </a:r>
           </a:p>
         </p:txBody>
@@ -23494,7 +23494,7 @@
           <p:cNvPr id="3" name="Task Specification의 다섯 책임">
             <a:extLst xmlns:a="http://schemas.openxmlformats.org/drawingml/2006/main">
               <a:ext uri="{FF2B5EF4-FFF2-40B4-BE49-F238E27FC236}">
-                <a16:creationId xmlns:a16="http://schemas.microsoft.com/office/drawing/2014/main" id="{8247046E-8DD0-47E0-99DC-6AB71991D8F5}"/>
+                <a16:creationId xmlns:a16="http://schemas.microsoft.com/office/drawing/2014/main" id="{2E5C7BA1-7730-4C22-8372-BE98E550592F}"/>
               </a:ext>
             </a:extLst>
           </p:cNvPr>
@@ -23652,7 +23652,7 @@
           <p:cNvPr id="4" name="">
             <a:extLst xmlns:a="http://schemas.openxmlformats.org/drawingml/2006/main">
               <a:ext uri="{FF2B5EF4-FFF2-40B4-BE49-F238E27FC236}">
-                <a16:creationId xmlns:a16="http://schemas.microsoft.com/office/drawing/2014/main" id="{9C2E9508-310E-419C-B4C8-C145BF630482}"/>
+                <a16:creationId xmlns:a16="http://schemas.microsoft.com/office/drawing/2014/main" id="{B2DDA4BA-CBC5-476B-AC7F-2F74BA3F89D6}"/>
               </a:ext>
             </a:extLst>
           </p:cNvPr>
@@ -23683,7 +23683,7 @@
           <p:cNvPr id="5" name="이 과정의 교육 모델 · 공식 OpenAI 분류나 모든 작업에 대한 법칙이 아님">
             <a:extLst xmlns:a="http://schemas.openxmlformats.org/drawingml/2006/main">
               <a:ext uri="{FF2B5EF4-FFF2-40B4-BE49-F238E27FC236}">
-                <a16:creationId xmlns:a16="http://schemas.microsoft.com/office/drawing/2014/main" id="{2B17E361-BE10-4C53-BDB1-9D947797A501}"/>
+                <a16:creationId xmlns:a16="http://schemas.microsoft.com/office/drawing/2014/main" id="{17B72244-66E4-49AB-A797-F037C6F86089}"/>
               </a:ext>
             </a:extLst>
           </p:cNvPr>
@@ -23841,7 +23841,7 @@
           <p:cNvPr id="6" name="다섯 항목은 서로 분리된 기능이 아니라 하나의 작업 요청에 담는 책임입니다.">
             <a:extLst xmlns:a="http://schemas.openxmlformats.org/drawingml/2006/main">
               <a:ext uri="{FF2B5EF4-FFF2-40B4-BE49-F238E27FC236}">
-                <a16:creationId xmlns:a16="http://schemas.microsoft.com/office/drawing/2014/main" id="{5A4F63A1-170B-4808-AD80-54D737F5BBFD}"/>
+                <a16:creationId xmlns:a16="http://schemas.microsoft.com/office/drawing/2014/main" id="{F5700059-D3DA-4A58-B26B-4EFCF74F0F5E}"/>
               </a:ext>
             </a:extLst>
           </p:cNvPr>
@@ -23999,7 +23999,7 @@
           <p:cNvPr id="7" name="앞의 질문을 묶고, 필요한 맥락과 작업 과정을 명시한다">
             <a:extLst xmlns:a="http://schemas.openxmlformats.org/drawingml/2006/main">
               <a:ext uri="{FF2B5EF4-FFF2-40B4-BE49-F238E27FC236}">
-                <a16:creationId xmlns:a16="http://schemas.microsoft.com/office/drawing/2014/main" id="{A687ECA5-4FD0-473A-985D-390B376365A3}"/>
+                <a16:creationId xmlns:a16="http://schemas.microsoft.com/office/drawing/2014/main" id="{BDA68AA1-B3E7-4AF6-AF11-8384D0800D22}"/>
               </a:ext>
             </a:extLst>
           </p:cNvPr>
@@ -24157,7 +24157,7 @@
           <p:cNvPr id="8" name="">
             <a:extLst xmlns:a="http://schemas.openxmlformats.org/drawingml/2006/main">
               <a:ext uri="{FF2B5EF4-FFF2-40B4-BE49-F238E27FC236}">
-                <a16:creationId xmlns:a16="http://schemas.microsoft.com/office/drawing/2014/main" id="{564B5C86-EBD0-4EF7-8201-6070DF25F9B2}"/>
+                <a16:creationId xmlns:a16="http://schemas.microsoft.com/office/drawing/2014/main" id="{49836C9C-0F93-44AA-B443-A6E20F222289}"/>
               </a:ext>
             </a:extLst>
           </p:cNvPr>
@@ -24190,7 +24190,7 @@
           <p:cNvPr id="9" name="">
             <a:extLst xmlns:a="http://schemas.openxmlformats.org/drawingml/2006/main">
               <a:ext uri="{FF2B5EF4-FFF2-40B4-BE49-F238E27FC236}">
-                <a16:creationId xmlns:a16="http://schemas.microsoft.com/office/drawing/2014/main" id="{CD41420A-133B-4F89-8280-242747CE0120}"/>
+                <a16:creationId xmlns:a16="http://schemas.microsoft.com/office/drawing/2014/main" id="{D918C3DE-AAB2-4033-B0DD-64C8FCCD4B00}"/>
               </a:ext>
             </a:extLst>
           </p:cNvPr>
@@ -24221,7 +24221,7 @@
           <p:cNvPr id="10" name="하나의&#10;Task&#10;Specification">
             <a:extLst xmlns:a="http://schemas.openxmlformats.org/drawingml/2006/main">
               <a:ext uri="{FF2B5EF4-FFF2-40B4-BE49-F238E27FC236}">
-                <a16:creationId xmlns:a16="http://schemas.microsoft.com/office/drawing/2014/main" id="{80E2A665-BAEB-4BF1-A5F1-E951C7E49E41}"/>
+                <a16:creationId xmlns:a16="http://schemas.microsoft.com/office/drawing/2014/main" id="{0043DDD1-10EF-4DA4-88EB-7C5E95057B43}"/>
               </a:ext>
             </a:extLst>
           </p:cNvPr>
@@ -24425,7 +24425,7 @@
           <p:cNvPr id="11" name="목표 · Goal">
             <a:extLst xmlns:a="http://schemas.openxmlformats.org/drawingml/2006/main">
               <a:ext uri="{FF2B5EF4-FFF2-40B4-BE49-F238E27FC236}">
-                <a16:creationId xmlns:a16="http://schemas.microsoft.com/office/drawing/2014/main" id="{27BACC48-EEC1-46EC-9286-A2011BF66972}"/>
+                <a16:creationId xmlns:a16="http://schemas.microsoft.com/office/drawing/2014/main" id="{4FF61466-7EBA-4198-91C4-364224A83B14}"/>
               </a:ext>
             </a:extLst>
           </p:cNvPr>
@@ -24583,7 +24583,7 @@
           <p:cNvPr id="12" name="어떤 결과를 바꿀까?">
             <a:extLst xmlns:a="http://schemas.openxmlformats.org/drawingml/2006/main">
               <a:ext uri="{FF2B5EF4-FFF2-40B4-BE49-F238E27FC236}">
-                <a16:creationId xmlns:a16="http://schemas.microsoft.com/office/drawing/2014/main" id="{58CB8165-A825-4835-9F03-377F80968D29}"/>
+                <a16:creationId xmlns:a16="http://schemas.microsoft.com/office/drawing/2014/main" id="{9CAC549E-94AF-4C00-B992-6D2D08645478}"/>
               </a:ext>
             </a:extLst>
           </p:cNvPr>
@@ -24741,7 +24741,7 @@
           <p:cNvPr id="13" name="">
             <a:extLst xmlns:a="http://schemas.openxmlformats.org/drawingml/2006/main">
               <a:ext uri="{FF2B5EF4-FFF2-40B4-BE49-F238E27FC236}">
-                <a16:creationId xmlns:a16="http://schemas.microsoft.com/office/drawing/2014/main" id="{300CC781-20C2-47FD-ABF0-2472891525E5}"/>
+                <a16:creationId xmlns:a16="http://schemas.microsoft.com/office/drawing/2014/main" id="{F13D8791-0C40-4B38-A0BF-A8522C9B2EBF}"/>
               </a:ext>
             </a:extLst>
           </p:cNvPr>
@@ -24772,7 +24772,7 @@
           <p:cNvPr id="14" name="맥락 · Context">
             <a:extLst xmlns:a="http://schemas.openxmlformats.org/drawingml/2006/main">
               <a:ext uri="{FF2B5EF4-FFF2-40B4-BE49-F238E27FC236}">
-                <a16:creationId xmlns:a16="http://schemas.microsoft.com/office/drawing/2014/main" id="{4C745817-2426-4084-9003-D4EA1986F060}"/>
+                <a16:creationId xmlns:a16="http://schemas.microsoft.com/office/drawing/2014/main" id="{6180E964-F397-46E9-BEE8-FB37D70E4999}"/>
               </a:ext>
             </a:extLst>
           </p:cNvPr>
@@ -24930,7 +24930,7 @@
           <p:cNvPr id="15" name="이 작업에 필요한 사실은?">
             <a:extLst xmlns:a="http://schemas.openxmlformats.org/drawingml/2006/main">
               <a:ext uri="{FF2B5EF4-FFF2-40B4-BE49-F238E27FC236}">
-                <a16:creationId xmlns:a16="http://schemas.microsoft.com/office/drawing/2014/main" id="{8D76013B-19AA-4500-A6E9-4F89A131806B}"/>
+                <a16:creationId xmlns:a16="http://schemas.microsoft.com/office/drawing/2014/main" id="{19913903-FE56-4DB4-B1DB-37962D553DB6}"/>
               </a:ext>
             </a:extLst>
           </p:cNvPr>
@@ -25088,7 +25088,7 @@
           <p:cNvPr id="16" name="">
             <a:extLst xmlns:a="http://schemas.openxmlformats.org/drawingml/2006/main">
               <a:ext uri="{FF2B5EF4-FFF2-40B4-BE49-F238E27FC236}">
-                <a16:creationId xmlns:a16="http://schemas.microsoft.com/office/drawing/2014/main" id="{793AB1EB-0D46-4C4F-B5FB-4722CC6AB5C7}"/>
+                <a16:creationId xmlns:a16="http://schemas.microsoft.com/office/drawing/2014/main" id="{D253DF7A-FA34-4A70-BDE4-6015A07B7D99}"/>
               </a:ext>
             </a:extLst>
           </p:cNvPr>
@@ -25119,7 +25119,7 @@
           <p:cNvPr id="17" name="제약 · Constraints">
             <a:extLst xmlns:a="http://schemas.openxmlformats.org/drawingml/2006/main">
               <a:ext uri="{FF2B5EF4-FFF2-40B4-BE49-F238E27FC236}">
-                <a16:creationId xmlns:a16="http://schemas.microsoft.com/office/drawing/2014/main" id="{34C37C2A-6354-48EC-BE1D-8B50995967BC}"/>
+                <a16:creationId xmlns:a16="http://schemas.microsoft.com/office/drawing/2014/main" id="{17F0E656-CE8B-4BA7-8F8E-9CAB81FD10ED}"/>
               </a:ext>
             </a:extLst>
           </p:cNvPr>
@@ -25277,7 +25277,7 @@
           <p:cNvPr id="18" name="무엇을 보존할까?">
             <a:extLst xmlns:a="http://schemas.openxmlformats.org/drawingml/2006/main">
               <a:ext uri="{FF2B5EF4-FFF2-40B4-BE49-F238E27FC236}">
-                <a16:creationId xmlns:a16="http://schemas.microsoft.com/office/drawing/2014/main" id="{094CDF1C-5F04-4BE9-A0CA-B2417AD6900E}"/>
+                <a16:creationId xmlns:a16="http://schemas.microsoft.com/office/drawing/2014/main" id="{7A9C9D36-0A76-4284-B4F6-477D5BEDB458}"/>
               </a:ext>
             </a:extLst>
           </p:cNvPr>
@@ -25435,7 +25435,7 @@
           <p:cNvPr id="19" name="">
             <a:extLst xmlns:a="http://schemas.openxmlformats.org/drawingml/2006/main">
               <a:ext uri="{FF2B5EF4-FFF2-40B4-BE49-F238E27FC236}">
-                <a16:creationId xmlns:a16="http://schemas.microsoft.com/office/drawing/2014/main" id="{9A0499E5-F708-4BD7-BCEF-06D9DA98DDA0}"/>
+                <a16:creationId xmlns:a16="http://schemas.microsoft.com/office/drawing/2014/main" id="{AA3659C3-BEEB-4053-BB17-62C295830DD5}"/>
               </a:ext>
             </a:extLst>
           </p:cNvPr>
@@ -25466,7 +25466,7 @@
           <p:cNvPr id="20" name="과정 · Process">
             <a:extLst xmlns:a="http://schemas.openxmlformats.org/drawingml/2006/main">
               <a:ext uri="{FF2B5EF4-FFF2-40B4-BE49-F238E27FC236}">
-                <a16:creationId xmlns:a16="http://schemas.microsoft.com/office/drawing/2014/main" id="{23D10EFB-2E5C-430D-8685-F0B68977BB52}"/>
+                <a16:creationId xmlns:a16="http://schemas.microsoft.com/office/drawing/2014/main" id="{362E36C4-9BFE-441F-952D-AE1B145759F8}"/>
               </a:ext>
             </a:extLst>
           </p:cNvPr>
@@ -25624,7 +25624,7 @@
           <p:cNvPr id="21" name="어떤 순서·경계를 지킬까?">
             <a:extLst xmlns:a="http://schemas.openxmlformats.org/drawingml/2006/main">
               <a:ext uri="{FF2B5EF4-FFF2-40B4-BE49-F238E27FC236}">
-                <a16:creationId xmlns:a16="http://schemas.microsoft.com/office/drawing/2014/main" id="{F01AFE62-DC3B-4691-A9D4-38D1EA948AC1}"/>
+                <a16:creationId xmlns:a16="http://schemas.microsoft.com/office/drawing/2014/main" id="{85F54346-EA33-4DB8-87FB-E214B0FAF4BD}"/>
               </a:ext>
             </a:extLst>
           </p:cNvPr>
@@ -25782,7 +25782,7 @@
           <p:cNvPr id="22" name="">
             <a:extLst xmlns:a="http://schemas.openxmlformats.org/drawingml/2006/main">
               <a:ext uri="{FF2B5EF4-FFF2-40B4-BE49-F238E27FC236}">
-                <a16:creationId xmlns:a16="http://schemas.microsoft.com/office/drawing/2014/main" id="{DF3F14FD-37F8-424D-B9F7-EDE5C32AA2EB}"/>
+                <a16:creationId xmlns:a16="http://schemas.microsoft.com/office/drawing/2014/main" id="{3A2B3E57-4ECC-4AD1-A146-E2C016E4829B}"/>
               </a:ext>
             </a:extLst>
           </p:cNvPr>
@@ -25813,7 +25813,7 @@
           <p:cNvPr id="23" name="검증 · Verification">
             <a:extLst xmlns:a="http://schemas.openxmlformats.org/drawingml/2006/main">
               <a:ext uri="{FF2B5EF4-FFF2-40B4-BE49-F238E27FC236}">
-                <a16:creationId xmlns:a16="http://schemas.microsoft.com/office/drawing/2014/main" id="{EAE242B3-2D1E-4E00-8DEC-D6270511F313}"/>
+                <a16:creationId xmlns:a16="http://schemas.microsoft.com/office/drawing/2014/main" id="{6E4E20CC-81F2-48DD-9ADF-015D7BAB040E}"/>
               </a:ext>
             </a:extLst>
           </p:cNvPr>
@@ -25971,7 +25971,7 @@
           <p:cNvPr id="24" name="무엇으로 완료를 확인할까?">
             <a:extLst xmlns:a="http://schemas.openxmlformats.org/drawingml/2006/main">
               <a:ext uri="{FF2B5EF4-FFF2-40B4-BE49-F238E27FC236}">
-                <a16:creationId xmlns:a16="http://schemas.microsoft.com/office/drawing/2014/main" id="{00DAC7B1-A917-40E2-8712-71668AD86AD8}"/>
+                <a16:creationId xmlns:a16="http://schemas.microsoft.com/office/drawing/2014/main" id="{D96C6EB8-8763-4C2D-AE53-FD6882A56B5B}"/>
               </a:ext>
             </a:extLst>
           </p:cNvPr>
@@ -26129,7 +26129,7 @@
           <p:cNvPr id="25" name="Legacy module connection">
             <a:extLst xmlns:a="http://schemas.openxmlformats.org/drawingml/2006/main">
               <a:ext uri="{FF2B5EF4-FFF2-40B4-BE49-F238E27FC236}">
-                <a16:creationId xmlns:a16="http://schemas.microsoft.com/office/drawing/2014/main" id="{6381CC52-EA67-4111-B6FF-960CCE458830}"/>
+                <a16:creationId xmlns:a16="http://schemas.microsoft.com/office/drawing/2014/main" id="{C0B5E42D-75BB-4CB4-A8F5-1201E533CD27}"/>
               </a:ext>
             </a:extLst>
           </p:cNvPr>
@@ -26285,7 +26285,7 @@
     </p:spTree>
     <p:extLst>
       <p:ext uri="{BB962C8B-B14F-4D97-AF65-F5344CB8AC3E}">
-        <p14:creationId xmlns:p14="http://schemas.microsoft.com/office/powerpoint/2010/main" val="738521295"/>
+        <p14:creationId xmlns:p14="http://schemas.microsoft.com/office/powerpoint/2010/main" val="356133140"/>
       </p:ext>
     </p:extLst>
   </p:cSld>
@@ -26316,7 +26316,7 @@
           <p:cNvPr id="27" name="ACT 1 · 같은 요청을 구체화하기">
             <a:extLst xmlns:a="http://schemas.openxmlformats.org/drawingml/2006/main">
               <a:ext uri="{FF2B5EF4-FFF2-40B4-BE49-F238E27FC236}">
-                <a16:creationId xmlns:a16="http://schemas.microsoft.com/office/drawing/2014/main" id="{73CA76AD-7763-4B3B-BF64-1AF9C46BDC2D}"/>
+                <a16:creationId xmlns:a16="http://schemas.microsoft.com/office/drawing/2014/main" id="{849893CC-76D9-4B53-989B-7EB479F90DCE}"/>
               </a:ext>
             </a:extLst>
           </p:cNvPr>
@@ -26471,10 +26471,10 @@
       </p:sp>
       <p:sp>
         <p:nvSpPr>
-          <p:cNvPr id="2" name="S14">
+          <p:cNvPr id="2" name="S15">
             <a:extLst xmlns:a="http://schemas.openxmlformats.org/drawingml/2006/main">
               <a:ext uri="{FF2B5EF4-FFF2-40B4-BE49-F238E27FC236}">
-                <a16:creationId xmlns:a16="http://schemas.microsoft.com/office/drawing/2014/main" id="{7E6F9472-5CA2-41FC-A7DA-57BCC4EB406E}"/>
+                <a16:creationId xmlns:a16="http://schemas.microsoft.com/office/drawing/2014/main" id="{E27246C1-04AF-4A4B-9DEA-346F56089511}"/>
               </a:ext>
             </a:extLst>
           </p:cNvPr>
@@ -26622,7 +26622,7 @@
                 <a:ea typeface="Malgun Gothic"/>
                 <a:cs typeface="Malgun Gothic"/>
               </a:rPr>
-              <a:t>S14</a:t>
+              <a:t>S15</a:t>
             </a:r>
           </a:p>
         </p:txBody>
@@ -26632,7 +26632,7 @@
           <p:cNvPr id="3" name="더 긴 Prompt보다 분명한 경계">
             <a:extLst xmlns:a="http://schemas.openxmlformats.org/drawingml/2006/main">
               <a:ext uri="{FF2B5EF4-FFF2-40B4-BE49-F238E27FC236}">
-                <a16:creationId xmlns:a16="http://schemas.microsoft.com/office/drawing/2014/main" id="{5A8954D5-BB05-40C6-B921-B3B126F8309C}"/>
+                <a16:creationId xmlns:a16="http://schemas.microsoft.com/office/drawing/2014/main" id="{8C4BA1E5-EDF1-4D76-A874-A087ED9E4BB0}"/>
               </a:ext>
             </a:extLst>
           </p:cNvPr>
@@ -26790,7 +26790,7 @@
           <p:cNvPr id="4" name="">
             <a:extLst xmlns:a="http://schemas.openxmlformats.org/drawingml/2006/main">
               <a:ext uri="{FF2B5EF4-FFF2-40B4-BE49-F238E27FC236}">
-                <a16:creationId xmlns:a16="http://schemas.microsoft.com/office/drawing/2014/main" id="{E0D454E0-972C-4628-9A21-C7F51D34D830}"/>
+                <a16:creationId xmlns:a16="http://schemas.microsoft.com/office/drawing/2014/main" id="{56E67DAD-325C-434F-94F3-B80D79067FE3}"/>
               </a:ext>
             </a:extLst>
           </p:cNvPr>
@@ -26821,7 +26821,7 @@
           <p:cNvPr id="5" name="교육용 Before / After · 실제 Trial Prompt나 우월성 비교 실험이 아님">
             <a:extLst xmlns:a="http://schemas.openxmlformats.org/drawingml/2006/main">
               <a:ext uri="{FF2B5EF4-FFF2-40B4-BE49-F238E27FC236}">
-                <a16:creationId xmlns:a16="http://schemas.microsoft.com/office/drawing/2014/main" id="{D50ACCCB-4CA5-4A2A-BDBB-049D6175FE0D}"/>
+                <a16:creationId xmlns:a16="http://schemas.microsoft.com/office/drawing/2014/main" id="{A4D59BBD-93E9-48BD-92AB-27E2837CAAC6}"/>
               </a:ext>
             </a:extLst>
           </p:cNvPr>
@@ -26979,7 +26979,7 @@
           <p:cNvPr id="6" name="완료 조건과 C++ 적용은 교육용 예시입니다. 특정 Windows·빌드 환경을 검증한 것은 아닙니다.">
             <a:extLst xmlns:a="http://schemas.openxmlformats.org/drawingml/2006/main">
               <a:ext uri="{FF2B5EF4-FFF2-40B4-BE49-F238E27FC236}">
-                <a16:creationId xmlns:a16="http://schemas.microsoft.com/office/drawing/2014/main" id="{4CF27AEB-E057-4AA4-A460-1D13C435C8A0}"/>
+                <a16:creationId xmlns:a16="http://schemas.microsoft.com/office/drawing/2014/main" id="{049F69B4-F926-4056-9835-90BCFC497F89}"/>
               </a:ext>
             </a:extLst>
           </p:cNvPr>
@@ -27137,7 +27137,7 @@
           <p:cNvPr id="7" name="처음 요청">
             <a:extLst xmlns:a="http://schemas.openxmlformats.org/drawingml/2006/main">
               <a:ext uri="{FF2B5EF4-FFF2-40B4-BE49-F238E27FC236}">
-                <a16:creationId xmlns:a16="http://schemas.microsoft.com/office/drawing/2014/main" id="{FE7DD6F1-5FE0-480D-9809-223B9D9358DB}"/>
+                <a16:creationId xmlns:a16="http://schemas.microsoft.com/office/drawing/2014/main" id="{35EC2796-6438-489C-8627-E8944AF64D47}"/>
               </a:ext>
             </a:extLst>
           </p:cNvPr>
@@ -27295,7 +27295,7 @@
           <p:cNvPr id="8" name="“crop test&#10;고쳐줘.”">
             <a:extLst xmlns:a="http://schemas.openxmlformats.org/drawingml/2006/main">
               <a:ext uri="{FF2B5EF4-FFF2-40B4-BE49-F238E27FC236}">
-                <a16:creationId xmlns:a16="http://schemas.microsoft.com/office/drawing/2014/main" id="{89FB8B1E-41A8-4805-A4C9-103E8FDC4108}"/>
+                <a16:creationId xmlns:a16="http://schemas.microsoft.com/office/drawing/2014/main" id="{376AC6B6-01AC-4104-9305-6350515AF43C}"/>
               </a:ext>
             </a:extLst>
           </p:cNvPr>
@@ -27476,7 +27476,7 @@
           <p:cNvPr id="9" name="">
             <a:extLst xmlns:a="http://schemas.openxmlformats.org/drawingml/2006/main">
               <a:ext uri="{FF2B5EF4-FFF2-40B4-BE49-F238E27FC236}">
-                <a16:creationId xmlns:a16="http://schemas.microsoft.com/office/drawing/2014/main" id="{E0CA56ED-300D-422B-8AA3-9D431222FFC6}"/>
+                <a16:creationId xmlns:a16="http://schemas.microsoft.com/office/drawing/2014/main" id="{977C646E-BDBF-44E4-BDC6-6F6490D9C857}"/>
               </a:ext>
             </a:extLst>
           </p:cNvPr>
@@ -27506,7 +27506,7 @@
           <p:cNvPr id="10" name="추가한 정보">
             <a:extLst xmlns:a="http://schemas.openxmlformats.org/drawingml/2006/main">
               <a:ext uri="{FF2B5EF4-FFF2-40B4-BE49-F238E27FC236}">
-                <a16:creationId xmlns:a16="http://schemas.microsoft.com/office/drawing/2014/main" id="{D9D4AD7C-3465-4592-BB40-FE5FC037484D}"/>
+                <a16:creationId xmlns:a16="http://schemas.microsoft.com/office/drawing/2014/main" id="{AFF61633-7ED0-4F1A-A827-DEE5494F6034}"/>
               </a:ext>
             </a:extLst>
           </p:cNvPr>
@@ -27664,7 +27664,7 @@
           <p:cNvPr id="11" name="">
             <a:extLst xmlns:a="http://schemas.openxmlformats.org/drawingml/2006/main">
               <a:ext uri="{FF2B5EF4-FFF2-40B4-BE49-F238E27FC236}">
-                <a16:creationId xmlns:a16="http://schemas.microsoft.com/office/drawing/2014/main" id="{6633032E-A812-432F-A63B-A6315FA3462E}"/>
+                <a16:creationId xmlns:a16="http://schemas.microsoft.com/office/drawing/2014/main" id="{3718F6C3-2589-4AEA-8A10-6C90221F7F2C}"/>
               </a:ext>
             </a:extLst>
           </p:cNvPr>
@@ -27695,7 +27695,7 @@
           <p:cNvPr id="12" name="목표·맥락">
             <a:extLst xmlns:a="http://schemas.openxmlformats.org/drawingml/2006/main">
               <a:ext uri="{FF2B5EF4-FFF2-40B4-BE49-F238E27FC236}">
-                <a16:creationId xmlns:a16="http://schemas.microsoft.com/office/drawing/2014/main" id="{DF7D2D0D-D054-47B4-BC7D-62BF4A86F5B9}"/>
+                <a16:creationId xmlns:a16="http://schemas.microsoft.com/office/drawing/2014/main" id="{967E75E3-78F9-4AC3-807A-8AFC71FB0DD8}"/>
               </a:ext>
             </a:extLst>
           </p:cNvPr>
@@ -27853,7 +27853,7 @@
           <p:cNvPr id="13" name="crop 경계 실패를 조사·수정한다.">
             <a:extLst xmlns:a="http://schemas.openxmlformats.org/drawingml/2006/main">
               <a:ext uri="{FF2B5EF4-FFF2-40B4-BE49-F238E27FC236}">
-                <a16:creationId xmlns:a16="http://schemas.microsoft.com/office/drawing/2014/main" id="{FCB018E4-5257-4828-8BF2-0496EE7F6245}"/>
+                <a16:creationId xmlns:a16="http://schemas.microsoft.com/office/drawing/2014/main" id="{287098EA-477B-48E2-BE28-7CBF673A69E3}"/>
               </a:ext>
             </a:extLst>
           </p:cNvPr>
@@ -28011,7 +28011,7 @@
           <p:cNvPr id="14" name="">
             <a:extLst xmlns:a="http://schemas.openxmlformats.org/drawingml/2006/main">
               <a:ext uri="{FF2B5EF4-FFF2-40B4-BE49-F238E27FC236}">
-                <a16:creationId xmlns:a16="http://schemas.microsoft.com/office/drawing/2014/main" id="{1D5F672C-B379-405C-8582-1BB1A4C9BB10}"/>
+                <a16:creationId xmlns:a16="http://schemas.microsoft.com/office/drawing/2014/main" id="{F6F01A7B-02C8-4DBD-93E7-5EF3839124E7}"/>
               </a:ext>
             </a:extLst>
           </p:cNvPr>
@@ -28042,7 +28042,7 @@
           <p:cNvPr id="15" name="제약">
             <a:extLst xmlns:a="http://schemas.openxmlformats.org/drawingml/2006/main">
               <a:ext uri="{FF2B5EF4-FFF2-40B4-BE49-F238E27FC236}">
-                <a16:creationId xmlns:a16="http://schemas.microsoft.com/office/drawing/2014/main" id="{8409448C-3D95-486D-81DD-51FD12C81C17}"/>
+                <a16:creationId xmlns:a16="http://schemas.microsoft.com/office/drawing/2014/main" id="{06D6B8F9-478D-4DB8-BD4F-0D811FC152AF}"/>
               </a:ext>
             </a:extLst>
           </p:cNvPr>
@@ -28200,7 +28200,7 @@
           <p:cNvPr id="16" name="끝 좌표 제외, 무관한 API·의존성 유지">
             <a:extLst xmlns:a="http://schemas.openxmlformats.org/drawingml/2006/main">
               <a:ext uri="{FF2B5EF4-FFF2-40B4-BE49-F238E27FC236}">
-                <a16:creationId xmlns:a16="http://schemas.microsoft.com/office/drawing/2014/main" id="{9D470903-4FDB-4DC9-8442-94E148ABF4AE}"/>
+                <a16:creationId xmlns:a16="http://schemas.microsoft.com/office/drawing/2014/main" id="{D17325C2-52B7-473C-9B78-DA4DBEDE396E}"/>
               </a:ext>
             </a:extLst>
           </p:cNvPr>
@@ -28358,7 +28358,7 @@
           <p:cNvPr id="17" name="">
             <a:extLst xmlns:a="http://schemas.openxmlformats.org/drawingml/2006/main">
               <a:ext uri="{FF2B5EF4-FFF2-40B4-BE49-F238E27FC236}">
-                <a16:creationId xmlns:a16="http://schemas.microsoft.com/office/drawing/2014/main" id="{EC6AE379-7E2A-4A6E-B570-98520BDB0F2A}"/>
+                <a16:creationId xmlns:a16="http://schemas.microsoft.com/office/drawing/2014/main" id="{330FB556-EAA3-4668-94EB-6B6F0BE63E13}"/>
               </a:ext>
             </a:extLst>
           </p:cNvPr>
@@ -28389,7 +28389,7 @@
           <p:cNvPr id="18" name="과정">
             <a:extLst xmlns:a="http://schemas.openxmlformats.org/drawingml/2006/main">
               <a:ext uri="{FF2B5EF4-FFF2-40B4-BE49-F238E27FC236}">
-                <a16:creationId xmlns:a16="http://schemas.microsoft.com/office/drawing/2014/main" id="{4512FBB1-98AE-4AEE-8D62-08CE73256554}"/>
+                <a16:creationId xmlns:a16="http://schemas.microsoft.com/office/drawing/2014/main" id="{D76AB4FD-D1AA-481B-B7FE-117976A760A6}"/>
               </a:ext>
             </a:extLst>
           </p:cNvPr>
@@ -28547,7 +28547,7 @@
           <p:cNvPr id="19" name="재현 → 조사 → 계획 → 최소 수정">
             <a:extLst xmlns:a="http://schemas.openxmlformats.org/drawingml/2006/main">
               <a:ext uri="{FF2B5EF4-FFF2-40B4-BE49-F238E27FC236}">
-                <a16:creationId xmlns:a16="http://schemas.microsoft.com/office/drawing/2014/main" id="{F5CE59E1-F9AF-4CB7-8AB8-9C4C1E70BA30}"/>
+                <a16:creationId xmlns:a16="http://schemas.microsoft.com/office/drawing/2014/main" id="{4693E2D5-B887-4D11-B87D-96042934EC7E}"/>
               </a:ext>
             </a:extLst>
           </p:cNvPr>
@@ -28705,7 +28705,7 @@
           <p:cNvPr id="20" name="">
             <a:extLst xmlns:a="http://schemas.openxmlformats.org/drawingml/2006/main">
               <a:ext uri="{FF2B5EF4-FFF2-40B4-BE49-F238E27FC236}">
-                <a16:creationId xmlns:a16="http://schemas.microsoft.com/office/drawing/2014/main" id="{E931F101-62AF-4A12-AF12-F138407F0BE2}"/>
+                <a16:creationId xmlns:a16="http://schemas.microsoft.com/office/drawing/2014/main" id="{936169F8-4257-4F35-AF58-495D7839043C}"/>
               </a:ext>
             </a:extLst>
           </p:cNvPr>
@@ -28736,7 +28736,7 @@
           <p:cNvPr id="21" name="검증">
             <a:extLst xmlns:a="http://schemas.openxmlformats.org/drawingml/2006/main">
               <a:ext uri="{FF2B5EF4-FFF2-40B4-BE49-F238E27FC236}">
-                <a16:creationId xmlns:a16="http://schemas.microsoft.com/office/drawing/2014/main" id="{0DF70098-B97B-4D0F-929C-C24000D9EC7A}"/>
+                <a16:creationId xmlns:a16="http://schemas.microsoft.com/office/drawing/2014/main" id="{9D4E27D3-C419-41CA-BF64-D052C10EA697}"/>
               </a:ext>
             </a:extLst>
           </p:cNvPr>
@@ -28894,7 +28894,7 @@
           <p:cNvPr id="22" name="집중·전체 Test + CLI smoke + diff">
             <a:extLst xmlns:a="http://schemas.openxmlformats.org/drawingml/2006/main">
               <a:ext uri="{FF2B5EF4-FFF2-40B4-BE49-F238E27FC236}">
-                <a16:creationId xmlns:a16="http://schemas.microsoft.com/office/drawing/2014/main" id="{49620E6E-0A7F-46FD-A8D4-212A3220C6DC}"/>
+                <a16:creationId xmlns:a16="http://schemas.microsoft.com/office/drawing/2014/main" id="{3225672A-EC56-4CB9-8B89-01B547A88949}"/>
               </a:ext>
             </a:extLst>
           </p:cNvPr>
@@ -29052,7 +29052,7 @@
           <p:cNvPr id="23" name="">
             <a:extLst xmlns:a="http://schemas.openxmlformats.org/drawingml/2006/main">
               <a:ext uri="{FF2B5EF4-FFF2-40B4-BE49-F238E27FC236}">
-                <a16:creationId xmlns:a16="http://schemas.microsoft.com/office/drawing/2014/main" id="{D9B46A70-035C-4DEA-8CA6-1EB0229DB512}"/>
+                <a16:creationId xmlns:a16="http://schemas.microsoft.com/office/drawing/2014/main" id="{9DDEFF24-9526-406A-BAAB-98CA9E4CB73A}"/>
               </a:ext>
             </a:extLst>
           </p:cNvPr>
@@ -29083,7 +29083,7 @@
           <p:cNvPr id="24" name="완료 조건 예 · 4열 입력의 crop 1 3 → 원본 열 1·2, 폭 2">
             <a:extLst xmlns:a="http://schemas.openxmlformats.org/drawingml/2006/main">
               <a:ext uri="{FF2B5EF4-FFF2-40B4-BE49-F238E27FC236}">
-                <a16:creationId xmlns:a16="http://schemas.microsoft.com/office/drawing/2014/main" id="{131DC856-E423-47FA-8E35-5761E1221647}"/>
+                <a16:creationId xmlns:a16="http://schemas.microsoft.com/office/drawing/2014/main" id="{5C354C58-DE58-4B7E-ABD9-E5877FAA7540}"/>
               </a:ext>
             </a:extLst>
           </p:cNvPr>
@@ -29241,7 +29241,7 @@
           <p:cNvPr id="25" name="C++에도: 출력·API/ABI 보존 범위와 Release 검증 조건을 먼저 정한다.">
             <a:extLst xmlns:a="http://schemas.openxmlformats.org/drawingml/2006/main">
               <a:ext uri="{FF2B5EF4-FFF2-40B4-BE49-F238E27FC236}">
-                <a16:creationId xmlns:a16="http://schemas.microsoft.com/office/drawing/2014/main" id="{130A0277-93DD-40A4-8128-904E250D0E67}"/>
+                <a16:creationId xmlns:a16="http://schemas.microsoft.com/office/drawing/2014/main" id="{9226942B-9E55-487C-A87F-1E4072145A3A}"/>
               </a:ext>
             </a:extLst>
           </p:cNvPr>
@@ -29399,7 +29399,7 @@
           <p:cNvPr id="26" name="Legacy module connection">
             <a:extLst xmlns:a="http://schemas.openxmlformats.org/drawingml/2006/main">
               <a:ext uri="{FF2B5EF4-FFF2-40B4-BE49-F238E27FC236}">
-                <a16:creationId xmlns:a16="http://schemas.microsoft.com/office/drawing/2014/main" id="{3108B8EC-2A69-464B-8DF9-90577919DAA0}"/>
+                <a16:creationId xmlns:a16="http://schemas.microsoft.com/office/drawing/2014/main" id="{8B726A3C-8C9E-4332-93BC-F5B7F65C0EDC}"/>
               </a:ext>
             </a:extLst>
           </p:cNvPr>
@@ -29555,7 +29555,7 @@
     </p:spTree>
     <p:extLst>
       <p:ext uri="{BB962C8B-B14F-4D97-AF65-F5344CB8AC3E}">
-        <p14:creationId xmlns:p14="http://schemas.microsoft.com/office/powerpoint/2010/main" val="231983631"/>
+        <p14:creationId xmlns:p14="http://schemas.microsoft.com/office/powerpoint/2010/main" val="1153287093"/>
       </p:ext>
     </p:extLst>
   </p:cSld>
@@ -29586,7 +29586,7 @@
           <p:cNvPr id="30" name="ACT 1 · TRIAL-002 관찰 시작">
             <a:extLst xmlns:a="http://schemas.openxmlformats.org/drawingml/2006/main">
               <a:ext uri="{FF2B5EF4-FFF2-40B4-BE49-F238E27FC236}">
-                <a16:creationId xmlns:a16="http://schemas.microsoft.com/office/drawing/2014/main" id="{61A063B7-7917-44E0-A507-6BCDFFE85699}"/>
+                <a16:creationId xmlns:a16="http://schemas.microsoft.com/office/drawing/2014/main" id="{09694CC1-4B8B-4608-8944-26382A61F2C5}"/>
               </a:ext>
             </a:extLst>
           </p:cNvPr>
@@ -29741,10 +29741,10 @@
       </p:sp>
       <p:sp>
         <p:nvSpPr>
-          <p:cNvPr id="2" name="S15">
+          <p:cNvPr id="2" name="S16">
             <a:extLst xmlns:a="http://schemas.openxmlformats.org/drawingml/2006/main">
               <a:ext uri="{FF2B5EF4-FFF2-40B4-BE49-F238E27FC236}">
-                <a16:creationId xmlns:a16="http://schemas.microsoft.com/office/drawing/2014/main" id="{672F21BB-57A6-4B8C-B2A7-8233CFC672FE}"/>
+                <a16:creationId xmlns:a16="http://schemas.microsoft.com/office/drawing/2014/main" id="{33649A2C-822E-40C9-8EDF-A9D4338B2BE6}"/>
               </a:ext>
             </a:extLst>
           </p:cNvPr>
@@ -29892,7 +29892,7 @@
                 <a:ea typeface="Malgun Gothic"/>
                 <a:cs typeface="Malgun Gothic"/>
               </a:rPr>
-              <a:t>S15</a:t>
+              <a:t>S16</a:t>
             </a:r>
           </a:p>
         </p:txBody>
@@ -29902,7 +29902,7 @@
           <p:cNvPr id="3" name="먼저 무엇을 하는지 보자">
             <a:extLst xmlns:a="http://schemas.openxmlformats.org/drawingml/2006/main">
               <a:ext uri="{FF2B5EF4-FFF2-40B4-BE49-F238E27FC236}">
-                <a16:creationId xmlns:a16="http://schemas.microsoft.com/office/drawing/2014/main" id="{D8B45E8C-5A41-4007-94F0-4C571CD5DFF6}"/>
+                <a16:creationId xmlns:a16="http://schemas.microsoft.com/office/drawing/2014/main" id="{005FAB4A-F596-46F6-8FA5-453E21668C45}"/>
               </a:ext>
             </a:extLst>
           </p:cNvPr>
@@ -30060,7 +30060,7 @@
           <p:cNvPr id="4" name="">
             <a:extLst xmlns:a="http://schemas.openxmlformats.org/drawingml/2006/main">
               <a:ext uri="{FF2B5EF4-FFF2-40B4-BE49-F238E27FC236}">
-                <a16:creationId xmlns:a16="http://schemas.microsoft.com/office/drawing/2014/main" id="{B62416E4-AB74-40A3-9E1F-274D8766DF4E}"/>
+                <a16:creationId xmlns:a16="http://schemas.microsoft.com/office/drawing/2014/main" id="{8BEEC521-32AF-4B34-9C3F-CA1E0BB55FDB}"/>
               </a:ext>
             </a:extLst>
           </p:cNvPr>
@@ -30091,7 +30091,7 @@
           <p:cNvPr id="5" name="TRIAL-002 관찰 기준 · 2026-09-28 · Codex CLI 0.154.0 · macOS">
             <a:extLst xmlns:a="http://schemas.openxmlformats.org/drawingml/2006/main">
               <a:ext uri="{FF2B5EF4-FFF2-40B4-BE49-F238E27FC236}">
-                <a16:creationId xmlns:a16="http://schemas.microsoft.com/office/drawing/2014/main" id="{53D243B0-0E93-411F-9D71-18309CCEE488}"/>
+                <a16:creationId xmlns:a16="http://schemas.microsoft.com/office/drawing/2014/main" id="{6ABE02E3-E350-4D21-8E52-59D081936993}"/>
               </a:ext>
             </a:extLst>
           </p:cNvPr>
@@ -30249,7 +30249,7 @@
           <p:cNvPr id="6" name="단일 과거 CLI 기록을 살펴봅니다. 현재 Desktop 실행이나 반복성을 입증하지 않습니다.">
             <a:extLst xmlns:a="http://schemas.openxmlformats.org/drawingml/2006/main">
               <a:ext uri="{FF2B5EF4-FFF2-40B4-BE49-F238E27FC236}">
-                <a16:creationId xmlns:a16="http://schemas.microsoft.com/office/drawing/2014/main" id="{E386D7B7-EC26-46EB-A175-172898BEBEDD}"/>
+                <a16:creationId xmlns:a16="http://schemas.microsoft.com/office/drawing/2014/main" id="{1C6E3E81-5A74-404E-B0E0-635EA69F015C}"/>
               </a:ext>
             </a:extLst>
           </p:cNvPr>
@@ -30407,7 +30407,7 @@
           <p:cNvPr id="7" name="“실제 기록에서는 수정 전에 무엇을 했을까?”">
             <a:extLst xmlns:a="http://schemas.openxmlformats.org/drawingml/2006/main">
               <a:ext uri="{FF2B5EF4-FFF2-40B4-BE49-F238E27FC236}">
-                <a16:creationId xmlns:a16="http://schemas.microsoft.com/office/drawing/2014/main" id="{2D79004B-5C47-4A29-BB3C-4F07CCF9F45C}"/>
+                <a16:creationId xmlns:a16="http://schemas.microsoft.com/office/drawing/2014/main" id="{75FC6F13-1CF6-419A-A0C8-34BBD8F33AE3}"/>
               </a:ext>
             </a:extLst>
           </p:cNvPr>
@@ -30565,7 +30565,7 @@
           <p:cNvPr id="8" name="01">
             <a:extLst xmlns:a="http://schemas.openxmlformats.org/drawingml/2006/main">
               <a:ext uri="{FF2B5EF4-FFF2-40B4-BE49-F238E27FC236}">
-                <a16:creationId xmlns:a16="http://schemas.microsoft.com/office/drawing/2014/main" id="{A055ABCB-795B-4485-AB2D-002598137E7A}"/>
+                <a16:creationId xmlns:a16="http://schemas.microsoft.com/office/drawing/2014/main" id="{C699A5DE-417A-4BCB-9525-08B1A13B23AB}"/>
               </a:ext>
             </a:extLst>
           </p:cNvPr>
@@ -30723,7 +30723,7 @@
           <p:cNvPr id="9" name="재현">
             <a:extLst xmlns:a="http://schemas.openxmlformats.org/drawingml/2006/main">
               <a:ext uri="{FF2B5EF4-FFF2-40B4-BE49-F238E27FC236}">
-                <a16:creationId xmlns:a16="http://schemas.microsoft.com/office/drawing/2014/main" id="{6D57F304-1331-423D-A6EC-F05C93B72A95}"/>
+                <a16:creationId xmlns:a16="http://schemas.microsoft.com/office/drawing/2014/main" id="{A623E5DF-04E0-4A45-8BB3-E02E463FC679}"/>
               </a:ext>
             </a:extLst>
           </p:cNvPr>
@@ -30881,7 +30881,7 @@
           <p:cNvPr id="10" name="실패 확인">
             <a:extLst xmlns:a="http://schemas.openxmlformats.org/drawingml/2006/main">
               <a:ext uri="{FF2B5EF4-FFF2-40B4-BE49-F238E27FC236}">
-                <a16:creationId xmlns:a16="http://schemas.microsoft.com/office/drawing/2014/main" id="{A4D6BD7B-A979-428F-8262-CD4FD45F4FE2}"/>
+                <a16:creationId xmlns:a16="http://schemas.microsoft.com/office/drawing/2014/main" id="{CCB46D64-1F71-4182-8D74-FD5147720973}"/>
               </a:ext>
             </a:extLst>
           </p:cNvPr>
@@ -31039,7 +31039,7 @@
           <p:cNvPr id="11" name="">
             <a:extLst xmlns:a="http://schemas.openxmlformats.org/drawingml/2006/main">
               <a:ext uri="{FF2B5EF4-FFF2-40B4-BE49-F238E27FC236}">
-                <a16:creationId xmlns:a16="http://schemas.microsoft.com/office/drawing/2014/main" id="{E3248D62-1995-4A42-AF31-3A43A6262B44}"/>
+                <a16:creationId xmlns:a16="http://schemas.microsoft.com/office/drawing/2014/main" id="{16475CCE-171A-4333-A7C7-5BDEB81DD164}"/>
               </a:ext>
             </a:extLst>
           </p:cNvPr>
@@ -31069,7 +31069,7 @@
           <p:cNvPr id="12" name="02">
             <a:extLst xmlns:a="http://schemas.openxmlformats.org/drawingml/2006/main">
               <a:ext uri="{FF2B5EF4-FFF2-40B4-BE49-F238E27FC236}">
-                <a16:creationId xmlns:a16="http://schemas.microsoft.com/office/drawing/2014/main" id="{DE6E6F6C-0BE4-4AA8-BE02-EE78694C095F}"/>
+                <a16:creationId xmlns:a16="http://schemas.microsoft.com/office/drawing/2014/main" id="{BA7D92C1-3AB9-487F-81B6-67C8432274AA}"/>
               </a:ext>
             </a:extLst>
           </p:cNvPr>
@@ -31227,7 +31227,7 @@
           <p:cNvPr id="13" name="조사">
             <a:extLst xmlns:a="http://schemas.openxmlformats.org/drawingml/2006/main">
               <a:ext uri="{FF2B5EF4-FFF2-40B4-BE49-F238E27FC236}">
-                <a16:creationId xmlns:a16="http://schemas.microsoft.com/office/drawing/2014/main" id="{D6E011DE-05A7-4E91-94DD-43D629EA68A2}"/>
+                <a16:creationId xmlns:a16="http://schemas.microsoft.com/office/drawing/2014/main" id="{9E790B3E-7AE9-48AE-BF76-2E86269E64D7}"/>
               </a:ext>
             </a:extLst>
           </p:cNvPr>
@@ -31385,7 +31385,7 @@
           <p:cNvPr id="14" name="근거 연결">
             <a:extLst xmlns:a="http://schemas.openxmlformats.org/drawingml/2006/main">
               <a:ext uri="{FF2B5EF4-FFF2-40B4-BE49-F238E27FC236}">
-                <a16:creationId xmlns:a16="http://schemas.microsoft.com/office/drawing/2014/main" id="{BB932501-96B8-4E14-AD49-7363BFDBEAA6}"/>
+                <a16:creationId xmlns:a16="http://schemas.microsoft.com/office/drawing/2014/main" id="{90B8533B-BC64-4340-96E3-120842FA2CBC}"/>
               </a:ext>
             </a:extLst>
           </p:cNvPr>
@@ -31543,7 +31543,7 @@
           <p:cNvPr id="15" name="">
             <a:extLst xmlns:a="http://schemas.openxmlformats.org/drawingml/2006/main">
               <a:ext uri="{FF2B5EF4-FFF2-40B4-BE49-F238E27FC236}">
-                <a16:creationId xmlns:a16="http://schemas.microsoft.com/office/drawing/2014/main" id="{492E6524-FAC6-4156-80BF-146BD1D2CB3F}"/>
+                <a16:creationId xmlns:a16="http://schemas.microsoft.com/office/drawing/2014/main" id="{CD4BABE3-F869-41B0-9114-D20A56807B9D}"/>
               </a:ext>
             </a:extLst>
           </p:cNvPr>
@@ -31573,7 +31573,7 @@
           <p:cNvPr id="16" name="03">
             <a:extLst xmlns:a="http://schemas.openxmlformats.org/drawingml/2006/main">
               <a:ext uri="{FF2B5EF4-FFF2-40B4-BE49-F238E27FC236}">
-                <a16:creationId xmlns:a16="http://schemas.microsoft.com/office/drawing/2014/main" id="{C9F4DAED-2164-4D49-BAE1-E21F7CD24535}"/>
+                <a16:creationId xmlns:a16="http://schemas.microsoft.com/office/drawing/2014/main" id="{3856840D-11A4-44F1-B516-5F188D61308D}"/>
               </a:ext>
             </a:extLst>
           </p:cNvPr>
@@ -31731,7 +31731,7 @@
           <p:cNvPr id="17" name="계획">
             <a:extLst xmlns:a="http://schemas.openxmlformats.org/drawingml/2006/main">
               <a:ext uri="{FF2B5EF4-FFF2-40B4-BE49-F238E27FC236}">
-                <a16:creationId xmlns:a16="http://schemas.microsoft.com/office/drawing/2014/main" id="{BCF2BF14-9FFE-4004-8881-7E8994B50CC3}"/>
+                <a16:creationId xmlns:a16="http://schemas.microsoft.com/office/drawing/2014/main" id="{CF2E6E63-4C3A-4954-B8B2-08653C9B0BCD}"/>
               </a:ext>
             </a:extLst>
           </p:cNvPr>
@@ -31889,7 +31889,7 @@
           <p:cNvPr id="18" name="수정 전 설명">
             <a:extLst xmlns:a="http://schemas.openxmlformats.org/drawingml/2006/main">
               <a:ext uri="{FF2B5EF4-FFF2-40B4-BE49-F238E27FC236}">
-                <a16:creationId xmlns:a16="http://schemas.microsoft.com/office/drawing/2014/main" id="{4B650F9C-C1BD-442B-87FC-C5348571322A}"/>
+                <a16:creationId xmlns:a16="http://schemas.microsoft.com/office/drawing/2014/main" id="{74264087-AAFA-45D0-994F-896639D51D9B}"/>
               </a:ext>
             </a:extLst>
           </p:cNvPr>
@@ -32047,7 +32047,7 @@
           <p:cNvPr id="19" name="">
             <a:extLst xmlns:a="http://schemas.openxmlformats.org/drawingml/2006/main">
               <a:ext uri="{FF2B5EF4-FFF2-40B4-BE49-F238E27FC236}">
-                <a16:creationId xmlns:a16="http://schemas.microsoft.com/office/drawing/2014/main" id="{661250B0-2578-436E-8149-FF0707AE9D29}"/>
+                <a16:creationId xmlns:a16="http://schemas.microsoft.com/office/drawing/2014/main" id="{A81811F8-D974-4045-95D0-C4C2D1D12FE6}"/>
               </a:ext>
             </a:extLst>
           </p:cNvPr>
@@ -32077,7 +32077,7 @@
           <p:cNvPr id="20" name="04">
             <a:extLst xmlns:a="http://schemas.openxmlformats.org/drawingml/2006/main">
               <a:ext uri="{FF2B5EF4-FFF2-40B4-BE49-F238E27FC236}">
-                <a16:creationId xmlns:a16="http://schemas.microsoft.com/office/drawing/2014/main" id="{7276FBF4-CC7D-4F80-BC8E-18692EB0E325}"/>
+                <a16:creationId xmlns:a16="http://schemas.microsoft.com/office/drawing/2014/main" id="{915558D2-729F-4DC0-97AF-B85AA6F56046}"/>
               </a:ext>
             </a:extLst>
           </p:cNvPr>
@@ -32235,7 +32235,7 @@
           <p:cNvPr id="21" name="수정">
             <a:extLst xmlns:a="http://schemas.openxmlformats.org/drawingml/2006/main">
               <a:ext uri="{FF2B5EF4-FFF2-40B4-BE49-F238E27FC236}">
-                <a16:creationId xmlns:a16="http://schemas.microsoft.com/office/drawing/2014/main" id="{A6F361C2-D64A-4195-B50B-745881D4FB5E}"/>
+                <a16:creationId xmlns:a16="http://schemas.microsoft.com/office/drawing/2014/main" id="{0BC844FB-ECAD-49E3-9955-510510CF2DE3}"/>
               </a:ext>
             </a:extLst>
           </p:cNvPr>
@@ -32393,7 +32393,7 @@
           <p:cNvPr id="22" name="최소 변경">
             <a:extLst xmlns:a="http://schemas.openxmlformats.org/drawingml/2006/main">
               <a:ext uri="{FF2B5EF4-FFF2-40B4-BE49-F238E27FC236}">
-                <a16:creationId xmlns:a16="http://schemas.microsoft.com/office/drawing/2014/main" id="{CD8DFF44-0F3A-4AA1-A31E-2517F4A01FB1}"/>
+                <a16:creationId xmlns:a16="http://schemas.microsoft.com/office/drawing/2014/main" id="{531C54F1-A120-4949-A79E-37AC0D3BCF25}"/>
               </a:ext>
             </a:extLst>
           </p:cNvPr>
@@ -32551,7 +32551,7 @@
           <p:cNvPr id="23" name="">
             <a:extLst xmlns:a="http://schemas.openxmlformats.org/drawingml/2006/main">
               <a:ext uri="{FF2B5EF4-FFF2-40B4-BE49-F238E27FC236}">
-                <a16:creationId xmlns:a16="http://schemas.microsoft.com/office/drawing/2014/main" id="{A75033FC-BF6F-4B0E-8B4F-052DC7C3196B}"/>
+                <a16:creationId xmlns:a16="http://schemas.microsoft.com/office/drawing/2014/main" id="{A2592D0D-8A6F-4C2D-A27D-79FE57433C1E}"/>
               </a:ext>
             </a:extLst>
           </p:cNvPr>
@@ -32581,7 +32581,7 @@
           <p:cNvPr id="24" name="05">
             <a:extLst xmlns:a="http://schemas.openxmlformats.org/drawingml/2006/main">
               <a:ext uri="{FF2B5EF4-FFF2-40B4-BE49-F238E27FC236}">
-                <a16:creationId xmlns:a16="http://schemas.microsoft.com/office/drawing/2014/main" id="{7008D000-A2A4-4233-953D-3E16A516BDC5}"/>
+                <a16:creationId xmlns:a16="http://schemas.microsoft.com/office/drawing/2014/main" id="{516F918D-F1F5-4346-B06B-4A541C0ECB7B}"/>
               </a:ext>
             </a:extLst>
           </p:cNvPr>
@@ -32739,7 +32739,7 @@
           <p:cNvPr id="25" name="검증">
             <a:extLst xmlns:a="http://schemas.openxmlformats.org/drawingml/2006/main">
               <a:ext uri="{FF2B5EF4-FFF2-40B4-BE49-F238E27FC236}">
-                <a16:creationId xmlns:a16="http://schemas.microsoft.com/office/drawing/2014/main" id="{6B5B049E-00BB-4276-BFE1-87D2267A7AA0}"/>
+                <a16:creationId xmlns:a16="http://schemas.microsoft.com/office/drawing/2014/main" id="{37A3BE51-4451-4647-818A-08E75288D1EF}"/>
               </a:ext>
             </a:extLst>
           </p:cNvPr>
@@ -32897,7 +32897,7 @@
           <p:cNvPr id="26" name="결과 확인">
             <a:extLst xmlns:a="http://schemas.openxmlformats.org/drawingml/2006/main">
               <a:ext uri="{FF2B5EF4-FFF2-40B4-BE49-F238E27FC236}">
-                <a16:creationId xmlns:a16="http://schemas.microsoft.com/office/drawing/2014/main" id="{0A65BD47-2C9D-4076-8120-B6FD5E6E53B5}"/>
+                <a16:creationId xmlns:a16="http://schemas.microsoft.com/office/drawing/2014/main" id="{5B8F8985-0A4D-4450-9DB5-179161C794FB}"/>
               </a:ext>
             </a:extLst>
           </p:cNvPr>
@@ -33055,7 +33055,7 @@
           <p:cNvPr id="27" name="">
             <a:extLst xmlns:a="http://schemas.openxmlformats.org/drawingml/2006/main">
               <a:ext uri="{FF2B5EF4-FFF2-40B4-BE49-F238E27FC236}">
-                <a16:creationId xmlns:a16="http://schemas.microsoft.com/office/drawing/2014/main" id="{CF87EF38-FCBF-4150-8A4A-3F19A83E6231}"/>
+                <a16:creationId xmlns:a16="http://schemas.microsoft.com/office/drawing/2014/main" id="{636F41F2-5884-4C7D-8879-95127421B6F8}"/>
               </a:ext>
             </a:extLst>
           </p:cNvPr>
@@ -33086,7 +33086,7 @@
           <p:cNvPr id="28" name="다음 두 장에서 TRIAL-002의 요청 흐름과 행동을 대조한다.">
             <a:extLst xmlns:a="http://schemas.openxmlformats.org/drawingml/2006/main">
               <a:ext uri="{FF2B5EF4-FFF2-40B4-BE49-F238E27FC236}">
-                <a16:creationId xmlns:a16="http://schemas.microsoft.com/office/drawing/2014/main" id="{93AC5D1E-089A-461A-ABA9-5484C84E7C4D}"/>
+                <a16:creationId xmlns:a16="http://schemas.microsoft.com/office/drawing/2014/main" id="{8A34BD7D-C29A-4699-ACD2-79BFF0BAB319}"/>
               </a:ext>
             </a:extLst>
           </p:cNvPr>
@@ -33244,7 +33244,7 @@
           <p:cNvPr id="29" name="Legacy module connection">
             <a:extLst xmlns:a="http://schemas.openxmlformats.org/drawingml/2006/main">
               <a:ext uri="{FF2B5EF4-FFF2-40B4-BE49-F238E27FC236}">
-                <a16:creationId xmlns:a16="http://schemas.microsoft.com/office/drawing/2014/main" id="{E1EA7ED0-3335-49B8-A749-C6DA8AC4679D}"/>
+                <a16:creationId xmlns:a16="http://schemas.microsoft.com/office/drawing/2014/main" id="{E774C154-951E-4B67-847A-73E9EA02C0AC}"/>
               </a:ext>
             </a:extLst>
           </p:cNvPr>
@@ -33400,7 +33400,7 @@
     </p:spTree>
     <p:extLst>
       <p:ext uri="{BB962C8B-B14F-4D97-AF65-F5344CB8AC3E}">
-        <p14:creationId xmlns:p14="http://schemas.microsoft.com/office/powerpoint/2010/main" val="746379290"/>
+        <p14:creationId xmlns:p14="http://schemas.microsoft.com/office/powerpoint/2010/main" val="2103765592"/>
       </p:ext>
     </p:extLst>
   </p:cSld>
@@ -33431,7 +33431,7 @@
           <p:cNvPr id="19" name="ACT 1 · 계약을 보존하는 최소 변경">
             <a:extLst xmlns:a="http://schemas.openxmlformats.org/drawingml/2006/main">
               <a:ext uri="{FF2B5EF4-FFF2-40B4-BE49-F238E27FC236}">
-                <a16:creationId xmlns:a16="http://schemas.microsoft.com/office/drawing/2014/main" id="{15FE112A-2B34-4F76-BC54-A86D64658965}"/>
+                <a16:creationId xmlns:a16="http://schemas.microsoft.com/office/drawing/2014/main" id="{785E0F3D-C134-4910-8C94-3216DF674DE7}"/>
               </a:ext>
             </a:extLst>
           </p:cNvPr>
@@ -33586,10 +33586,10 @@
       </p:sp>
       <p:sp>
         <p:nvSpPr>
-          <p:cNvPr id="2" name="S16">
+          <p:cNvPr id="2" name="S17">
             <a:extLst xmlns:a="http://schemas.openxmlformats.org/drawingml/2006/main">
               <a:ext uri="{FF2B5EF4-FFF2-40B4-BE49-F238E27FC236}">
-                <a16:creationId xmlns:a16="http://schemas.microsoft.com/office/drawing/2014/main" id="{688DFE5C-1431-424C-8CC9-4B0E47EDF1AD}"/>
+                <a16:creationId xmlns:a16="http://schemas.microsoft.com/office/drawing/2014/main" id="{91B2DB6D-D7DB-4A36-8C9A-B8E0478CE9F0}"/>
               </a:ext>
             </a:extLst>
           </p:cNvPr>
@@ -33737,7 +33737,7 @@
                 <a:ea typeface="Malgun Gothic"/>
                 <a:cs typeface="Malgun Gothic"/>
               </a:rPr>
-              <a:t>S16</a:t>
+              <a:t>S17</a:t>
             </a:r>
           </a:p>
         </p:txBody>
@@ -33747,7 +33747,7 @@
           <p:cNvPr id="3" name="조사에서 한 줄 변경까지">
             <a:extLst xmlns:a="http://schemas.openxmlformats.org/drawingml/2006/main">
               <a:ext uri="{FF2B5EF4-FFF2-40B4-BE49-F238E27FC236}">
-                <a16:creationId xmlns:a16="http://schemas.microsoft.com/office/drawing/2014/main" id="{26D00673-D0BA-483B-AB53-F3F80997BE72}"/>
+                <a16:creationId xmlns:a16="http://schemas.microsoft.com/office/drawing/2014/main" id="{1172B301-BC73-4B9C-9647-907B9C7A1D7D}"/>
               </a:ext>
             </a:extLst>
           </p:cNvPr>
@@ -33905,7 +33905,7 @@
           <p:cNvPr id="4" name="">
             <a:extLst xmlns:a="http://schemas.openxmlformats.org/drawingml/2006/main">
               <a:ext uri="{FF2B5EF4-FFF2-40B4-BE49-F238E27FC236}">
-                <a16:creationId xmlns:a16="http://schemas.microsoft.com/office/drawing/2014/main" id="{68A55FB6-6EC7-41BA-8316-E854240B6B42}"/>
+                <a16:creationId xmlns:a16="http://schemas.microsoft.com/office/drawing/2014/main" id="{9E6BAC91-11D4-48FB-AB89-1BC01FBA175A}"/>
               </a:ext>
             </a:extLst>
           </p:cNvPr>
@@ -33936,7 +33936,7 @@
           <p:cNvPr id="5" name="TRIAL-002 · STATE-00 → STATE-00-FIXED · 실제 diff를 재구성한 도식">
             <a:extLst xmlns:a="http://schemas.openxmlformats.org/drawingml/2006/main">
               <a:ext uri="{FF2B5EF4-FFF2-40B4-BE49-F238E27FC236}">
-                <a16:creationId xmlns:a16="http://schemas.microsoft.com/office/drawing/2014/main" id="{80BDB7EF-D74A-48D7-9B3D-49BDB6876B68}"/>
+                <a16:creationId xmlns:a16="http://schemas.microsoft.com/office/drawing/2014/main" id="{635BE1CB-23FA-45F7-8782-4D5474C05AC5}"/>
               </a:ext>
             </a:extLst>
           </p:cNvPr>
@@ -34094,7 +34094,7 @@
           <p:cNvPr id="6" name="src/graypipe/transform.py · 단일 CLI 기록 · 실제 터미널 화면이 아님">
             <a:extLst xmlns:a="http://schemas.openxmlformats.org/drawingml/2006/main">
               <a:ext uri="{FF2B5EF4-FFF2-40B4-BE49-F238E27FC236}">
-                <a16:creationId xmlns:a16="http://schemas.microsoft.com/office/drawing/2014/main" id="{EA8DDB52-0448-4F2D-B96D-76158F21FB2E}"/>
+                <a16:creationId xmlns:a16="http://schemas.microsoft.com/office/drawing/2014/main" id="{39ADB497-9C88-4994-990A-760BC380DF21}"/>
               </a:ext>
             </a:extLst>
           </p:cNvPr>
@@ -34252,7 +34252,7 @@
           <p:cNvPr id="7" name="실패 테스트 → 호출 경로 → 계약 확인 → 수정 전 계획">
             <a:extLst xmlns:a="http://schemas.openxmlformats.org/drawingml/2006/main">
               <a:ext uri="{FF2B5EF4-FFF2-40B4-BE49-F238E27FC236}">
-                <a16:creationId xmlns:a16="http://schemas.microsoft.com/office/drawing/2014/main" id="{79CB0E98-8B3E-4FBD-9E4E-57B9F5BB1E8B}"/>
+                <a16:creationId xmlns:a16="http://schemas.microsoft.com/office/drawing/2014/main" id="{EBD35E40-DA6F-4D03-B47E-F5B12E1996E7}"/>
               </a:ext>
             </a:extLst>
           </p:cNvPr>
@@ -34410,7 +34410,7 @@
           <p:cNvPr id="8" name="끝 좌표를 제외한다: [x_start, x_end)">
             <a:extLst xmlns:a="http://schemas.openxmlformats.org/drawingml/2006/main">
               <a:ext uri="{FF2B5EF4-FFF2-40B4-BE49-F238E27FC236}">
-                <a16:creationId xmlns:a16="http://schemas.microsoft.com/office/drawing/2014/main" id="{F917CDBF-8188-4EA7-A90E-2DF16A80312A}"/>
+                <a16:creationId xmlns:a16="http://schemas.microsoft.com/office/drawing/2014/main" id="{49F1697C-E4F5-4F96-8BCD-B4F3C796D08E}"/>
               </a:ext>
             </a:extLst>
           </p:cNvPr>
@@ -34568,7 +34568,7 @@
           <p:cNvPr id="9" name="">
             <a:extLst xmlns:a="http://schemas.openxmlformats.org/drawingml/2006/main">
               <a:ext uri="{FF2B5EF4-FFF2-40B4-BE49-F238E27FC236}">
-                <a16:creationId xmlns:a16="http://schemas.microsoft.com/office/drawing/2014/main" id="{EB28727D-71EF-4F15-838D-BBED83415952}"/>
+                <a16:creationId xmlns:a16="http://schemas.microsoft.com/office/drawing/2014/main" id="{D39AF9E5-55A7-473E-9DD3-1BC1DB09D9F3}"/>
               </a:ext>
             </a:extLst>
           </p:cNvPr>
@@ -34599,7 +34599,7 @@
           <p:cNvPr id="10" name="">
             <a:extLst xmlns:a="http://schemas.openxmlformats.org/drawingml/2006/main">
               <a:ext uri="{FF2B5EF4-FFF2-40B4-BE49-F238E27FC236}">
-                <a16:creationId xmlns:a16="http://schemas.microsoft.com/office/drawing/2014/main" id="{9EB8624D-A537-4E03-AEA1-925B5FA5E0AE}"/>
+                <a16:creationId xmlns:a16="http://schemas.microsoft.com/office/drawing/2014/main" id="{25C50410-0E26-4241-B03C-232C14D26CAF}"/>
               </a:ext>
             </a:extLst>
           </p:cNvPr>
@@ -34630,7 +34630,7 @@
           <p:cNvPr id="11" name="변경 전">
             <a:extLst xmlns:a="http://schemas.openxmlformats.org/drawingml/2006/main">
               <a:ext uri="{FF2B5EF4-FFF2-40B4-BE49-F238E27FC236}">
-                <a16:creationId xmlns:a16="http://schemas.microsoft.com/office/drawing/2014/main" id="{2D7F43B8-685B-4E37-A585-0CE96A2A4987}"/>
+                <a16:creationId xmlns:a16="http://schemas.microsoft.com/office/drawing/2014/main" id="{881D9572-5B23-4ABD-895B-4BB39C37CE0E}"/>
               </a:ext>
             </a:extLst>
           </p:cNvPr>
@@ -34788,7 +34788,7 @@
           <p:cNvPr id="12" name="변경 후">
             <a:extLst xmlns:a="http://schemas.openxmlformats.org/drawingml/2006/main">
               <a:ext uri="{FF2B5EF4-FFF2-40B4-BE49-F238E27FC236}">
-                <a16:creationId xmlns:a16="http://schemas.microsoft.com/office/drawing/2014/main" id="{3084EAC0-C1A1-43C1-B6D9-63DB3BEBBE7A}"/>
+                <a16:creationId xmlns:a16="http://schemas.microsoft.com/office/drawing/2014/main" id="{FC6E42D4-AC63-4045-9419-1C068534E76C}"/>
               </a:ext>
             </a:extLst>
           </p:cNvPr>
@@ -34946,7 +34946,7 @@
           <p:cNvPr id="13" name="row[x_start : x_end + 1]">
             <a:extLst xmlns:a="http://schemas.openxmlformats.org/drawingml/2006/main">
               <a:ext uri="{FF2B5EF4-FFF2-40B4-BE49-F238E27FC236}">
-                <a16:creationId xmlns:a16="http://schemas.microsoft.com/office/drawing/2014/main" id="{AE24046B-BFFD-4C0B-B33E-C1EA31692CB0}"/>
+                <a16:creationId xmlns:a16="http://schemas.microsoft.com/office/drawing/2014/main" id="{D9F46B83-8B35-4ED4-836F-C5CBD20132EB}"/>
               </a:ext>
             </a:extLst>
           </p:cNvPr>
@@ -35104,7 +35104,7 @@
           <p:cNvPr id="14" name="row[x_start : x_end]">
             <a:extLst xmlns:a="http://schemas.openxmlformats.org/drawingml/2006/main">
               <a:ext uri="{FF2B5EF4-FFF2-40B4-BE49-F238E27FC236}">
-                <a16:creationId xmlns:a16="http://schemas.microsoft.com/office/drawing/2014/main" id="{01D7B6DB-384F-4E15-AE8B-E8B7EC6B172B}"/>
+                <a16:creationId xmlns:a16="http://schemas.microsoft.com/office/drawing/2014/main" id="{3A0473DE-9ABE-4023-9F7F-6A822A826B22}"/>
               </a:ext>
             </a:extLst>
           </p:cNvPr>
@@ -35262,7 +35262,7 @@
           <p:cNvPr id="15" name="">
             <a:extLst xmlns:a="http://schemas.openxmlformats.org/drawingml/2006/main">
               <a:ext uri="{FF2B5EF4-FFF2-40B4-BE49-F238E27FC236}">
-                <a16:creationId xmlns:a16="http://schemas.microsoft.com/office/drawing/2014/main" id="{006A2F6C-F156-40EE-9082-EA5D5E4425EE}"/>
+                <a16:creationId xmlns:a16="http://schemas.microsoft.com/office/drawing/2014/main" id="{45B1A508-6591-4714-B01D-5AA9E2FD1B95}"/>
               </a:ext>
             </a:extLst>
           </p:cNvPr>
@@ -35292,7 +35292,7 @@
           <p:cNvPr id="16" name="crop(image, 1, 3)">
             <a:extLst xmlns:a="http://schemas.openxmlformats.org/drawingml/2006/main">
               <a:ext uri="{FF2B5EF4-FFF2-40B4-BE49-F238E27FC236}">
-                <a16:creationId xmlns:a16="http://schemas.microsoft.com/office/drawing/2014/main" id="{D99D9605-FA79-4738-99EC-0F45668417FA}"/>
+                <a16:creationId xmlns:a16="http://schemas.microsoft.com/office/drawing/2014/main" id="{432F50DF-0308-4B11-83DD-5B2A1EE39022}"/>
               </a:ext>
             </a:extLst>
           </p:cNvPr>
@@ -35450,7 +35450,7 @@
           <p:cNvPr id="17" name="너비 3 → 계약대로 너비 2">
             <a:extLst xmlns:a="http://schemas.openxmlformats.org/drawingml/2006/main">
               <a:ext uri="{FF2B5EF4-FFF2-40B4-BE49-F238E27FC236}">
-                <a16:creationId xmlns:a16="http://schemas.microsoft.com/office/drawing/2014/main" id="{893EFAC4-3A19-4BEA-A96C-C4A779705DBE}"/>
+                <a16:creationId xmlns:a16="http://schemas.microsoft.com/office/drawing/2014/main" id="{FEF67157-E115-4FC2-96BC-9F238F95CE52}"/>
               </a:ext>
             </a:extLst>
           </p:cNvPr>
@@ -35608,7 +35608,7 @@
           <p:cNvPr id="18" name="Legacy module connection">
             <a:extLst xmlns:a="http://schemas.openxmlformats.org/drawingml/2006/main">
               <a:ext uri="{FF2B5EF4-FFF2-40B4-BE49-F238E27FC236}">
-                <a16:creationId xmlns:a16="http://schemas.microsoft.com/office/drawing/2014/main" id="{A88A78FA-68B7-4E27-8380-B42CCCF8C35A}"/>
+                <a16:creationId xmlns:a16="http://schemas.microsoft.com/office/drawing/2014/main" id="{47474D91-A2D4-4DA9-B909-9745E48C5ACB}"/>
               </a:ext>
             </a:extLst>
           </p:cNvPr>
@@ -35764,7 +35764,7 @@
     </p:spTree>
     <p:extLst>
       <p:ext uri="{BB962C8B-B14F-4D97-AF65-F5344CB8AC3E}">
-        <p14:creationId xmlns:p14="http://schemas.microsoft.com/office/powerpoint/2010/main" val="121237837"/>
+        <p14:creationId xmlns:p14="http://schemas.microsoft.com/office/powerpoint/2010/main" val="1619466929"/>
       </p:ext>
     </p:extLst>
   </p:cSld>
@@ -35795,7 +35795,7 @@
           <p:cNvPr id="23" name="ACT 1 · 수정 뒤 확인한 것">
             <a:extLst xmlns:a="http://schemas.openxmlformats.org/drawingml/2006/main">
               <a:ext uri="{FF2B5EF4-FFF2-40B4-BE49-F238E27FC236}">
-                <a16:creationId xmlns:a16="http://schemas.microsoft.com/office/drawing/2014/main" id="{791FC188-10C8-4B9F-91DF-6C2F7E35294F}"/>
+                <a16:creationId xmlns:a16="http://schemas.microsoft.com/office/drawing/2014/main" id="{5D851F56-7426-45C1-A290-57DC8FA4B8E6}"/>
               </a:ext>
             </a:extLst>
           </p:cNvPr>
@@ -35950,10 +35950,10 @@
       </p:sp>
       <p:sp>
         <p:nvSpPr>
-          <p:cNvPr id="2" name="S17">
+          <p:cNvPr id="2" name="S18">
             <a:extLst xmlns:a="http://schemas.openxmlformats.org/drawingml/2006/main">
               <a:ext uri="{FF2B5EF4-FFF2-40B4-BE49-F238E27FC236}">
-                <a16:creationId xmlns:a16="http://schemas.microsoft.com/office/drawing/2014/main" id="{39D01D7E-DA50-42FD-94E7-E080720C888D}"/>
+                <a16:creationId xmlns:a16="http://schemas.microsoft.com/office/drawing/2014/main" id="{6A9B263C-6D16-4E1F-AA26-296CF6B8D7AD}"/>
               </a:ext>
             </a:extLst>
           </p:cNvPr>
@@ -36101,7 +36101,7 @@
                 <a:ea typeface="Malgun Gothic"/>
                 <a:cs typeface="Malgun Gothic"/>
               </a:rPr>
-              <a:t>S17</a:t>
+              <a:t>S18</a:t>
             </a:r>
           </a:p>
         </p:txBody>
@@ -36111,7 +36111,7 @@
           <p:cNvPr id="3" name="변경 결과와 확인 증거">
             <a:extLst xmlns:a="http://schemas.openxmlformats.org/drawingml/2006/main">
               <a:ext uri="{FF2B5EF4-FFF2-40B4-BE49-F238E27FC236}">
-                <a16:creationId xmlns:a16="http://schemas.microsoft.com/office/drawing/2014/main" id="{A1E11715-2930-409E-A8F5-8AD351BB9871}"/>
+                <a16:creationId xmlns:a16="http://schemas.microsoft.com/office/drawing/2014/main" id="{8F1A3FB6-26CC-4DFA-8512-70286271295C}"/>
               </a:ext>
             </a:extLst>
           </p:cNvPr>
@@ -36269,7 +36269,7 @@
           <p:cNvPr id="4" name="">
             <a:extLst xmlns:a="http://schemas.openxmlformats.org/drawingml/2006/main">
               <a:ext uri="{FF2B5EF4-FFF2-40B4-BE49-F238E27FC236}">
-                <a16:creationId xmlns:a16="http://schemas.microsoft.com/office/drawing/2014/main" id="{CA1820D2-EA89-4DA1-A7FB-7ABF5E018F52}"/>
+                <a16:creationId xmlns:a16="http://schemas.microsoft.com/office/drawing/2014/main" id="{7AB06DA3-BDD9-4EC0-899A-A8E5D3C5983F}"/>
               </a:ext>
             </a:extLst>
           </p:cNvPr>
@@ -36300,7 +36300,7 @@
           <p:cNvPr id="5" name="TRIAL-002 기록 요약 · 단일 Codex CLI 실행 · STATE-00-FIXED">
             <a:extLst xmlns:a="http://schemas.openxmlformats.org/drawingml/2006/main">
               <a:ext uri="{FF2B5EF4-FFF2-40B4-BE49-F238E27FC236}">
-                <a16:creationId xmlns:a16="http://schemas.microsoft.com/office/drawing/2014/main" id="{E2CFAFAF-B70F-49B6-A562-6B7126AA91EA}"/>
+                <a16:creationId xmlns:a16="http://schemas.microsoft.com/office/drawing/2014/main" id="{280BFB05-B6E4-424D-9C99-BA37201879CB}"/>
               </a:ext>
             </a:extLst>
           </p:cNvPr>
@@ -36458,7 +36458,7 @@
           <p:cNvPr id="6" name="해당 테스트·입력·수정 범위의 확인입니다. 성능 benchmark는 수행하지 않았습니다.">
             <a:extLst xmlns:a="http://schemas.openxmlformats.org/drawingml/2006/main">
               <a:ext uri="{FF2B5EF4-FFF2-40B4-BE49-F238E27FC236}">
-                <a16:creationId xmlns:a16="http://schemas.microsoft.com/office/drawing/2014/main" id="{3D1D174D-F264-4D53-B896-445F9EC78B9C}"/>
+                <a16:creationId xmlns:a16="http://schemas.microsoft.com/office/drawing/2014/main" id="{BBA734FA-8BAB-4FBA-B152-62A5BE145DAE}"/>
               </a:ext>
             </a:extLst>
           </p:cNvPr>
@@ -36616,7 +36616,7 @@
           <p:cNvPr id="7" name="동작 확인">
             <a:extLst xmlns:a="http://schemas.openxmlformats.org/drawingml/2006/main">
               <a:ext uri="{FF2B5EF4-FFF2-40B4-BE49-F238E27FC236}">
-                <a16:creationId xmlns:a16="http://schemas.microsoft.com/office/drawing/2014/main" id="{E1B5DD06-480E-4CBD-8F2C-88297A9459D8}"/>
+                <a16:creationId xmlns:a16="http://schemas.microsoft.com/office/drawing/2014/main" id="{DADDCFD6-D3D6-41D5-8F4F-872DDDDD220D}"/>
               </a:ext>
             </a:extLst>
           </p:cNvPr>
@@ -36774,7 +36774,7 @@
           <p:cNvPr id="8" name="">
             <a:extLst xmlns:a="http://schemas.openxmlformats.org/drawingml/2006/main">
               <a:ext uri="{FF2B5EF4-FFF2-40B4-BE49-F238E27FC236}">
-                <a16:creationId xmlns:a16="http://schemas.microsoft.com/office/drawing/2014/main" id="{52430510-533A-48A4-A940-67737AA1CD19}"/>
+                <a16:creationId xmlns:a16="http://schemas.microsoft.com/office/drawing/2014/main" id="{E3E1C8E2-580F-4008-8644-5BAD8C7C8055}"/>
               </a:ext>
             </a:extLst>
           </p:cNvPr>
@@ -36805,7 +36805,7 @@
           <p:cNvPr id="9" name="3 / 3">
             <a:extLst xmlns:a="http://schemas.openxmlformats.org/drawingml/2006/main">
               <a:ext uri="{FF2B5EF4-FFF2-40B4-BE49-F238E27FC236}">
-                <a16:creationId xmlns:a16="http://schemas.microsoft.com/office/drawing/2014/main" id="{C9B64DF8-515A-41A0-BFA3-564872C6C15E}"/>
+                <a16:creationId xmlns:a16="http://schemas.microsoft.com/office/drawing/2014/main" id="{A00DF8A5-6FC2-4427-80A8-2B22EED83DCD}"/>
               </a:ext>
             </a:extLst>
           </p:cNvPr>
@@ -36963,7 +36963,7 @@
           <p:cNvPr id="10" name="crop 집중 테스트">
             <a:extLst xmlns:a="http://schemas.openxmlformats.org/drawingml/2006/main">
               <a:ext uri="{FF2B5EF4-FFF2-40B4-BE49-F238E27FC236}">
-                <a16:creationId xmlns:a16="http://schemas.microsoft.com/office/drawing/2014/main" id="{59102FF0-68A5-4AC7-B05A-724D8371E6F4}"/>
+                <a16:creationId xmlns:a16="http://schemas.microsoft.com/office/drawing/2014/main" id="{D5B5CCF5-C722-4334-9A6C-FA371D11AD6D}"/>
               </a:ext>
             </a:extLst>
           </p:cNvPr>
@@ -37121,7 +37121,7 @@
           <p:cNvPr id="11" name="전체 suite 11 / 11 통과">
             <a:extLst xmlns:a="http://schemas.openxmlformats.org/drawingml/2006/main">
               <a:ext uri="{FF2B5EF4-FFF2-40B4-BE49-F238E27FC236}">
-                <a16:creationId xmlns:a16="http://schemas.microsoft.com/office/drawing/2014/main" id="{91384B39-D09E-42F6-B0BD-4ADFC81410D6}"/>
+                <a16:creationId xmlns:a16="http://schemas.microsoft.com/office/drawing/2014/main" id="{53657A36-CF40-4A2C-A77A-818BD91282D8}"/>
               </a:ext>
             </a:extLst>
           </p:cNvPr>
@@ -37279,7 +37279,7 @@
           <p:cNvPr id="12" name="실행 확인">
             <a:extLst xmlns:a="http://schemas.openxmlformats.org/drawingml/2006/main">
               <a:ext uri="{FF2B5EF4-FFF2-40B4-BE49-F238E27FC236}">
-                <a16:creationId xmlns:a16="http://schemas.microsoft.com/office/drawing/2014/main" id="{F2C02E7D-06B1-4321-8318-BBB9CD7CCFA4}"/>
+                <a16:creationId xmlns:a16="http://schemas.microsoft.com/office/drawing/2014/main" id="{FCBAEBA5-9DA8-4840-881A-E028C220FF4F}"/>
               </a:ext>
             </a:extLst>
           </p:cNvPr>
@@ -37437,7 +37437,7 @@
           <p:cNvPr id="13" name="">
             <a:extLst xmlns:a="http://schemas.openxmlformats.org/drawingml/2006/main">
               <a:ext uri="{FF2B5EF4-FFF2-40B4-BE49-F238E27FC236}">
-                <a16:creationId xmlns:a16="http://schemas.microsoft.com/office/drawing/2014/main" id="{DB070A8A-480D-4AC1-935B-C32F1AA30B16}"/>
+                <a16:creationId xmlns:a16="http://schemas.microsoft.com/office/drawing/2014/main" id="{8698C227-9EA3-4344-9A48-70D7311EF29E}"/>
               </a:ext>
             </a:extLst>
           </p:cNvPr>
@@ -37468,7 +37468,7 @@
           <p:cNvPr id="14" name="PASS">
             <a:extLst xmlns:a="http://schemas.openxmlformats.org/drawingml/2006/main">
               <a:ext uri="{FF2B5EF4-FFF2-40B4-BE49-F238E27FC236}">
-                <a16:creationId xmlns:a16="http://schemas.microsoft.com/office/drawing/2014/main" id="{7C6BAFFE-5AD0-42E0-9E39-1BE3CCBA6C09}"/>
+                <a16:creationId xmlns:a16="http://schemas.microsoft.com/office/drawing/2014/main" id="{D5DB3BDB-28BA-4CE5-ADF6-998C6442B581}"/>
               </a:ext>
             </a:extLst>
           </p:cNvPr>
@@ -37626,7 +37626,7 @@
           <p:cNvPr id="15" name="CLI smoke">
             <a:extLst xmlns:a="http://schemas.openxmlformats.org/drawingml/2006/main">
               <a:ext uri="{FF2B5EF4-FFF2-40B4-BE49-F238E27FC236}">
-                <a16:creationId xmlns:a16="http://schemas.microsoft.com/office/drawing/2014/main" id="{BC5BD038-3C26-4EA7-AFD0-69B77512152E}"/>
+                <a16:creationId xmlns:a16="http://schemas.microsoft.com/office/drawing/2014/main" id="{B07B295A-FDD5-4C2F-BF3D-73D9F667D812}"/>
               </a:ext>
             </a:extLst>
           </p:cNvPr>
@@ -37784,7 +37784,7 @@
           <p:cNvPr id="16" name="기록된 샘플의 실행 경로">
             <a:extLst xmlns:a="http://schemas.openxmlformats.org/drawingml/2006/main">
               <a:ext uri="{FF2B5EF4-FFF2-40B4-BE49-F238E27FC236}">
-                <a16:creationId xmlns:a16="http://schemas.microsoft.com/office/drawing/2014/main" id="{BF043013-08BB-4DCA-8383-3E8AE9075A23}"/>
+                <a16:creationId xmlns:a16="http://schemas.microsoft.com/office/drawing/2014/main" id="{6890630E-E6C9-42BE-9325-66D50FB6604D}"/>
               </a:ext>
             </a:extLst>
           </p:cNvPr>
@@ -37942,7 +37942,7 @@
           <p:cNvPr id="17" name="범위 확인">
             <a:extLst xmlns:a="http://schemas.openxmlformats.org/drawingml/2006/main">
               <a:ext uri="{FF2B5EF4-FFF2-40B4-BE49-F238E27FC236}">
-                <a16:creationId xmlns:a16="http://schemas.microsoft.com/office/drawing/2014/main" id="{8633A255-5A40-4C87-A19C-FD9232E5ADDF}"/>
+                <a16:creationId xmlns:a16="http://schemas.microsoft.com/office/drawing/2014/main" id="{DA4E4DD6-2633-47B0-92CE-484BD0648A67}"/>
               </a:ext>
             </a:extLst>
           </p:cNvPr>
@@ -38100,7 +38100,7 @@
           <p:cNvPr id="18" name="">
             <a:extLst xmlns:a="http://schemas.openxmlformats.org/drawingml/2006/main">
               <a:ext uri="{FF2B5EF4-FFF2-40B4-BE49-F238E27FC236}">
-                <a16:creationId xmlns:a16="http://schemas.microsoft.com/office/drawing/2014/main" id="{3AF68CB9-495E-4611-AD13-4902807515A0}"/>
+                <a16:creationId xmlns:a16="http://schemas.microsoft.com/office/drawing/2014/main" id="{3AEE95F8-A8DE-4B87-9229-072DE53D0F5A}"/>
               </a:ext>
             </a:extLst>
           </p:cNvPr>
@@ -38131,7 +38131,7 @@
           <p:cNvPr id="19" name="1줄">
             <a:extLst xmlns:a="http://schemas.openxmlformats.org/drawingml/2006/main">
               <a:ext uri="{FF2B5EF4-FFF2-40B4-BE49-F238E27FC236}">
-                <a16:creationId xmlns:a16="http://schemas.microsoft.com/office/drawing/2014/main" id="{E56B50BC-8F86-41D5-AF66-3C4C25B08BA2}"/>
+                <a16:creationId xmlns:a16="http://schemas.microsoft.com/office/drawing/2014/main" id="{5E3F6B2C-8CBD-4258-ABDE-886E2048872E}"/>
               </a:ext>
             </a:extLst>
           </p:cNvPr>
@@ -38289,7 +38289,7 @@
           <p:cNvPr id="20" name="한 파일의 crop 구현">
             <a:extLst xmlns:a="http://schemas.openxmlformats.org/drawingml/2006/main">
               <a:ext uri="{FF2B5EF4-FFF2-40B4-BE49-F238E27FC236}">
-                <a16:creationId xmlns:a16="http://schemas.microsoft.com/office/drawing/2014/main" id="{ED3FD9C5-5F49-4B21-9C6C-7ECA43D48F15}"/>
+                <a16:creationId xmlns:a16="http://schemas.microsoft.com/office/drawing/2014/main" id="{0E383801-E3EE-4939-9618-09B586898802}"/>
               </a:ext>
             </a:extLst>
           </p:cNvPr>
@@ -38447,7 +38447,7 @@
           <p:cNvPr id="21" name="git diff --check 통과">
             <a:extLst xmlns:a="http://schemas.openxmlformats.org/drawingml/2006/main">
               <a:ext uri="{FF2B5EF4-FFF2-40B4-BE49-F238E27FC236}">
-                <a16:creationId xmlns:a16="http://schemas.microsoft.com/office/drawing/2014/main" id="{5A0BD5F2-8147-49B7-AA63-700582D9D54B}"/>
+                <a16:creationId xmlns:a16="http://schemas.microsoft.com/office/drawing/2014/main" id="{91DDB1C8-81E1-4C91-8813-7D266EE6D8A3}"/>
               </a:ext>
             </a:extLst>
           </p:cNvPr>
@@ -38605,7 +38605,7 @@
           <p:cNvPr id="22" name="Legacy module connection">
             <a:extLst xmlns:a="http://schemas.openxmlformats.org/drawingml/2006/main">
               <a:ext uri="{FF2B5EF4-FFF2-40B4-BE49-F238E27FC236}">
-                <a16:creationId xmlns:a16="http://schemas.microsoft.com/office/drawing/2014/main" id="{7D1B973A-B7C6-455F-8D9C-B142249C9EA2}"/>
+                <a16:creationId xmlns:a16="http://schemas.microsoft.com/office/drawing/2014/main" id="{8C4EA1D2-F5C3-44A0-94F4-E91EF04F1D6A}"/>
               </a:ext>
             </a:extLst>
           </p:cNvPr>
@@ -38761,7 +38761,7 @@
     </p:spTree>
     <p:extLst>
       <p:ext uri="{BB962C8B-B14F-4D97-AF65-F5344CB8AC3E}">
-        <p14:creationId xmlns:p14="http://schemas.microsoft.com/office/powerpoint/2010/main" val="991477280"/>
+        <p14:creationId xmlns:p14="http://schemas.microsoft.com/office/powerpoint/2010/main" val="552811129"/>
       </p:ext>
     </p:extLst>
   </p:cSld>
@@ -38792,7 +38792,7 @@
           <p:cNvPr id="24" name="ACT 1 · 생성 뒤에 남는 판단">
             <a:extLst xmlns:a="http://schemas.openxmlformats.org/drawingml/2006/main">
               <a:ext uri="{FF2B5EF4-FFF2-40B4-BE49-F238E27FC236}">
-                <a16:creationId xmlns:a16="http://schemas.microsoft.com/office/drawing/2014/main" id="{BC421CE6-42EC-4140-BBAE-02CFA4F6A65C}"/>
+                <a16:creationId xmlns:a16="http://schemas.microsoft.com/office/drawing/2014/main" id="{F8F38D1E-8BB5-4DE0-9945-3DDA93C65DC2}"/>
               </a:ext>
             </a:extLst>
           </p:cNvPr>
@@ -38947,10 +38947,10 @@
       </p:sp>
       <p:sp>
         <p:nvSpPr>
-          <p:cNvPr id="2" name="S18">
+          <p:cNvPr id="2" name="S19">
             <a:extLst xmlns:a="http://schemas.openxmlformats.org/drawingml/2006/main">
               <a:ext uri="{FF2B5EF4-FFF2-40B4-BE49-F238E27FC236}">
-                <a16:creationId xmlns:a16="http://schemas.microsoft.com/office/drawing/2014/main" id="{AE3113EA-4E84-460F-82A7-8DE3F7A4ADB8}"/>
+                <a16:creationId xmlns:a16="http://schemas.microsoft.com/office/drawing/2014/main" id="{9FD64CAB-A51D-4763-B198-A5CE610A516E}"/>
               </a:ext>
             </a:extLst>
           </p:cNvPr>
@@ -39098,7 +39098,7 @@
                 <a:ea typeface="Malgun Gothic"/>
                 <a:cs typeface="Malgun Gothic"/>
               </a:rPr>
-              <a:t>S18</a:t>
+              <a:t>S19</a:t>
             </a:r>
           </a:p>
         </p:txBody>
@@ -39108,7 +39108,7 @@
           <p:cNvPr id="3" name="Generated ≠ Done">
             <a:extLst xmlns:a="http://schemas.openxmlformats.org/drawingml/2006/main">
               <a:ext uri="{FF2B5EF4-FFF2-40B4-BE49-F238E27FC236}">
-                <a16:creationId xmlns:a16="http://schemas.microsoft.com/office/drawing/2014/main" id="{C6D4740D-DD3E-4CA6-81B1-A36FD73C2B62}"/>
+                <a16:creationId xmlns:a16="http://schemas.microsoft.com/office/drawing/2014/main" id="{D2A4B257-32ED-4C4B-AC02-0B61623FE6E9}"/>
               </a:ext>
             </a:extLst>
           </p:cNvPr>
@@ -39266,7 +39266,7 @@
           <p:cNvPr id="4" name="">
             <a:extLst xmlns:a="http://schemas.openxmlformats.org/drawingml/2006/main">
               <a:ext uri="{FF2B5EF4-FFF2-40B4-BE49-F238E27FC236}">
-                <a16:creationId xmlns:a16="http://schemas.microsoft.com/office/drawing/2014/main" id="{C472FA90-4CE3-4608-9C73-FDB67AEF11F5}"/>
+                <a16:creationId xmlns:a16="http://schemas.microsoft.com/office/drawing/2014/main" id="{60E94F0A-9DBC-4B9F-9F5B-386EACDDA0B0}"/>
               </a:ext>
             </a:extLst>
           </p:cNvPr>
@@ -39297,7 +39297,7 @@
           <p:cNvPr id="5" name="교육용 결과 인계 예 · TRIAL-002 기록 재구성 · 실제 PR 원문이 아님">
             <a:extLst xmlns:a="http://schemas.openxmlformats.org/drawingml/2006/main">
               <a:ext uri="{FF2B5EF4-FFF2-40B4-BE49-F238E27FC236}">
-                <a16:creationId xmlns:a16="http://schemas.microsoft.com/office/drawing/2014/main" id="{5E24623B-8D16-45CF-BEB2-477E0C774A6B}"/>
+                <a16:creationId xmlns:a16="http://schemas.microsoft.com/office/drawing/2014/main" id="{89EB9121-29B8-44F4-8A41-4CDE0BEBBD5A}"/>
               </a:ext>
             </a:extLst>
           </p:cNvPr>
@@ -39455,7 +39455,7 @@
           <p:cNvPr id="6" name="검사는 주장과 위험에 맞춰 선택합니다. TRIAL-002에서 benchmark는 수행하지 않았습니다.">
             <a:extLst xmlns:a="http://schemas.openxmlformats.org/drawingml/2006/main">
               <a:ext uri="{FF2B5EF4-FFF2-40B4-BE49-F238E27FC236}">
-                <a16:creationId xmlns:a16="http://schemas.microsoft.com/office/drawing/2014/main" id="{B70BB207-DBF1-4B88-A3FF-8127E3498CE5}"/>
+                <a16:creationId xmlns:a16="http://schemas.microsoft.com/office/drawing/2014/main" id="{70F806BC-A173-40D5-8E7C-353B6F5ED14B}"/>
               </a:ext>
             </a:extLst>
           </p:cNvPr>
@@ -39613,7 +39613,7 @@
           <p:cNvPr id="7" name="코드가 나왔다">
             <a:extLst xmlns:a="http://schemas.openxmlformats.org/drawingml/2006/main">
               <a:ext uri="{FF2B5EF4-FFF2-40B4-BE49-F238E27FC236}">
-                <a16:creationId xmlns:a16="http://schemas.microsoft.com/office/drawing/2014/main" id="{85974AC3-3829-4338-BE6C-E2C196B347E1}"/>
+                <a16:creationId xmlns:a16="http://schemas.microsoft.com/office/drawing/2014/main" id="{7A654BED-3FDB-45F6-B434-FA253619E015}"/>
               </a:ext>
             </a:extLst>
           </p:cNvPr>
@@ -39771,7 +39771,7 @@
           <p:cNvPr id="8" name="">
             <a:extLst xmlns:a="http://schemas.openxmlformats.org/drawingml/2006/main">
               <a:ext uri="{FF2B5EF4-FFF2-40B4-BE49-F238E27FC236}">
-                <a16:creationId xmlns:a16="http://schemas.microsoft.com/office/drawing/2014/main" id="{1E931898-51E6-4406-96FF-0AE9CCDFCA49}"/>
+                <a16:creationId xmlns:a16="http://schemas.microsoft.com/office/drawing/2014/main" id="{46CFC3B3-65A6-45F7-BA3D-B9099C092427}"/>
               </a:ext>
             </a:extLst>
           </p:cNvPr>
@@ -39801,7 +39801,7 @@
           <p:cNvPr id="9" name="완료라고 말할 수 있나?">
             <a:extLst xmlns:a="http://schemas.openxmlformats.org/drawingml/2006/main">
               <a:ext uri="{FF2B5EF4-FFF2-40B4-BE49-F238E27FC236}">
-                <a16:creationId xmlns:a16="http://schemas.microsoft.com/office/drawing/2014/main" id="{3E0059D9-7E2C-46E1-9532-5EE6DA52E222}"/>
+                <a16:creationId xmlns:a16="http://schemas.microsoft.com/office/drawing/2014/main" id="{7E7A502C-5511-437C-BF5B-E2E4CAC1673C}"/>
               </a:ext>
             </a:extLst>
           </p:cNvPr>
@@ -39959,7 +39959,7 @@
           <p:cNvPr id="10" name="">
             <a:extLst xmlns:a="http://schemas.openxmlformats.org/drawingml/2006/main">
               <a:ext uri="{FF2B5EF4-FFF2-40B4-BE49-F238E27FC236}">
-                <a16:creationId xmlns:a16="http://schemas.microsoft.com/office/drawing/2014/main" id="{394B9522-B6CC-42E1-A318-0DA4BFDF9BA2}"/>
+                <a16:creationId xmlns:a16="http://schemas.microsoft.com/office/drawing/2014/main" id="{C20CC24F-49B0-452E-B06A-C566FCE82A10}"/>
               </a:ext>
             </a:extLst>
           </p:cNvPr>
@@ -39990,7 +39990,7 @@
           <p:cNvPr id="11" name="변경 이유·범위">
             <a:extLst xmlns:a="http://schemas.openxmlformats.org/drawingml/2006/main">
               <a:ext uri="{FF2B5EF4-FFF2-40B4-BE49-F238E27FC236}">
-                <a16:creationId xmlns:a16="http://schemas.microsoft.com/office/drawing/2014/main" id="{9E8708BA-AFC4-48B2-8A04-4CB438B82CF6}"/>
+                <a16:creationId xmlns:a16="http://schemas.microsoft.com/office/drawing/2014/main" id="{9EB0C048-4FF5-4DAB-A4BA-2E6E1BF208FA}"/>
               </a:ext>
             </a:extLst>
           </p:cNvPr>
@@ -40148,7 +40148,7 @@
           <p:cNvPr id="12" name="끝 좌표 계약에 맞춰 crop 구현 1줄 수정">
             <a:extLst xmlns:a="http://schemas.openxmlformats.org/drawingml/2006/main">
               <a:ext uri="{FF2B5EF4-FFF2-40B4-BE49-F238E27FC236}">
-                <a16:creationId xmlns:a16="http://schemas.microsoft.com/office/drawing/2014/main" id="{999EB37B-8E99-4AB8-A900-D875314200C2}"/>
+                <a16:creationId xmlns:a16="http://schemas.microsoft.com/office/drawing/2014/main" id="{905E3587-5ECD-4C27-9480-3DD51AF31D19}"/>
               </a:ext>
             </a:extLst>
           </p:cNvPr>
@@ -40306,7 +40306,7 @@
           <p:cNvPr id="13" name="">
             <a:extLst xmlns:a="http://schemas.openxmlformats.org/drawingml/2006/main">
               <a:ext uri="{FF2B5EF4-FFF2-40B4-BE49-F238E27FC236}">
-                <a16:creationId xmlns:a16="http://schemas.microsoft.com/office/drawing/2014/main" id="{A92B74F1-1600-4E9F-B77A-6660D9A11F1C}"/>
+                <a16:creationId xmlns:a16="http://schemas.microsoft.com/office/drawing/2014/main" id="{9F2AF352-2290-4BB7-8BBF-5472FC783BCE}"/>
               </a:ext>
             </a:extLst>
           </p:cNvPr>
@@ -40337,7 +40337,7 @@
           <p:cNvPr id="14" name="검증 근거·결과">
             <a:extLst xmlns:a="http://schemas.openxmlformats.org/drawingml/2006/main">
               <a:ext uri="{FF2B5EF4-FFF2-40B4-BE49-F238E27FC236}">
-                <a16:creationId xmlns:a16="http://schemas.microsoft.com/office/drawing/2014/main" id="{C5B5BE35-EB8F-4088-A4AA-B1B1FF98D39E}"/>
+                <a16:creationId xmlns:a16="http://schemas.microsoft.com/office/drawing/2014/main" id="{7CBE66D3-3E96-48CE-81F9-5ACD80419C21}"/>
               </a:ext>
             </a:extLst>
           </p:cNvPr>
@@ -40495,7 +40495,7 @@
           <p:cNvPr id="15" name="집중 3/3 · 전체 11/11 · CLI smoke · diff">
             <a:extLst xmlns:a="http://schemas.openxmlformats.org/drawingml/2006/main">
               <a:ext uri="{FF2B5EF4-FFF2-40B4-BE49-F238E27FC236}">
-                <a16:creationId xmlns:a16="http://schemas.microsoft.com/office/drawing/2014/main" id="{2E4C2C58-C872-470A-AE2A-43679FFCBD5D}"/>
+                <a16:creationId xmlns:a16="http://schemas.microsoft.com/office/drawing/2014/main" id="{290CD0ED-263C-4391-BFA7-3AB5BE81D6A4}"/>
               </a:ext>
             </a:extLst>
           </p:cNvPr>
@@ -40653,7 +40653,7 @@
           <p:cNvPr id="16" name="">
             <a:extLst xmlns:a="http://schemas.openxmlformats.org/drawingml/2006/main">
               <a:ext uri="{FF2B5EF4-FFF2-40B4-BE49-F238E27FC236}">
-                <a16:creationId xmlns:a16="http://schemas.microsoft.com/office/drawing/2014/main" id="{FCA33687-E837-467A-A3C0-D025DA00F4E7}"/>
+                <a16:creationId xmlns:a16="http://schemas.microsoft.com/office/drawing/2014/main" id="{420BC5B7-7686-47B4-B755-8F9070573CDB}"/>
               </a:ext>
             </a:extLst>
           </p:cNvPr>
@@ -40684,7 +40684,7 @@
           <p:cNvPr id="17" name="미확인 사항">
             <a:extLst xmlns:a="http://schemas.openxmlformats.org/drawingml/2006/main">
               <a:ext uri="{FF2B5EF4-FFF2-40B4-BE49-F238E27FC236}">
-                <a16:creationId xmlns:a16="http://schemas.microsoft.com/office/drawing/2014/main" id="{E3F634A8-73FB-49B7-AC3D-967B0D896DF3}"/>
+                <a16:creationId xmlns:a16="http://schemas.microsoft.com/office/drawing/2014/main" id="{917F7774-468A-4D85-8D35-3EB74FB42F05}"/>
               </a:ext>
             </a:extLst>
           </p:cNvPr>
@@ -40842,7 +40842,7 @@
           <p:cNvPr id="18" name="성능 미측정 · 현재 Desktop 동작 미검증">
             <a:extLst xmlns:a="http://schemas.openxmlformats.org/drawingml/2006/main">
               <a:ext uri="{FF2B5EF4-FFF2-40B4-BE49-F238E27FC236}">
-                <a16:creationId xmlns:a16="http://schemas.microsoft.com/office/drawing/2014/main" id="{C2054517-1094-41C8-8AEA-EFE94AAEBB6E}"/>
+                <a16:creationId xmlns:a16="http://schemas.microsoft.com/office/drawing/2014/main" id="{02F1893F-D2C1-45D9-9CF3-EA3B03C27A47}"/>
               </a:ext>
             </a:extLst>
           </p:cNvPr>
@@ -41000,7 +41000,7 @@
           <p:cNvPr id="19" name="">
             <a:extLst xmlns:a="http://schemas.openxmlformats.org/drawingml/2006/main">
               <a:ext uri="{FF2B5EF4-FFF2-40B4-BE49-F238E27FC236}">
-                <a16:creationId xmlns:a16="http://schemas.microsoft.com/office/drawing/2014/main" id="{1B34C028-5020-43D8-B909-2710F903503A}"/>
+                <a16:creationId xmlns:a16="http://schemas.microsoft.com/office/drawing/2014/main" id="{CAB1479A-568A-4EEC-AE87-98A5590A2027}"/>
               </a:ext>
             </a:extLst>
           </p:cNvPr>
@@ -41031,7 +41031,7 @@
           <p:cNvPr id="20" name="사람의 수용 판단">
             <a:extLst xmlns:a="http://schemas.openxmlformats.org/drawingml/2006/main">
               <a:ext uri="{FF2B5EF4-FFF2-40B4-BE49-F238E27FC236}">
-                <a16:creationId xmlns:a16="http://schemas.microsoft.com/office/drawing/2014/main" id="{1E84A160-2F74-47E4-927E-0B9E1778597D}"/>
+                <a16:creationId xmlns:a16="http://schemas.microsoft.com/office/drawing/2014/main" id="{EF1E3C40-44FC-418D-991F-4956E42739E5}"/>
               </a:ext>
             </a:extLst>
           </p:cNvPr>
@@ -41189,7 +41189,7 @@
           <p:cNvPr id="21" name="근거와 남은 위험을 보고 완료 여부 결정">
             <a:extLst xmlns:a="http://schemas.openxmlformats.org/drawingml/2006/main">
               <a:ext uri="{FF2B5EF4-FFF2-40B4-BE49-F238E27FC236}">
-                <a16:creationId xmlns:a16="http://schemas.microsoft.com/office/drawing/2014/main" id="{7A385EC9-FD5C-4FE2-9990-D9F5ECE28488}"/>
+                <a16:creationId xmlns:a16="http://schemas.microsoft.com/office/drawing/2014/main" id="{B06AEB8F-7D09-42E5-A620-94AE0DE40AFD}"/>
               </a:ext>
             </a:extLst>
           </p:cNvPr>
@@ -41347,7 +41347,7 @@
           <p:cNvPr id="22" name="“더 빨라졌다”고 말하려면 → 해당 조건의 성능 측정도 필요">
             <a:extLst xmlns:a="http://schemas.openxmlformats.org/drawingml/2006/main">
               <a:ext uri="{FF2B5EF4-FFF2-40B4-BE49-F238E27FC236}">
-                <a16:creationId xmlns:a16="http://schemas.microsoft.com/office/drawing/2014/main" id="{B02B292C-8357-409C-8BCA-2944619A1D36}"/>
+                <a16:creationId xmlns:a16="http://schemas.microsoft.com/office/drawing/2014/main" id="{0319AC94-A0F9-4F3E-B054-9BE335B1E2E0}"/>
               </a:ext>
             </a:extLst>
           </p:cNvPr>
@@ -41505,7 +41505,7 @@
           <p:cNvPr id="23" name="Legacy module connection">
             <a:extLst xmlns:a="http://schemas.openxmlformats.org/drawingml/2006/main">
               <a:ext uri="{FF2B5EF4-FFF2-40B4-BE49-F238E27FC236}">
-                <a16:creationId xmlns:a16="http://schemas.microsoft.com/office/drawing/2014/main" id="{6905D09E-604F-4AAB-A617-730745F117B7}"/>
+                <a16:creationId xmlns:a16="http://schemas.microsoft.com/office/drawing/2014/main" id="{B7707619-046A-46AA-AD6C-BA78EC211140}"/>
               </a:ext>
             </a:extLst>
           </p:cNvPr>
@@ -41661,7 +41661,7 @@
     </p:spTree>
     <p:extLst>
       <p:ext uri="{BB962C8B-B14F-4D97-AF65-F5344CB8AC3E}">
-        <p14:creationId xmlns:p14="http://schemas.microsoft.com/office/powerpoint/2010/main" val="816253720"/>
+        <p14:creationId xmlns:p14="http://schemas.microsoft.com/office/powerpoint/2010/main" val="632632011"/>
       </p:ext>
     </p:extLst>
   </p:cSld>

</xml_diff>